<commit_message>
refactor: update presentation slides and narration script with refined content and structure
</commit_message>
<xml_diff>
--- a/Thesis Defence Presentation Final.pptx
+++ b/Thesis Defence Presentation Final.pptx
@@ -239,7 +239,7 @@
           <a:p>
             <a:fld id="{5D16D8C7-7ACE-0E43-ADC6-5E8A68AC397B}" type="datetimeFigureOut">
               <a:rPr lang="en-US" smtClean="0"/>
-              <a:t>8/16/26</a:t>
+              <a:t>8/18/26</a:t>
             </a:fld>
             <a:endParaRPr lang="en-US"/>
           </a:p>
@@ -770,7 +770,7 @@
           <a:p>
             <a:fld id="{5BCAD085-E8A6-8845-BD4E-CB4CCA059FC4}" type="datetimeFigureOut">
               <a:rPr lang="en-US" smtClean="0"/>
-              <a:t>8/16/26</a:t>
+              <a:t>8/18/26</a:t>
             </a:fld>
             <a:endParaRPr lang="en-US"/>
           </a:p>
@@ -938,7 +938,7 @@
           <a:p>
             <a:fld id="{5BCAD085-E8A6-8845-BD4E-CB4CCA059FC4}" type="datetimeFigureOut">
               <a:rPr lang="en-US" smtClean="0"/>
-              <a:t>8/16/26</a:t>
+              <a:t>8/18/26</a:t>
             </a:fld>
             <a:endParaRPr lang="en-US"/>
           </a:p>
@@ -1116,7 +1116,7 @@
           <a:p>
             <a:fld id="{5BCAD085-E8A6-8845-BD4E-CB4CCA059FC4}" type="datetimeFigureOut">
               <a:rPr lang="en-US" smtClean="0"/>
-              <a:t>8/16/26</a:t>
+              <a:t>8/18/26</a:t>
             </a:fld>
             <a:endParaRPr lang="en-US"/>
           </a:p>
@@ -1284,7 +1284,7 @@
           <a:p>
             <a:fld id="{5BCAD085-E8A6-8845-BD4E-CB4CCA059FC4}" type="datetimeFigureOut">
               <a:rPr lang="en-US" smtClean="0"/>
-              <a:t>8/16/26</a:t>
+              <a:t>8/18/26</a:t>
             </a:fld>
             <a:endParaRPr lang="en-US"/>
           </a:p>
@@ -1529,7 +1529,7 @@
           <a:p>
             <a:fld id="{5BCAD085-E8A6-8845-BD4E-CB4CCA059FC4}" type="datetimeFigureOut">
               <a:rPr lang="en-US" smtClean="0"/>
-              <a:t>8/16/26</a:t>
+              <a:t>8/18/26</a:t>
             </a:fld>
             <a:endParaRPr lang="en-US"/>
           </a:p>
@@ -1814,7 +1814,7 @@
           <a:p>
             <a:fld id="{5BCAD085-E8A6-8845-BD4E-CB4CCA059FC4}" type="datetimeFigureOut">
               <a:rPr lang="en-US" smtClean="0"/>
-              <a:t>8/16/26</a:t>
+              <a:t>8/18/26</a:t>
             </a:fld>
             <a:endParaRPr lang="en-US"/>
           </a:p>
@@ -2233,7 +2233,7 @@
           <a:p>
             <a:fld id="{5BCAD085-E8A6-8845-BD4E-CB4CCA059FC4}" type="datetimeFigureOut">
               <a:rPr lang="en-US" smtClean="0"/>
-              <a:t>8/16/26</a:t>
+              <a:t>8/18/26</a:t>
             </a:fld>
             <a:endParaRPr lang="en-US"/>
           </a:p>
@@ -2350,7 +2350,7 @@
           <a:p>
             <a:fld id="{5BCAD085-E8A6-8845-BD4E-CB4CCA059FC4}" type="datetimeFigureOut">
               <a:rPr lang="en-US" smtClean="0"/>
-              <a:t>8/16/26</a:t>
+              <a:t>8/18/26</a:t>
             </a:fld>
             <a:endParaRPr lang="en-US"/>
           </a:p>
@@ -2445,7 +2445,7 @@
           <a:p>
             <a:fld id="{5BCAD085-E8A6-8845-BD4E-CB4CCA059FC4}" type="datetimeFigureOut">
               <a:rPr lang="en-US" smtClean="0"/>
-              <a:t>8/16/26</a:t>
+              <a:t>8/18/26</a:t>
             </a:fld>
             <a:endParaRPr lang="en-US"/>
           </a:p>
@@ -2720,7 +2720,7 @@
           <a:p>
             <a:fld id="{5BCAD085-E8A6-8845-BD4E-CB4CCA059FC4}" type="datetimeFigureOut">
               <a:rPr lang="en-US" smtClean="0"/>
-              <a:t>8/16/26</a:t>
+              <a:t>8/18/26</a:t>
             </a:fld>
             <a:endParaRPr lang="en-US"/>
           </a:p>
@@ -2972,7 +2972,7 @@
           <a:p>
             <a:fld id="{5BCAD085-E8A6-8845-BD4E-CB4CCA059FC4}" type="datetimeFigureOut">
               <a:rPr lang="en-US" smtClean="0"/>
-              <a:t>8/16/26</a:t>
+              <a:t>8/18/26</a:t>
             </a:fld>
             <a:endParaRPr lang="en-US"/>
           </a:p>
@@ -3183,7 +3183,7 @@
           <a:p>
             <a:fld id="{5BCAD085-E8A6-8845-BD4E-CB4CCA059FC4}" type="datetimeFigureOut">
               <a:rPr lang="en-US" smtClean="0"/>
-              <a:t>8/16/26</a:t>
+              <a:t>8/18/26</a:t>
             </a:fld>
             <a:endParaRPr lang="en-US"/>
           </a:p>
@@ -10605,7 +10605,7 @@
         </p:nvSpPr>
         <p:spPr>
           <a:xfrm>
-            <a:off x="718950" y="1759662"/>
+            <a:off x="718950" y="1599022"/>
             <a:ext cx="4919472" cy="2743200"/>
           </a:xfrm>
           <a:prstGeom prst="roundRect">
@@ -10653,7 +10653,7 @@
         </p:nvSpPr>
         <p:spPr>
           <a:xfrm>
-            <a:off x="970404" y="1852094"/>
+            <a:off x="970404" y="1691454"/>
             <a:ext cx="1719072" cy="347472"/>
           </a:xfrm>
           <a:prstGeom prst="roundRect">
@@ -10715,7 +10715,7 @@
         </p:nvSpPr>
         <p:spPr>
           <a:xfrm>
-            <a:off x="956694" y="2343888"/>
+            <a:off x="956694" y="2183248"/>
             <a:ext cx="4352544" cy="2046714"/>
           </a:xfrm>
           <a:prstGeom prst="rect">
@@ -10811,7 +10811,7 @@
         </p:nvSpPr>
         <p:spPr>
           <a:xfrm>
-            <a:off x="5839590" y="1759662"/>
+            <a:off x="5839590" y="1599022"/>
             <a:ext cx="5468112" cy="2743200"/>
           </a:xfrm>
           <a:prstGeom prst="roundRect">
@@ -10859,7 +10859,7 @@
         </p:nvSpPr>
         <p:spPr>
           <a:xfrm>
-            <a:off x="6059045" y="1852094"/>
+            <a:off x="6059045" y="1691454"/>
             <a:ext cx="2755769" cy="347472"/>
           </a:xfrm>
           <a:prstGeom prst="roundRect">
@@ -10918,7 +10918,7 @@
         </p:nvSpPr>
         <p:spPr>
           <a:xfrm>
-            <a:off x="6095622" y="2343888"/>
+            <a:off x="6095622" y="2183248"/>
             <a:ext cx="4846320" cy="2046714"/>
           </a:xfrm>
           <a:prstGeom prst="rect">
@@ -11083,7 +11083,7 @@
         </p:nvSpPr>
         <p:spPr>
           <a:xfrm>
-            <a:off x="824248" y="4895800"/>
+            <a:off x="824248" y="4735160"/>
             <a:ext cx="2559032" cy="1479296"/>
           </a:xfrm>
           <a:prstGeom prst="roundRect">
@@ -11137,7 +11137,7 @@
         </p:nvSpPr>
         <p:spPr>
           <a:xfrm>
-            <a:off x="824248" y="4895800"/>
+            <a:off x="824248" y="4735160"/>
             <a:ext cx="2559032" cy="93924"/>
           </a:xfrm>
           <a:prstGeom prst="rect">
@@ -11189,7 +11189,7 @@
         </p:nvSpPr>
         <p:spPr>
           <a:xfrm>
-            <a:off x="970404" y="5023815"/>
+            <a:off x="970404" y="4863175"/>
             <a:ext cx="2266571" cy="338554"/>
           </a:xfrm>
           <a:prstGeom prst="rect">
@@ -11234,7 +11234,7 @@
         </p:nvSpPr>
         <p:spPr>
           <a:xfrm>
-            <a:off x="970404" y="5389576"/>
+            <a:off x="970404" y="5228936"/>
             <a:ext cx="2266571" cy="646331"/>
           </a:xfrm>
           <a:prstGeom prst="rect">
@@ -11279,7 +11279,7 @@
         </p:nvSpPr>
         <p:spPr>
           <a:xfrm>
-            <a:off x="3613168" y="4895800"/>
+            <a:off x="3613168" y="4735160"/>
             <a:ext cx="2559032" cy="1479296"/>
           </a:xfrm>
           <a:prstGeom prst="roundRect">
@@ -11333,7 +11333,7 @@
         </p:nvSpPr>
         <p:spPr>
           <a:xfrm>
-            <a:off x="3613168" y="4895800"/>
+            <a:off x="3613168" y="4735160"/>
             <a:ext cx="2559032" cy="93924"/>
           </a:xfrm>
           <a:prstGeom prst="rect">
@@ -11385,7 +11385,7 @@
         </p:nvSpPr>
         <p:spPr>
           <a:xfrm>
-            <a:off x="3759324" y="5023815"/>
+            <a:off x="3759324" y="4863175"/>
             <a:ext cx="2266571" cy="338554"/>
           </a:xfrm>
           <a:prstGeom prst="rect">
@@ -11439,7 +11439,7 @@
         </p:nvSpPr>
         <p:spPr>
           <a:xfrm>
-            <a:off x="3759324" y="5389576"/>
+            <a:off x="3759324" y="5228936"/>
             <a:ext cx="2266571" cy="646331"/>
           </a:xfrm>
           <a:prstGeom prst="rect">
@@ -11487,7 +11487,7 @@
         </p:nvSpPr>
         <p:spPr>
           <a:xfrm>
-            <a:off x="6402088" y="4895799"/>
+            <a:off x="6402088" y="4735159"/>
             <a:ext cx="2559032" cy="1521017"/>
           </a:xfrm>
           <a:prstGeom prst="roundRect">
@@ -11541,7 +11541,7 @@
         </p:nvSpPr>
         <p:spPr>
           <a:xfrm>
-            <a:off x="6402088" y="4895800"/>
+            <a:off x="6402088" y="4735160"/>
             <a:ext cx="2559032" cy="93924"/>
           </a:xfrm>
           <a:prstGeom prst="rect">
@@ -11593,7 +11593,7 @@
         </p:nvSpPr>
         <p:spPr>
           <a:xfrm>
-            <a:off x="6548244" y="5023815"/>
+            <a:off x="6548244" y="4863175"/>
             <a:ext cx="2266571" cy="338554"/>
           </a:xfrm>
           <a:prstGeom prst="rect">
@@ -11638,7 +11638,7 @@
         </p:nvSpPr>
         <p:spPr>
           <a:xfrm>
-            <a:off x="6483211" y="5362370"/>
+            <a:off x="6483211" y="5201730"/>
             <a:ext cx="2412802" cy="646331"/>
           </a:xfrm>
           <a:prstGeom prst="rect">
@@ -11686,7 +11686,7 @@
         </p:nvSpPr>
         <p:spPr>
           <a:xfrm>
-            <a:off x="9190778" y="4895799"/>
+            <a:off x="9190778" y="4735159"/>
             <a:ext cx="2102062" cy="1521017"/>
           </a:xfrm>
           <a:prstGeom prst="roundRect">
@@ -11740,7 +11740,7 @@
         </p:nvSpPr>
         <p:spPr>
           <a:xfrm>
-            <a:off x="9190778" y="4895800"/>
+            <a:off x="9190778" y="4735160"/>
             <a:ext cx="2102062" cy="93924"/>
           </a:xfrm>
           <a:prstGeom prst="rect">
@@ -11792,7 +11792,7 @@
         </p:nvSpPr>
         <p:spPr>
           <a:xfrm>
-            <a:off x="9336934" y="5023815"/>
+            <a:off x="9336934" y="4863175"/>
             <a:ext cx="1809601" cy="338554"/>
           </a:xfrm>
           <a:prstGeom prst="rect">
@@ -11837,7 +11837,7 @@
         </p:nvSpPr>
         <p:spPr>
           <a:xfrm>
-            <a:off x="9336934" y="5340148"/>
+            <a:off x="9336934" y="5179508"/>
             <a:ext cx="1955906" cy="1015663"/>
           </a:xfrm>
           <a:prstGeom prst="rect">
@@ -16765,7 +16765,7 @@
         </p:nvSpPr>
         <p:spPr>
           <a:xfrm>
-            <a:off x="731520" y="396667"/>
+            <a:off x="558522" y="359596"/>
             <a:ext cx="10698480" cy="677108"/>
           </a:xfrm>
           <a:prstGeom prst="rect">
@@ -16861,7 +16861,7 @@
         <p:spPr>
           <a:xfrm>
             <a:off x="594360" y="1787485"/>
-            <a:ext cx="5760720" cy="4921660"/>
+            <a:ext cx="5760720" cy="4761596"/>
           </a:xfrm>
           <a:prstGeom prst="roundRect">
             <a:avLst/>
@@ -16955,7 +16955,7 @@
         <p:spPr>
           <a:xfrm>
             <a:off x="868680" y="2071145"/>
-            <a:ext cx="5486400" cy="4452501"/>
+            <a:ext cx="5486400" cy="3931846"/>
           </a:xfrm>
           <a:prstGeom prst="rect">
             <a:avLst/>
@@ -16982,7 +16982,19 @@
               <a:rPr dirty="0">
                 <a:latin typeface="Avenir Next" panose="020B0503020202020204" pitchFamily="34" charset="0"/>
               </a:rPr>
-              <a:t>The Green Façade (What Companies Show)</a:t>
+              <a:t>The Green Fa</a:t>
+            </a:r>
+            <a:r>
+              <a:rPr lang="en-US" dirty="0">
+                <a:latin typeface="Avenir Next" panose="020B0503020202020204" pitchFamily="34" charset="0"/>
+              </a:rPr>
+              <a:t>c</a:t>
+            </a:r>
+            <a:r>
+              <a:rPr dirty="0">
+                <a:latin typeface="Avenir Next" panose="020B0503020202020204" pitchFamily="34" charset="0"/>
+              </a:rPr>
+              <a:t>ade (What Companies Show)</a:t>
             </a:r>
           </a:p>
           <a:p>
@@ -17204,7 +17216,19 @@
               <a:rPr dirty="0">
                 <a:latin typeface="Avenir Next" panose="020B0503020202020204" pitchFamily="34" charset="0"/>
               </a:rPr>
-              <a:t>The Hidden Reality (What Stays Concealed)</a:t>
+              <a:t>The Hidden Reality (What Stays </a:t>
+            </a:r>
+            <a:r>
+              <a:rPr lang="en-US" dirty="0">
+                <a:latin typeface="Avenir Next" panose="020B0503020202020204" pitchFamily="34" charset="0"/>
+              </a:rPr>
+              <a:t>Hidden</a:t>
+            </a:r>
+            <a:r>
+              <a:rPr dirty="0">
+                <a:latin typeface="Avenir Next" panose="020B0503020202020204" pitchFamily="34" charset="0"/>
+              </a:rPr>
+              <a:t>)</a:t>
             </a:r>
           </a:p>
           <a:p>
@@ -17297,34 +17321,6 @@
                 <a:latin typeface="Avenir Next" panose="020B0503020202020204" pitchFamily="34" charset="0"/>
               </a:rPr>
               <a:t> independent audits, or verifiable data backing up the claims.</a:t>
-            </a:r>
-          </a:p>
-          <a:p>
-            <a:pPr>
-              <a:spcBef>
-                <a:spcPts val="300"/>
-              </a:spcBef>
-              <a:spcAft>
-                <a:spcPts val="400"/>
-              </a:spcAft>
-            </a:pPr>
-            <a:r>
-              <a:rPr sz="1400" b="1" dirty="0">
-                <a:solidFill>
-                  <a:srgbClr val="A8552F"/>
-                </a:solidFill>
-                <a:latin typeface="Avenir Next" panose="020B0503020202020204" pitchFamily="34" charset="0"/>
-              </a:rPr>
-              <a:t>• Disconnected Governance: </a:t>
-            </a:r>
-            <a:r>
-              <a:rPr sz="1400" dirty="0">
-                <a:solidFill>
-                  <a:srgbClr val="2D2D2D"/>
-                </a:solidFill>
-                <a:latin typeface="Avenir Next" panose="020B0503020202020204" pitchFamily="34" charset="0"/>
-              </a:rPr>
-              <a:t>PR and marketing operate independently from boardroom decisions and oversight.</a:t>
             </a:r>
           </a:p>
         </p:txBody>
@@ -17367,7 +17363,7 @@
         </p:nvSpPr>
         <p:spPr>
           <a:xfrm>
-            <a:off x="731520" y="1041256"/>
+            <a:off x="706806" y="1016542"/>
             <a:ext cx="7717021" cy="677108"/>
           </a:xfrm>
           <a:prstGeom prst="rect">
@@ -17395,6 +17391,56 @@
               </a:rPr>
               <a:t>Greenwashing is defined as any misleading, exaggerated, vague, or unsubstantiated environmental claim made by an entity.</a:t>
             </a:r>
+          </a:p>
+        </p:txBody>
+      </p:sp>
+      <p:sp>
+        <p:nvSpPr>
+          <p:cNvPr id="2" name="Rectangle 1">
+            <a:extLst>
+              <a:ext uri="{FF2B5EF4-FFF2-40B4-BE49-F238E27FC236}">
+                <a16:creationId xmlns:a16="http://schemas.microsoft.com/office/drawing/2014/main" id="{3FDCB222-8459-526C-D2D9-E81267351D93}"/>
+              </a:ext>
+            </a:extLst>
+          </p:cNvPr>
+          <p:cNvSpPr/>
+          <p:nvPr/>
+        </p:nvSpPr>
+        <p:spPr>
+          <a:xfrm>
+            <a:off x="0" y="0"/>
+            <a:ext cx="12191695" cy="201168"/>
+          </a:xfrm>
+          <a:prstGeom prst="rect">
+            <a:avLst/>
+          </a:prstGeom>
+          <a:solidFill>
+            <a:srgbClr val="173F35"/>
+          </a:solidFill>
+          <a:ln>
+            <a:noFill/>
+          </a:ln>
+        </p:spPr>
+        <p:style>
+          <a:lnRef idx="1">
+            <a:schemeClr val="accent1"/>
+          </a:lnRef>
+          <a:fillRef idx="3">
+            <a:schemeClr val="accent1"/>
+          </a:fillRef>
+          <a:effectRef idx="2">
+            <a:schemeClr val="accent1"/>
+          </a:effectRef>
+          <a:fontRef idx="minor">
+            <a:schemeClr val="lt1"/>
+          </a:fontRef>
+        </p:style>
+        <p:txBody>
+          <a:bodyPr rtlCol="0" anchor="ctr"/>
+          <a:lstStyle/>
+          <a:p>
+            <a:pPr algn="ctr"/>
+            <a:endParaRPr/>
           </a:p>
         </p:txBody>
       </p:sp>
@@ -19698,7 +19744,7 @@
         <p:spPr>
           <a:xfrm>
             <a:off x="670473" y="1700443"/>
-            <a:ext cx="2057400" cy="3233507"/>
+            <a:ext cx="1911096" cy="3233507"/>
           </a:xfrm>
           <a:prstGeom prst="roundRect">
             <a:avLst/>
@@ -19746,7 +19792,7 @@
         <p:spPr>
           <a:xfrm>
             <a:off x="670473" y="1700443"/>
-            <a:ext cx="2057400" cy="97615"/>
+            <a:ext cx="1911096" cy="97615"/>
           </a:xfrm>
           <a:prstGeom prst="rect">
             <a:avLst/>
@@ -19870,7 +19916,7 @@
         <p:spPr>
           <a:xfrm>
             <a:off x="2810169" y="1700443"/>
-            <a:ext cx="2057400" cy="3233507"/>
+            <a:ext cx="1911096" cy="3233507"/>
           </a:xfrm>
           <a:prstGeom prst="roundRect">
             <a:avLst/>
@@ -19918,7 +19964,7 @@
         <p:spPr>
           <a:xfrm>
             <a:off x="2810169" y="1700443"/>
-            <a:ext cx="2057400" cy="97615"/>
+            <a:ext cx="1911096" cy="97615"/>
           </a:xfrm>
           <a:prstGeom prst="rect">
             <a:avLst/>
@@ -20042,7 +20088,7 @@
         <p:spPr>
           <a:xfrm>
             <a:off x="4949865" y="1700443"/>
-            <a:ext cx="2057400" cy="3233507"/>
+            <a:ext cx="1911096" cy="3233507"/>
           </a:xfrm>
           <a:prstGeom prst="roundRect">
             <a:avLst/>
@@ -20090,7 +20136,7 @@
         <p:spPr>
           <a:xfrm>
             <a:off x="4949865" y="1700443"/>
-            <a:ext cx="2057400" cy="97615"/>
+            <a:ext cx="1911096" cy="97615"/>
           </a:xfrm>
           <a:prstGeom prst="rect">
             <a:avLst/>
@@ -20214,7 +20260,7 @@
         <p:spPr>
           <a:xfrm>
             <a:off x="7089561" y="1700443"/>
-            <a:ext cx="2057400" cy="3233507"/>
+            <a:ext cx="1911096" cy="3233507"/>
           </a:xfrm>
           <a:prstGeom prst="roundRect">
             <a:avLst/>
@@ -20262,7 +20308,7 @@
         <p:spPr>
           <a:xfrm>
             <a:off x="7089561" y="1700443"/>
-            <a:ext cx="2057400" cy="97615"/>
+            <a:ext cx="1911096" cy="97615"/>
           </a:xfrm>
           <a:prstGeom prst="rect">
             <a:avLst/>
@@ -20386,7 +20432,7 @@
         <p:spPr>
           <a:xfrm>
             <a:off x="9229257" y="1700443"/>
-            <a:ext cx="2057400" cy="3233507"/>
+            <a:ext cx="1911096" cy="3233507"/>
           </a:xfrm>
           <a:prstGeom prst="roundRect">
             <a:avLst/>
@@ -20434,7 +20480,7 @@
         <p:spPr>
           <a:xfrm>
             <a:off x="9229257" y="1700443"/>
-            <a:ext cx="2057400" cy="97615"/>
+            <a:ext cx="1911096" cy="97615"/>
           </a:xfrm>
           <a:prstGeom prst="rect">
             <a:avLst/>
@@ -20605,8 +20651,8 @@
         </p:nvSpPr>
         <p:spPr>
           <a:xfrm>
-            <a:off x="620714" y="5984853"/>
-            <a:ext cx="10835640" cy="564232"/>
+            <a:off x="620714" y="5680103"/>
+            <a:ext cx="10835640" cy="584775"/>
           </a:xfrm>
           <a:prstGeom prst="roundRect">
             <a:avLst>
@@ -20661,7 +20707,7 @@
         </p:nvSpPr>
         <p:spPr>
           <a:xfrm>
-            <a:off x="750714" y="6028442"/>
+            <a:off x="750714" y="5744235"/>
             <a:ext cx="10575640" cy="477054"/>
           </a:xfrm>
           <a:prstGeom prst="rect">
@@ -20835,7 +20881,7 @@
         <p:spPr>
           <a:xfrm>
             <a:off x="652690" y="1474623"/>
-            <a:ext cx="3547872" cy="4023360"/>
+            <a:ext cx="3300984" cy="4023360"/>
           </a:xfrm>
           <a:prstGeom prst="roundRect">
             <a:avLst/>
@@ -20883,7 +20929,7 @@
         <p:spPr>
           <a:xfrm>
             <a:off x="652690" y="1474623"/>
-            <a:ext cx="3547872" cy="73152"/>
+            <a:ext cx="3255264" cy="73152"/>
           </a:xfrm>
           <a:prstGeom prst="rect">
             <a:avLst/>
@@ -21043,7 +21089,7 @@
         <p:spPr>
           <a:xfrm>
             <a:off x="4246282" y="1474623"/>
-            <a:ext cx="3547872" cy="4023360"/>
+            <a:ext cx="3300984" cy="4023360"/>
           </a:xfrm>
           <a:prstGeom prst="roundRect">
             <a:avLst/>
@@ -21091,7 +21137,7 @@
         <p:spPr>
           <a:xfrm>
             <a:off x="4246282" y="1474623"/>
-            <a:ext cx="3547872" cy="73152"/>
+            <a:ext cx="3255264" cy="73152"/>
           </a:xfrm>
           <a:prstGeom prst="rect">
             <a:avLst/>
@@ -21251,7 +21297,7 @@
         <p:spPr>
           <a:xfrm>
             <a:off x="7839874" y="1474623"/>
-            <a:ext cx="3547872" cy="4023360"/>
+            <a:ext cx="3300984" cy="4023360"/>
           </a:xfrm>
           <a:prstGeom prst="roundRect">
             <a:avLst/>
@@ -21299,7 +21345,7 @@
         <p:spPr>
           <a:xfrm>
             <a:off x="7839874" y="1474623"/>
-            <a:ext cx="3547872" cy="73152"/>
+            <a:ext cx="3255264" cy="73152"/>
           </a:xfrm>
           <a:prstGeom prst="rect">
             <a:avLst/>
@@ -22081,7 +22127,7 @@
         </p:nvSpPr>
         <p:spPr>
           <a:xfrm>
-            <a:off x="731520" y="370909"/>
+            <a:off x="484384" y="418457"/>
             <a:ext cx="10698480" cy="677108"/>
           </a:xfrm>
           <a:prstGeom prst="rect">
@@ -22128,7 +22174,7 @@
         </p:nvSpPr>
         <p:spPr>
           <a:xfrm>
-            <a:off x="731520" y="1067013"/>
+            <a:off x="731520" y="1314149"/>
             <a:ext cx="10698480" cy="430887"/>
           </a:xfrm>
           <a:prstGeom prst="rect">
@@ -22153,7 +22199,43 @@
               <a:rPr sz="1600" dirty="0">
                 <a:latin typeface="Avenir Next" panose="020B0503020202020204" pitchFamily="34" charset="0"/>
               </a:rPr>
-              <a:t>Greenwashing is not just a distant corporate issue—it directly affects our wallets, our choices, and our future.</a:t>
+              <a:t>Greenwashing is not</a:t>
+            </a:r>
+            <a:r>
+              <a:rPr lang="en-US" sz="1600" dirty="0">
+                <a:latin typeface="Avenir Next" panose="020B0503020202020204" pitchFamily="34" charset="0"/>
+              </a:rPr>
+              <a:t> </a:t>
+            </a:r>
+            <a:r>
+              <a:rPr sz="1600" dirty="0">
+                <a:latin typeface="Avenir Next" panose="020B0503020202020204" pitchFamily="34" charset="0"/>
+              </a:rPr>
+              <a:t>a distant</a:t>
+            </a:r>
+            <a:r>
+              <a:rPr lang="en-US" sz="1600" dirty="0">
+                <a:latin typeface="Avenir Next" panose="020B0503020202020204" pitchFamily="34" charset="0"/>
+              </a:rPr>
+              <a:t> </a:t>
+            </a:r>
+            <a:r>
+              <a:rPr sz="1600" dirty="0">
+                <a:latin typeface="Avenir Next" panose="020B0503020202020204" pitchFamily="34" charset="0"/>
+              </a:rPr>
+              <a:t>issue</a:t>
+            </a:r>
+            <a:r>
+              <a:rPr lang="en-US" sz="1600" dirty="0">
+                <a:latin typeface="Avenir Next" panose="020B0503020202020204" pitchFamily="34" charset="0"/>
+              </a:rPr>
+              <a:t>, </a:t>
+            </a:r>
+            <a:r>
+              <a:rPr sz="1600" dirty="0">
+                <a:latin typeface="Avenir Next" panose="020B0503020202020204" pitchFamily="34" charset="0"/>
+              </a:rPr>
+              <a:t>it directly affects our wallets, our choices, and our future.</a:t>
             </a:r>
           </a:p>
         </p:txBody>
@@ -22166,7 +22248,7 @@
         </p:nvSpPr>
         <p:spPr>
           <a:xfrm>
-            <a:off x="731520" y="1737360"/>
+            <a:off x="731520" y="2182205"/>
             <a:ext cx="3383280" cy="3474720"/>
           </a:xfrm>
           <a:prstGeom prst="roundRect">
@@ -22214,7 +22296,7 @@
         </p:nvSpPr>
         <p:spPr>
           <a:xfrm>
-            <a:off x="731520" y="1737360"/>
+            <a:off x="731520" y="2182205"/>
             <a:ext cx="3383280" cy="109728"/>
           </a:xfrm>
           <a:prstGeom prst="rect">
@@ -22260,7 +22342,7 @@
         </p:nvSpPr>
         <p:spPr>
           <a:xfrm>
-            <a:off x="868680" y="1920240"/>
+            <a:off x="868680" y="2365085"/>
             <a:ext cx="3108960" cy="2908489"/>
           </a:xfrm>
           <a:prstGeom prst="rect">
@@ -22364,7 +22446,7 @@
         </p:nvSpPr>
         <p:spPr>
           <a:xfrm>
-            <a:off x="4389120" y="1737360"/>
+            <a:off x="4389120" y="2182205"/>
             <a:ext cx="3383280" cy="3474720"/>
           </a:xfrm>
           <a:prstGeom prst="roundRect">
@@ -22412,7 +22494,7 @@
         </p:nvSpPr>
         <p:spPr>
           <a:xfrm>
-            <a:off x="4389120" y="1737360"/>
+            <a:off x="4389120" y="2182205"/>
             <a:ext cx="3383280" cy="109728"/>
           </a:xfrm>
           <a:prstGeom prst="rect">
@@ -22458,7 +22540,7 @@
         </p:nvSpPr>
         <p:spPr>
           <a:xfrm>
-            <a:off x="4526280" y="1920240"/>
+            <a:off x="4526280" y="2365085"/>
             <a:ext cx="3108960" cy="3154710"/>
           </a:xfrm>
           <a:prstGeom prst="rect">
@@ -22562,7 +22644,7 @@
         </p:nvSpPr>
         <p:spPr>
           <a:xfrm>
-            <a:off x="8046720" y="1737360"/>
+            <a:off x="8046720" y="2182205"/>
             <a:ext cx="3383280" cy="3474720"/>
           </a:xfrm>
           <a:prstGeom prst="roundRect">
@@ -22610,7 +22692,7 @@
         </p:nvSpPr>
         <p:spPr>
           <a:xfrm>
-            <a:off x="8046720" y="1737360"/>
+            <a:off x="8046720" y="2182205"/>
             <a:ext cx="3383280" cy="109728"/>
           </a:xfrm>
           <a:prstGeom prst="rect">
@@ -22656,7 +22738,7 @@
         </p:nvSpPr>
         <p:spPr>
           <a:xfrm>
-            <a:off x="8183880" y="1920240"/>
+            <a:off x="8183880" y="2365085"/>
             <a:ext cx="3108960" cy="3154710"/>
           </a:xfrm>
           <a:prstGeom prst="rect">
@@ -22720,7 +22802,19 @@
               <a:rPr sz="1600" dirty="0">
                 <a:latin typeface="Avenir Next" panose="020B0503020202020204" pitchFamily="34" charset="0"/>
               </a:rPr>
-              <a:t>• Corporate slogans like 'Net-Zero by 2050' create a false comfort that someone else is solving the climate crisis.</a:t>
+              <a:t>• </a:t>
+            </a:r>
+            <a:r>
+              <a:rPr lang="en-US" sz="1600" dirty="0">
+                <a:latin typeface="Avenir Next" panose="020B0503020202020204" pitchFamily="34" charset="0"/>
+              </a:rPr>
+              <a:t>Un-substantiated slogans like </a:t>
+            </a:r>
+            <a:r>
+              <a:rPr sz="1600" dirty="0">
+                <a:latin typeface="Avenir Next" panose="020B0503020202020204" pitchFamily="34" charset="0"/>
+              </a:rPr>
+              <a:t>'Net-Zero by 2050' create a false comfort that someone else is solving the climate crisis.</a:t>
             </a:r>
           </a:p>
           <a:p>
@@ -22759,23 +22853,41 @@
               <a:rPr sz="1600" dirty="0">
                 <a:latin typeface="Avenir Next" panose="020B0503020202020204" pitchFamily="34" charset="0"/>
               </a:rPr>
-              <a:t>delays urgent action, while extreme weather and toxic pollution directly threaten our families.</a:t>
-            </a:r>
-          </a:p>
-        </p:txBody>
-      </p:sp>
-      <p:sp>
-        <p:nvSpPr>
-          <p:cNvPr id="15" name="Rounded Rectangle 14"/>
+              <a:t>delays urgent </a:t>
+            </a:r>
+            <a:r>
+              <a:rPr lang="en-US" sz="1600" dirty="0">
+                <a:latin typeface="Avenir Next" panose="020B0503020202020204" pitchFamily="34" charset="0"/>
+              </a:rPr>
+              <a:t>climate </a:t>
+            </a:r>
+            <a:r>
+              <a:rPr sz="1600" dirty="0">
+                <a:latin typeface="Avenir Next" panose="020B0503020202020204" pitchFamily="34" charset="0"/>
+              </a:rPr>
+              <a:t>action, while extreme weather and toxic pollution directly threaten our families.</a:t>
+            </a:r>
+          </a:p>
+        </p:txBody>
+      </p:sp>
+      <p:sp>
+        <p:nvSpPr>
+          <p:cNvPr id="2" name="Rectangle 1">
+            <a:extLst>
+              <a:ext uri="{FF2B5EF4-FFF2-40B4-BE49-F238E27FC236}">
+                <a16:creationId xmlns:a16="http://schemas.microsoft.com/office/drawing/2014/main" id="{66655456-B331-7B6A-DA3E-76E0DEDDAA45}"/>
+              </a:ext>
+            </a:extLst>
+          </p:cNvPr>
           <p:cNvSpPr/>
           <p:nvPr/>
         </p:nvSpPr>
         <p:spPr>
           <a:xfrm>
-            <a:off x="731520" y="5394960"/>
-            <a:ext cx="10698480" cy="1005840"/>
-          </a:xfrm>
-          <a:prstGeom prst="roundRect">
+            <a:off x="0" y="0"/>
+            <a:ext cx="12191695" cy="201168"/>
+          </a:xfrm>
+          <a:prstGeom prst="rect">
             <a:avLst/>
           </a:prstGeom>
           <a:solidFill>
@@ -22800,76 +22912,11 @@
           </a:fontRef>
         </p:style>
         <p:txBody>
-          <a:bodyPr wrap="square" lIns="274320" tIns="137160" rIns="274320" rtlCol="0" anchor="ctr"/>
-          <a:lstStyle/>
-          <a:p>
-            <a:pPr algn="ctr">
-              <a:spcAft>
-                <a:spcPts val="400"/>
-              </a:spcAft>
-              <a:defRPr sz="1100" b="1">
-                <a:solidFill>
-                  <a:srgbClr val="F5C542"/>
-                </a:solidFill>
-              </a:defRPr>
-            </a:pPr>
-            <a:r>
-              <a:rPr dirty="0">
-                <a:latin typeface="Avenir Next" panose="020B0503020202020204" pitchFamily="34" charset="0"/>
-              </a:rPr>
-              <a:t>THE </a:t>
-            </a:r>
-            <a:r>
-              <a:rPr lang="en-US" dirty="0">
-                <a:latin typeface="Avenir Next" panose="020B0503020202020204" pitchFamily="34" charset="0"/>
-              </a:rPr>
-              <a:t>PROBLEM</a:t>
-            </a:r>
-            <a:r>
-              <a:rPr dirty="0">
-                <a:latin typeface="Avenir Next" panose="020B0503020202020204" pitchFamily="34" charset="0"/>
-              </a:rPr>
-              <a:t> </a:t>
-            </a:r>
-            <a:r>
-              <a:rPr lang="en-US" dirty="0">
-                <a:latin typeface="Avenir Next" panose="020B0503020202020204" pitchFamily="34" charset="0"/>
-              </a:rPr>
-              <a:t>IN FRONT OF</a:t>
-            </a:r>
-            <a:r>
-              <a:rPr dirty="0">
-                <a:latin typeface="Avenir Next" panose="020B0503020202020204" pitchFamily="34" charset="0"/>
-              </a:rPr>
-              <a:t> US:</a:t>
-            </a:r>
-          </a:p>
-          <a:p>
-            <a:pPr algn="ctr">
-              <a:defRPr sz="1500" b="1" i="1">
-                <a:solidFill>
-                  <a:srgbClr val="FFFFFF"/>
-                </a:solidFill>
-              </a:defRPr>
-            </a:pPr>
-            <a:r>
-              <a:rPr dirty="0">
-                <a:latin typeface="Avenir Next" panose="020B0503020202020204" pitchFamily="34" charset="0"/>
-              </a:rPr>
-              <a:t>“When every label claims to be 'green', how do </a:t>
-            </a:r>
-            <a:r>
-              <a:rPr lang="en-US" dirty="0">
-                <a:latin typeface="Avenir Next" panose="020B0503020202020204" pitchFamily="34" charset="0"/>
-              </a:rPr>
-              <a:t>we</a:t>
-            </a:r>
-            <a:r>
-              <a:rPr dirty="0">
-                <a:latin typeface="Avenir Next" panose="020B0503020202020204" pitchFamily="34" charset="0"/>
-              </a:rPr>
-              <a:t> protect our wallet, our trust and our family's future?”</a:t>
-            </a:r>
+          <a:bodyPr rtlCol="0" anchor="ctr"/>
+          <a:lstStyle/>
+          <a:p>
+            <a:pPr algn="ctr"/>
+            <a:endParaRPr/>
           </a:p>
         </p:txBody>
       </p:sp>
@@ -22991,7 +23038,7 @@
                 </a:solidFill>
                 <a:latin typeface="Avenir Next Demi Bold"/>
               </a:rPr>
-              <a:t>: As </a:t>
+              <a:t> </a:t>
             </a:r>
             <a:r>
               <a:rPr sz="3200" b="1" dirty="0">
@@ -23000,7 +23047,7 @@
                 </a:solidFill>
                 <a:latin typeface="Avenir Next Demi Bold"/>
               </a:rPr>
-              <a:t>Visible in India</a:t>
+              <a:t>in India</a:t>
             </a:r>
           </a:p>
         </p:txBody>
@@ -23014,7 +23061,7 @@
         <p:spPr>
           <a:xfrm>
             <a:off x="783524" y="1614768"/>
-            <a:ext cx="3166684" cy="2968856"/>
+            <a:ext cx="3009045" cy="2574173"/>
           </a:xfrm>
           <a:prstGeom prst="roundRect">
             <a:avLst/>
@@ -23061,8 +23108,8 @@
         </p:nvSpPr>
         <p:spPr>
           <a:xfrm>
-            <a:off x="948116" y="1721529"/>
-            <a:ext cx="2207454" cy="553533"/>
+            <a:off x="713336" y="1560889"/>
+            <a:ext cx="2782636" cy="553533"/>
           </a:xfrm>
           <a:prstGeom prst="roundRect">
             <a:avLst/>
@@ -23165,8 +23212,8 @@
         </p:nvSpPr>
         <p:spPr>
           <a:xfrm>
-            <a:off x="987552" y="2752875"/>
-            <a:ext cx="2670048" cy="1384995"/>
+            <a:off x="783524" y="2693225"/>
+            <a:ext cx="2712448" cy="1292662"/>
           </a:xfrm>
           <a:prstGeom prst="rect">
             <a:avLst/>
@@ -23179,7 +23226,9 @@
           </a:bodyPr>
           <a:lstStyle/>
           <a:p>
-            <a:pPr>
+            <a:pPr marL="285750" indent="-285750" algn="just">
+              <a:buFont typeface="Arial" panose="020B0604020202020204" pitchFamily="34" charset="0"/>
+              <a:buChar char="•"/>
               <a:defRPr sz="1150" b="0">
                 <a:solidFill>
                   <a:srgbClr val="2A2A2A"/>
@@ -23188,31 +23237,49 @@
               </a:defRPr>
             </a:pPr>
             <a:r>
-              <a:rPr sz="1400" dirty="0">
+              <a:rPr sz="1300" b="1" dirty="0">
                 <a:latin typeface="Avenir Next" panose="020B0503020202020204" pitchFamily="34" charset="0"/>
               </a:rPr>
               <a:t>ASCI reviewed 211 environmental ads in </a:t>
             </a:r>
             <a:r>
-              <a:rPr lang="en-US" sz="1400" dirty="0">
-                <a:latin typeface="Avenir Next" panose="020B0503020202020204" pitchFamily="34" charset="0"/>
-              </a:rPr>
-              <a:t>its 2024-25 Annual Report </a:t>
-            </a:r>
-            <a:r>
-              <a:rPr sz="1400" dirty="0">
-                <a:latin typeface="Avenir Next" panose="020B0503020202020204" pitchFamily="34" charset="0"/>
-              </a:rPr>
-              <a:t>and every one </a:t>
-            </a:r>
-            <a:r>
-              <a:rPr lang="en-US" sz="1400" dirty="0">
+              <a:rPr lang="en-US" sz="1300" b="1" dirty="0">
+                <a:latin typeface="Avenir Next" panose="020B0503020202020204" pitchFamily="34" charset="0"/>
+              </a:rPr>
+              <a:t>its 2024-25 Annual Report.</a:t>
+            </a:r>
+          </a:p>
+          <a:p>
+            <a:pPr marL="285750" indent="-285750" algn="just">
+              <a:buFont typeface="Arial" panose="020B0604020202020204" pitchFamily="34" charset="0"/>
+              <a:buChar char="•"/>
+              <a:defRPr sz="1150" b="0">
+                <a:solidFill>
+                  <a:srgbClr val="2A2A2A"/>
+                </a:solidFill>
+                <a:latin typeface="Avenir Next"/>
+              </a:defRPr>
+            </a:pPr>
+            <a:r>
+              <a:rPr lang="en-US" sz="1300" b="1" dirty="0">
+                <a:latin typeface="Avenir Next" panose="020B0503020202020204" pitchFamily="34" charset="0"/>
+              </a:rPr>
+              <a:t>A</a:t>
+            </a:r>
+            <a:r>
+              <a:rPr sz="1300" b="1" dirty="0">
+                <a:latin typeface="Avenir Next" panose="020B0503020202020204" pitchFamily="34" charset="0"/>
+              </a:rPr>
+              <a:t>nd every one </a:t>
+            </a:r>
+            <a:r>
+              <a:rPr lang="en-US" sz="1300" b="1" dirty="0">
                 <a:latin typeface="Avenir Next" panose="020B0503020202020204" pitchFamily="34" charset="0"/>
               </a:rPr>
               <a:t>of them </a:t>
             </a:r>
             <a:r>
-              <a:rPr sz="1400" dirty="0">
+              <a:rPr sz="1300" b="1" dirty="0">
                 <a:latin typeface="Avenir Next" panose="020B0503020202020204" pitchFamily="34" charset="0"/>
               </a:rPr>
               <a:t>required modification for lack of substantiation.</a:t>
@@ -23276,7 +23343,7 @@
         </p:nvSpPr>
         <p:spPr>
           <a:xfrm>
-            <a:off x="4315968" y="1721528"/>
+            <a:off x="4068831" y="1548531"/>
             <a:ext cx="2542032" cy="553189"/>
           </a:xfrm>
           <a:prstGeom prst="roundRect">
@@ -23352,8 +23419,8 @@
         </p:nvSpPr>
         <p:spPr>
           <a:xfrm>
-            <a:off x="4226470" y="2299101"/>
-            <a:ext cx="2722970" cy="738664"/>
+            <a:off x="4169811" y="2221724"/>
+            <a:ext cx="2945376" cy="2492990"/>
           </a:xfrm>
           <a:prstGeom prst="rect">
             <a:avLst/>
@@ -23366,7 +23433,7 @@
           </a:bodyPr>
           <a:lstStyle/>
           <a:p>
-            <a:pPr marL="285750" indent="-285750" algn="l">
+            <a:pPr marL="285750" indent="-285750" algn="just">
               <a:buFont typeface="Arial" panose="020B0604020202020204" pitchFamily="34" charset="0"/>
               <a:buChar char="•"/>
               <a:defRPr sz="1150" b="1">
@@ -23377,40 +23444,30 @@
               </a:defRPr>
             </a:pPr>
             <a:r>
-              <a:rPr sz="1400" dirty="0">
+              <a:rPr sz="1300" dirty="0">
                 <a:latin typeface="Avenir Next" panose="020B0503020202020204" pitchFamily="34" charset="0"/>
               </a:rPr>
               <a:t>54% of NSE-listed firms in one study engaged in greenwashing.</a:t>
             </a:r>
-            <a:endParaRPr lang="en-US" sz="1400" dirty="0">
+            <a:endParaRPr lang="en-US" sz="1300" dirty="0">
               <a:latin typeface="Avenir Next" panose="020B0503020202020204" pitchFamily="34" charset="0"/>
             </a:endParaRPr>
           </a:p>
-        </p:txBody>
-      </p:sp>
-      <p:sp>
-        <p:nvSpPr>
-          <p:cNvPr id="16" name="TextBox 15"/>
-          <p:cNvSpPr txBox="1"/>
-          <p:nvPr/>
-        </p:nvSpPr>
-        <p:spPr>
-          <a:xfrm>
-            <a:off x="4226470" y="3008074"/>
-            <a:ext cx="2722970" cy="738664"/>
-          </a:xfrm>
-          <a:prstGeom prst="rect">
-            <a:avLst/>
-          </a:prstGeom>
-          <a:noFill/>
-        </p:spPr>
-        <p:txBody>
-          <a:bodyPr wrap="square" lIns="91440" tIns="45720" rIns="91440" bIns="45720" anchor="t">
-            <a:spAutoFit/>
-          </a:bodyPr>
-          <a:lstStyle/>
-          <a:p>
-            <a:pPr marL="342900" indent="-342900">
+          <a:p>
+            <a:pPr algn="just">
+              <a:defRPr sz="1150" b="1">
+                <a:solidFill>
+                  <a:srgbClr val="2A2A2A"/>
+                </a:solidFill>
+                <a:latin typeface="Avenir Next"/>
+              </a:defRPr>
+            </a:pPr>
+            <a:endParaRPr lang="en-US" sz="1050" dirty="0">
+              <a:latin typeface="Avenir Next" panose="020B0503020202020204" pitchFamily="34" charset="0"/>
+            </a:endParaRPr>
+          </a:p>
+          <a:p>
+            <a:pPr marL="285750" indent="-285750" algn="just">
               <a:buFont typeface="Arial" panose="020B0604020202020204" pitchFamily="34" charset="0"/>
               <a:buChar char="•"/>
               <a:defRPr sz="1150" b="1">
@@ -23421,55 +23478,30 @@
               </a:defRPr>
             </a:pPr>
             <a:r>
-              <a:rPr sz="1400" dirty="0">
-                <a:latin typeface="Avenir Next" panose="020B0503020202020204" pitchFamily="34" charset="0"/>
-              </a:rPr>
-              <a:t>47% of NIFTY 50 companies were flagged in </a:t>
-            </a:r>
-            <a:r>
-              <a:rPr lang="en-US" sz="1400" dirty="0">
-                <a:latin typeface="Avenir Next" panose="020B0503020202020204" pitchFamily="34" charset="0"/>
-              </a:rPr>
-              <a:t>another research</a:t>
-            </a:r>
-            <a:r>
-              <a:rPr sz="1400" dirty="0">
-                <a:latin typeface="Avenir Next" panose="020B0503020202020204" pitchFamily="34" charset="0"/>
-              </a:rPr>
-              <a:t>.</a:t>
-            </a:r>
-            <a:endParaRPr lang="en-US" sz="1400" dirty="0">
+              <a:rPr lang="en-IN" sz="1300" dirty="0">
+                <a:latin typeface="Avenir Next" panose="020B0503020202020204" pitchFamily="34" charset="0"/>
+              </a:rPr>
+              <a:t>47% of NIFTY 50 companies were flagged in another research.</a:t>
+            </a:r>
+          </a:p>
+          <a:p>
+            <a:pPr algn="just">
+              <a:defRPr sz="1150" b="1">
+                <a:solidFill>
+                  <a:srgbClr val="2A2A2A"/>
+                </a:solidFill>
+                <a:latin typeface="Avenir Next"/>
+              </a:defRPr>
+            </a:pPr>
+            <a:endParaRPr lang="en-IN" sz="1050" dirty="0">
               <a:latin typeface="Avenir Next" panose="020B0503020202020204" pitchFamily="34" charset="0"/>
             </a:endParaRPr>
           </a:p>
-        </p:txBody>
-      </p:sp>
-      <p:sp>
-        <p:nvSpPr>
-          <p:cNvPr id="17" name="TextBox 16"/>
-          <p:cNvSpPr txBox="1"/>
-          <p:nvPr/>
-        </p:nvSpPr>
-        <p:spPr>
-          <a:xfrm>
-            <a:off x="4212151" y="3692983"/>
-            <a:ext cx="2938457" cy="954107"/>
-          </a:xfrm>
-          <a:prstGeom prst="rect">
-            <a:avLst/>
-          </a:prstGeom>
-          <a:noFill/>
-        </p:spPr>
-        <p:txBody>
-          <a:bodyPr wrap="square" anchor="t">
-            <a:spAutoFit/>
-          </a:bodyPr>
-          <a:lstStyle/>
-          <a:p>
-            <a:pPr marL="285750" indent="-285750" algn="l">
+          <a:p>
+            <a:pPr marL="285750" indent="-285750" algn="just">
               <a:buFont typeface="Arial" panose="020B0604020202020204" pitchFamily="34" charset="0"/>
               <a:buChar char="•"/>
-              <a:defRPr sz="1080" b="0">
+              <a:defRPr sz="1150" b="1">
                 <a:solidFill>
                   <a:srgbClr val="2A2A2A"/>
                 </a:solidFill>
@@ -23477,7 +23509,7 @@
               </a:defRPr>
             </a:pPr>
             <a:r>
-              <a:rPr sz="1400" dirty="0">
+              <a:rPr lang="en-IN" sz="1300" dirty="0">
                 <a:latin typeface="Avenir Next" panose="020B0503020202020204" pitchFamily="34" charset="0"/>
               </a:rPr>
               <a:t>CRISIL also found nearly 80% of 586 companies scored below average or weak on ESG parameters.</a:t>
@@ -23493,8 +23525,8 @@
         </p:nvSpPr>
         <p:spPr>
           <a:xfrm>
-            <a:off x="7443216" y="1614769"/>
-            <a:ext cx="4224528" cy="3352221"/>
+            <a:off x="7588036" y="1614769"/>
+            <a:ext cx="4079708" cy="3352221"/>
           </a:xfrm>
           <a:prstGeom prst="roundRect">
             <a:avLst/>
@@ -23541,7 +23573,7 @@
         </p:nvSpPr>
         <p:spPr>
           <a:xfrm>
-            <a:off x="7644382" y="1721529"/>
+            <a:off x="7496101" y="1560889"/>
             <a:ext cx="1792223" cy="426572"/>
           </a:xfrm>
           <a:prstGeom prst="roundRect">
@@ -23600,7 +23632,7 @@
         </p:nvSpPr>
         <p:spPr>
           <a:xfrm>
-            <a:off x="7699248" y="2289590"/>
+            <a:off x="7588036" y="2166020"/>
             <a:ext cx="1591056" cy="400110"/>
           </a:xfrm>
           <a:prstGeom prst="rect">
@@ -23626,19 +23658,7 @@
               <a:rPr sz="2000" dirty="0">
                 <a:latin typeface="Avenir Next" panose="020B0503020202020204" pitchFamily="34" charset="0"/>
               </a:rPr>
-              <a:t>USD 1.2</a:t>
-            </a:r>
-            <a:r>
-              <a:rPr lang="en-US" sz="2000" dirty="0">
-                <a:latin typeface="Avenir Next" panose="020B0503020202020204" pitchFamily="34" charset="0"/>
-              </a:rPr>
-              <a:t> </a:t>
-            </a:r>
-            <a:r>
-              <a:rPr sz="2000" dirty="0">
-                <a:latin typeface="Avenir Next" panose="020B0503020202020204" pitchFamily="34" charset="0"/>
-              </a:rPr>
-              <a:t>B</a:t>
+              <a:t>USD 1.2B</a:t>
             </a:r>
             <a:endParaRPr lang="en-US" sz="2000" dirty="0">
               <a:latin typeface="Avenir Next" panose="020B0503020202020204" pitchFamily="34" charset="0"/>
@@ -23654,7 +23674,7 @@
         </p:nvSpPr>
         <p:spPr>
           <a:xfrm>
-            <a:off x="7719478" y="2634238"/>
+            <a:off x="7719478" y="2510668"/>
             <a:ext cx="1591056" cy="830997"/>
           </a:xfrm>
           <a:prstGeom prst="rect">
@@ -23668,7 +23688,7 @@
           </a:bodyPr>
           <a:lstStyle/>
           <a:p>
-            <a:pPr algn="ctr">
+            <a:pPr algn="just">
               <a:defRPr sz="1050" b="0">
                 <a:solidFill>
                   <a:srgbClr val="2A2A2A"/>
@@ -23693,7 +23713,7 @@
         </p:nvSpPr>
         <p:spPr>
           <a:xfrm>
-            <a:off x="9400032" y="2289590"/>
+            <a:off x="9400032" y="2166020"/>
             <a:ext cx="1792224" cy="400110"/>
           </a:xfrm>
           <a:prstGeom prst="rect">
@@ -23719,19 +23739,7 @@
               <a:rPr sz="2000" dirty="0">
                 <a:latin typeface="Avenir Next" panose="020B0503020202020204" pitchFamily="34" charset="0"/>
               </a:rPr>
-              <a:t>USD 55.9</a:t>
-            </a:r>
-            <a:r>
-              <a:rPr lang="en-US" sz="2000" dirty="0">
-                <a:latin typeface="Avenir Next" panose="020B0503020202020204" pitchFamily="34" charset="0"/>
-              </a:rPr>
-              <a:t> </a:t>
-            </a:r>
-            <a:r>
-              <a:rPr sz="2000" dirty="0">
-                <a:latin typeface="Avenir Next" panose="020B0503020202020204" pitchFamily="34" charset="0"/>
-              </a:rPr>
-              <a:t>B</a:t>
+              <a:t>USD 55.9B</a:t>
             </a:r>
             <a:endParaRPr lang="en-US" sz="2000" dirty="0">
               <a:latin typeface="Avenir Next" panose="020B0503020202020204" pitchFamily="34" charset="0"/>
@@ -23747,8 +23755,8 @@
         </p:nvSpPr>
         <p:spPr>
           <a:xfrm>
-            <a:off x="9349052" y="2701672"/>
-            <a:ext cx="1901952" cy="830997"/>
+            <a:off x="9586796" y="2528674"/>
+            <a:ext cx="1591056" cy="830997"/>
           </a:xfrm>
           <a:prstGeom prst="rect">
             <a:avLst/>
@@ -23761,7 +23769,7 @@
           </a:bodyPr>
           <a:lstStyle/>
           <a:p>
-            <a:pPr algn="ctr">
+            <a:pPr algn="just">
               <a:defRPr sz="1050" b="0">
                 <a:solidFill>
                   <a:srgbClr val="2A2A2A"/>
@@ -23786,8 +23794,8 @@
         </p:nvSpPr>
         <p:spPr>
           <a:xfrm>
-            <a:off x="7702107" y="3585394"/>
-            <a:ext cx="3657600" cy="1384995"/>
+            <a:off x="7702107" y="3461824"/>
+            <a:ext cx="3657600" cy="1431161"/>
           </a:xfrm>
           <a:prstGeom prst="rect">
             <a:avLst/>
@@ -23800,7 +23808,9 @@
           </a:bodyPr>
           <a:lstStyle/>
           <a:p>
-            <a:pPr algn="ctr">
+            <a:pPr marL="285750" indent="-285750" algn="just">
+              <a:buFont typeface="Arial" panose="020B0604020202020204" pitchFamily="34" charset="0"/>
+              <a:buChar char="•"/>
               <a:defRPr sz="1070" b="1">
                 <a:solidFill>
                   <a:srgbClr val="A23E2A"/>
@@ -23809,17 +23819,29 @@
               </a:defRPr>
             </a:pPr>
             <a:r>
-              <a:rPr sz="1400" dirty="0">
+              <a:rPr sz="1300" dirty="0">
+                <a:solidFill>
+                  <a:schemeClr val="tx1">
+                    <a:lumMod val="95000"/>
+                    <a:lumOff val="5000"/>
+                  </a:schemeClr>
+                </a:solidFill>
                 <a:latin typeface="Avenir Next" panose="020B0503020202020204" pitchFamily="34" charset="0"/>
               </a:rPr>
               <a:t>India is already the fourth-largest emerging-market source of sustainable debt globally, </a:t>
             </a:r>
-            <a:endParaRPr lang="en-US" sz="1400" dirty="0">
+            <a:endParaRPr lang="en-US" sz="1300" dirty="0">
+              <a:solidFill>
+                <a:schemeClr val="tx1">
+                  <a:lumMod val="95000"/>
+                  <a:lumOff val="5000"/>
+                </a:schemeClr>
+              </a:solidFill>
               <a:latin typeface="Avenir Next" panose="020B0503020202020204" pitchFamily="34" charset="0"/>
             </a:endParaRPr>
           </a:p>
           <a:p>
-            <a:pPr algn="ctr">
+            <a:pPr algn="just">
               <a:defRPr sz="1070" b="1">
                 <a:solidFill>
                   <a:srgbClr val="A23E2A"/>
@@ -23827,26 +23849,71 @@
                 <a:latin typeface="Avenir Next"/>
               </a:defRPr>
             </a:pPr>
-            <a:r>
-              <a:rPr lang="en-US" sz="1400" dirty="0">
+            <a:endParaRPr lang="en-US" sz="600" dirty="0">
+              <a:solidFill>
+                <a:schemeClr val="tx1">
+                  <a:lumMod val="95000"/>
+                  <a:lumOff val="5000"/>
+                </a:schemeClr>
+              </a:solidFill>
+              <a:latin typeface="Avenir Next" panose="020B0503020202020204" pitchFamily="34" charset="0"/>
+            </a:endParaRPr>
+          </a:p>
+          <a:p>
+            <a:pPr marL="285750" indent="-285750" algn="just">
+              <a:buFont typeface="Arial" panose="020B0604020202020204" pitchFamily="34" charset="0"/>
+              <a:buChar char="•"/>
+              <a:defRPr sz="1070" b="1">
+                <a:solidFill>
+                  <a:srgbClr val="A23E2A"/>
+                </a:solidFill>
+                <a:latin typeface="Avenir Next"/>
+              </a:defRPr>
+            </a:pPr>
+            <a:r>
+              <a:rPr lang="en-US" sz="1300" dirty="0">
+                <a:solidFill>
+                  <a:schemeClr val="tx1">
+                    <a:lumMod val="95000"/>
+                    <a:lumOff val="5000"/>
+                  </a:schemeClr>
+                </a:solidFill>
                 <a:latin typeface="Avenir Next" panose="020B0503020202020204" pitchFamily="34" charset="0"/>
               </a:rPr>
               <a:t>And</a:t>
             </a:r>
             <a:r>
-              <a:rPr sz="1400" dirty="0">
+              <a:rPr sz="1300" dirty="0">
+                <a:solidFill>
+                  <a:schemeClr val="tx1">
+                    <a:lumMod val="95000"/>
+                    <a:lumOff val="5000"/>
+                  </a:schemeClr>
+                </a:solidFill>
                 <a:latin typeface="Avenir Next" panose="020B0503020202020204" pitchFamily="34" charset="0"/>
               </a:rPr>
               <a:t> RBI research finds ESG </a:t>
             </a:r>
             <a:r>
-              <a:rPr lang="en-US" sz="1400" dirty="0">
+              <a:rPr lang="en-US" sz="1300" dirty="0">
+                <a:solidFill>
+                  <a:schemeClr val="tx1">
+                    <a:lumMod val="95000"/>
+                    <a:lumOff val="5000"/>
+                  </a:schemeClr>
+                </a:solidFill>
                 <a:latin typeface="Avenir Next" panose="020B0503020202020204" pitchFamily="34" charset="0"/>
               </a:rPr>
               <a:t>claim based stocks have returns</a:t>
             </a:r>
             <a:r>
-              <a:rPr sz="1400" dirty="0">
+              <a:rPr sz="1300" dirty="0">
+                <a:solidFill>
+                  <a:schemeClr val="tx1">
+                    <a:lumMod val="95000"/>
+                    <a:lumOff val="5000"/>
+                  </a:schemeClr>
+                </a:solidFill>
                 <a:latin typeface="Avenir Next" panose="020B0503020202020204" pitchFamily="34" charset="0"/>
               </a:rPr>
               <a:t> above market predictions.</a:t>
@@ -23862,8 +23929,8 @@
         </p:nvSpPr>
         <p:spPr>
           <a:xfrm>
-            <a:off x="770037" y="4909764"/>
-            <a:ext cx="4931936" cy="1453652"/>
+            <a:off x="770037" y="4909763"/>
+            <a:ext cx="4931936" cy="1553965"/>
           </a:xfrm>
           <a:prstGeom prst="roundRect">
             <a:avLst/>
@@ -23910,7 +23977,7 @@
         </p:nvSpPr>
         <p:spPr>
           <a:xfrm>
-            <a:off x="948116" y="5038696"/>
+            <a:off x="713336" y="4865699"/>
             <a:ext cx="3459291" cy="487833"/>
           </a:xfrm>
           <a:prstGeom prst="roundRect">
@@ -23959,7 +24026,7 @@
               <a:rPr lang="en-US" sz="1400" dirty="0">
                 <a:latin typeface="Avenir Next" panose="020B0503020202020204" pitchFamily="34" charset="0"/>
               </a:rPr>
-              <a:t>infrastructure lacks proper Verification</a:t>
+              <a:t>infrastructure in India lacks substance</a:t>
             </a:r>
             <a:endParaRPr sz="1400" dirty="0">
               <a:latin typeface="Avenir Next" panose="020B0503020202020204" pitchFamily="34" charset="0"/>
@@ -23975,8 +24042,8 @@
         </p:nvSpPr>
         <p:spPr>
           <a:xfrm>
-            <a:off x="783524" y="5555990"/>
-            <a:ext cx="4918449" cy="830997"/>
+            <a:off x="770037" y="5417225"/>
+            <a:ext cx="4918449" cy="892552"/>
           </a:xfrm>
           <a:prstGeom prst="rect">
             <a:avLst/>
@@ -23989,7 +24056,9 @@
           </a:bodyPr>
           <a:lstStyle/>
           <a:p>
-            <a:pPr algn="ctr">
+            <a:pPr marL="171450" indent="-171450" algn="just">
+              <a:buFont typeface="Arial" panose="020B0604020202020204" pitchFamily="34" charset="0"/>
+              <a:buChar char="•"/>
               <a:defRPr sz="1100" b="0">
                 <a:solidFill>
                   <a:srgbClr val="2A2A2A"/>
@@ -23998,50 +24067,28 @@
               </a:defRPr>
             </a:pPr>
             <a:r>
-              <a:rPr sz="1200" dirty="0">
+              <a:rPr sz="1300" b="1" dirty="0">
                 <a:latin typeface="Avenir Next" panose="020B0503020202020204" pitchFamily="34" charset="0"/>
               </a:rPr>
               <a:t>CPCB uncovered about 600,000 fake EPR certificates in 2024, </a:t>
             </a:r>
             <a:r>
-              <a:rPr lang="en-US" sz="1200" dirty="0">
+              <a:rPr lang="en-US" sz="1300" b="1" dirty="0">
                 <a:latin typeface="Avenir Next" panose="020B0503020202020204" pitchFamily="34" charset="0"/>
               </a:rPr>
               <a:t>and NGT took </a:t>
             </a:r>
             <a:r>
-              <a:rPr lang="en-US" sz="1200" dirty="0" err="1">
+              <a:rPr lang="en-US" sz="1300" b="1" dirty="0" err="1">
                 <a:latin typeface="Avenir Next" panose="020B0503020202020204" pitchFamily="34" charset="0"/>
               </a:rPr>
               <a:t>suo</a:t>
             </a:r>
             <a:r>
-              <a:rPr lang="en-US" sz="1200" dirty="0">
-                <a:latin typeface="Avenir Next" panose="020B0503020202020204" pitchFamily="34" charset="0"/>
-              </a:rPr>
-              <a:t> moto cognizance of it; </a:t>
-            </a:r>
-          </a:p>
-          <a:p>
-            <a:pPr algn="ctr">
-              <a:defRPr sz="1100" b="0">
-                <a:solidFill>
-                  <a:srgbClr val="2A2A2A"/>
-                </a:solidFill>
-                <a:latin typeface="Avenir Next"/>
-              </a:defRPr>
-            </a:pPr>
-            <a:r>
-              <a:rPr lang="en-US" sz="1200" dirty="0">
-                <a:latin typeface="Avenir Next" panose="020B0503020202020204" pitchFamily="34" charset="0"/>
-              </a:rPr>
-              <a:t>showing</a:t>
-            </a:r>
-            <a:r>
-              <a:rPr sz="1200" dirty="0">
-                <a:latin typeface="Avenir Next" panose="020B0503020202020204" pitchFamily="34" charset="0"/>
-              </a:rPr>
-              <a:t> that the verification deficit reaches the infrastructure of environmental compliance itself.</a:t>
+              <a:rPr lang="en-US" sz="1300" b="1" dirty="0">
+                <a:latin typeface="Avenir Next" panose="020B0503020202020204" pitchFamily="34" charset="0"/>
+              </a:rPr>
+              <a:t> moto cognizance of it; showing that the verification deficit reaches the infrastructure of environmental compliance itself.</a:t>
             </a:r>
           </a:p>
         </p:txBody>
@@ -24055,7 +24102,7 @@
         <p:spPr>
           <a:xfrm>
             <a:off x="5925312" y="5390971"/>
-            <a:ext cx="5742432" cy="934460"/>
+            <a:ext cx="5742432" cy="993388"/>
           </a:xfrm>
           <a:prstGeom prst="roundRect">
             <a:avLst/>
@@ -24103,7 +24150,7 @@
         <p:spPr>
           <a:xfrm>
             <a:off x="5987728" y="5464473"/>
-            <a:ext cx="5266944" cy="738664"/>
+            <a:ext cx="5266944" cy="861774"/>
           </a:xfrm>
           <a:prstGeom prst="rect">
             <a:avLst/>
@@ -24125,15 +24172,44 @@
               </a:defRPr>
             </a:pPr>
             <a:r>
-              <a:rPr lang="en-IN" sz="1400" dirty="0">
-                <a:latin typeface="Avenir Next" panose="020B0503020202020204" pitchFamily="34" charset="0"/>
-              </a:rPr>
-              <a:t>Key Takeaway: At this scale, greenwashing is not harmless marketing hype. It distorts both consumer choice and capital allocation.</a:t>
-            </a:r>
-            <a:endParaRPr lang="en-IN" sz="1600" dirty="0">
+              <a:rPr lang="en-US" sz="1400" cap="small" dirty="0">
+                <a:latin typeface="Avenir Next" panose="020B0503020202020204" pitchFamily="34" charset="0"/>
+              </a:rPr>
+              <a:t>Greenwashing distorts the information on which consumers, investors and regulators rely on.</a:t>
+            </a:r>
+          </a:p>
+          <a:p>
+            <a:pPr algn="ctr">
+              <a:defRPr sz="1150" b="1">
+                <a:solidFill>
+                  <a:srgbClr val="12402D"/>
+                </a:solidFill>
+                <a:latin typeface="Avenir Next Demi Bold"/>
+              </a:defRPr>
+            </a:pPr>
+            <a:endParaRPr lang="en-IN" sz="600" cap="small" dirty="0">
               <a:latin typeface="Avenir Next" panose="020B0503020202020204" pitchFamily="34" charset="0"/>
             </a:endParaRPr>
           </a:p>
+          <a:p>
+            <a:pPr algn="ctr">
+              <a:defRPr sz="1150" b="1">
+                <a:solidFill>
+                  <a:srgbClr val="12402D"/>
+                </a:solidFill>
+                <a:latin typeface="Avenir Next Demi Bold"/>
+              </a:defRPr>
+            </a:pPr>
+            <a:r>
+              <a:rPr lang="en-IN" sz="1400" cap="small" dirty="0">
+                <a:latin typeface="Avenir Next" panose="020B0503020202020204" pitchFamily="34" charset="0"/>
+              </a:rPr>
+              <a:t>It affects consumer choice and capital allocation.</a:t>
+            </a:r>
+            <a:endParaRPr lang="en-IN" sz="1600" cap="small" dirty="0">
+              <a:latin typeface="Avenir Next" panose="020B0503020202020204" pitchFamily="34" charset="0"/>
+            </a:endParaRPr>
+          </a:p>
         </p:txBody>
       </p:sp>
       <p:sp>
@@ -24144,8 +24220,8 @@
         </p:nvSpPr>
         <p:spPr>
           <a:xfrm>
-            <a:off x="593901" y="6545178"/>
-            <a:ext cx="6784230" cy="261610"/>
+            <a:off x="643329" y="6557535"/>
+            <a:ext cx="8112927" cy="307777"/>
           </a:xfrm>
           <a:prstGeom prst="rect">
             <a:avLst/>
@@ -24167,23 +24243,80 @@
               </a:defRPr>
             </a:pPr>
             <a:r>
-              <a:rPr sz="1100" dirty="0"/>
+              <a:rPr sz="1400" dirty="0">
+                <a:solidFill>
+                  <a:schemeClr val="tx1">
+                    <a:lumMod val="95000"/>
+                    <a:lumOff val="5000"/>
+                  </a:schemeClr>
+                </a:solidFill>
+              </a:rPr>
               <a:t>Source base: </a:t>
             </a:r>
             <a:r>
-              <a:rPr lang="en-US" sz="1100" dirty="0"/>
+              <a:rPr lang="en-US" sz="1400" dirty="0">
+                <a:solidFill>
+                  <a:schemeClr val="tx1">
+                    <a:lumMod val="95000"/>
+                    <a:lumOff val="5000"/>
+                  </a:schemeClr>
+                </a:solidFill>
+              </a:rPr>
               <a:t>ASCI</a:t>
             </a:r>
             <a:r>
-              <a:rPr sz="1100" dirty="0"/>
-              <a:t>, CRISIL, RBI, CPCB figures</a:t>
-            </a:r>
-            <a:r>
-              <a:rPr lang="en-US" sz="1100" dirty="0"/>
-              <a:t> and NSE/NIFTY peer-reviewed studies, </a:t>
-            </a:r>
-            <a:r>
-              <a:rPr sz="1100" dirty="0"/>
+              <a:rPr sz="1400" dirty="0">
+                <a:solidFill>
+                  <a:schemeClr val="tx1">
+                    <a:lumMod val="95000"/>
+                    <a:lumOff val="5000"/>
+                  </a:schemeClr>
+                </a:solidFill>
+              </a:rPr>
+              <a:t>, RBI,</a:t>
+            </a:r>
+            <a:r>
+              <a:rPr lang="en-US" sz="1400" dirty="0">
+                <a:solidFill>
+                  <a:schemeClr val="tx1">
+                    <a:lumMod val="95000"/>
+                    <a:lumOff val="5000"/>
+                  </a:schemeClr>
+                </a:solidFill>
+              </a:rPr>
+              <a:t> CRISIL,</a:t>
+            </a:r>
+            <a:r>
+              <a:rPr sz="1400" dirty="0">
+                <a:solidFill>
+                  <a:schemeClr val="tx1">
+                    <a:lumMod val="95000"/>
+                    <a:lumOff val="5000"/>
+                  </a:schemeClr>
+                </a:solidFill>
+              </a:rPr>
+              <a:t> CPCB figures</a:t>
+            </a:r>
+            <a:r>
+              <a:rPr lang="en-US" sz="1400" dirty="0">
+                <a:solidFill>
+                  <a:schemeClr val="tx1">
+                    <a:lumMod val="95000"/>
+                    <a:lumOff val="5000"/>
+                  </a:schemeClr>
+                </a:solidFill>
+              </a:rPr>
+              <a:t> and some peer-reviewed studies, </a:t>
+            </a:r>
+            <a:r>
+              <a:rPr sz="1400" dirty="0">
+                <a:solidFill>
+                  <a:schemeClr val="tx1">
+                    <a:lumMod val="95000"/>
+                    <a:lumOff val="5000"/>
+                  </a:schemeClr>
+                </a:solidFill>
+              </a:rPr>
               <a:t>cited in the thesis.</a:t>
             </a:r>
           </a:p>
@@ -24203,8 +24336,8 @@
         </p:nvSpPr>
         <p:spPr>
           <a:xfrm>
-            <a:off x="695718" y="1088910"/>
-            <a:ext cx="4844596" cy="307777"/>
+            <a:off x="695718" y="1039482"/>
+            <a:ext cx="5464894" cy="338554"/>
           </a:xfrm>
           <a:prstGeom prst="rect">
             <a:avLst/>
@@ -24226,7 +24359,10 @@
               </a:defRPr>
             </a:pPr>
             <a:r>
-              <a:rPr lang="en-US" sz="1400" b="1" dirty="0">
+              <a:rPr lang="en-US" sz="1600" b="1" i="1" dirty="0">
+                <a:solidFill>
+                  <a:srgbClr val="12402D"/>
+                </a:solidFill>
                 <a:latin typeface="Avenir Next" panose="020B0503020202020204" pitchFamily="34" charset="0"/>
               </a:rPr>
               <a:t>Based on available data from authority-based sources</a:t>
@@ -24280,7 +24416,7 @@
         </p:nvSpPr>
         <p:spPr>
           <a:xfrm>
-            <a:off x="914400" y="428064"/>
+            <a:off x="620486" y="428064"/>
             <a:ext cx="10058400" cy="584775"/>
           </a:xfrm>
           <a:prstGeom prst="rect">
@@ -24319,55 +24455,14 @@
       </p:sp>
       <p:sp>
         <p:nvSpPr>
-          <p:cNvPr id="4" name="TextBox 3"/>
-          <p:cNvSpPr txBox="1"/>
-          <p:nvPr/>
-        </p:nvSpPr>
-        <p:spPr>
-          <a:xfrm>
-            <a:off x="731520" y="1251794"/>
-            <a:ext cx="10698480" cy="584775"/>
-          </a:xfrm>
-          <a:prstGeom prst="rect">
-            <a:avLst/>
-          </a:prstGeom>
-          <a:noFill/>
-        </p:spPr>
-        <p:txBody>
-          <a:bodyPr wrap="square" lIns="91440" tIns="45720" rIns="91440" bIns="45720" anchor="t">
-            <a:spAutoFit/>
-          </a:bodyPr>
-          <a:lstStyle/>
-          <a:p>
-            <a:pPr>
-              <a:defRPr sz="1200" b="0">
-                <a:solidFill>
-                  <a:srgbClr val="6B6B7B"/>
-                </a:solidFill>
-                <a:latin typeface="Calibri"/>
-              </a:defRPr>
-            </a:pPr>
-            <a:r>
-              <a:rPr sz="1600" b="1" dirty="0"/>
-              <a:t>Existing scholarship treats greenwashing primarily as a marketing issue. This research investigates the structural flaws in legal accountability.</a:t>
-            </a:r>
-            <a:endParaRPr lang="en-US" sz="1600" b="1" dirty="0">
-              <a:ea typeface="Calibri"/>
-              <a:cs typeface="Calibri"/>
-            </a:endParaRPr>
-          </a:p>
-        </p:txBody>
-      </p:sp>
-      <p:sp>
-        <p:nvSpPr>
           <p:cNvPr id="5" name="Rounded Rectangle 4"/>
           <p:cNvSpPr/>
           <p:nvPr/>
         </p:nvSpPr>
         <p:spPr>
           <a:xfrm>
-            <a:off x="746974" y="1850000"/>
-            <a:ext cx="5196625" cy="1080000"/>
+            <a:off x="709903" y="1181657"/>
+            <a:ext cx="10627808" cy="4267792"/>
           </a:xfrm>
           <a:prstGeom prst="roundRect">
             <a:avLst/>
@@ -24408,69 +24503,14 @@
       </p:sp>
       <p:sp>
         <p:nvSpPr>
-          <p:cNvPr id="6" name="Rounded Rectangle 5"/>
-          <p:cNvSpPr/>
-          <p:nvPr/>
-        </p:nvSpPr>
-        <p:spPr>
-          <a:xfrm>
-            <a:off x="824586" y="1970000"/>
-            <a:ext cx="547013" cy="318828"/>
-          </a:xfrm>
-          <a:prstGeom prst="roundRect">
-            <a:avLst/>
-          </a:prstGeom>
-          <a:solidFill>
-            <a:srgbClr val="0E8A74"/>
-          </a:solidFill>
-          <a:ln>
-            <a:noFill/>
-          </a:ln>
-        </p:spPr>
-        <p:style>
-          <a:lnRef idx="1">
-            <a:schemeClr val="accent1"/>
-          </a:lnRef>
-          <a:fillRef idx="3">
-            <a:schemeClr val="accent1"/>
-          </a:fillRef>
-          <a:effectRef idx="2">
-            <a:schemeClr val="accent1"/>
-          </a:effectRef>
-          <a:fontRef idx="minor">
-            <a:schemeClr val="lt1"/>
-          </a:fontRef>
-        </p:style>
-        <p:txBody>
-          <a:bodyPr rtlCol="0" anchor="ctr"/>
-          <a:lstStyle/>
-          <a:p>
-            <a:pPr algn="ctr">
-              <a:defRPr sz="900" b="1">
-                <a:solidFill>
-                  <a:srgbClr val="FFFFFF"/>
-                </a:solidFill>
-              </a:defRPr>
-            </a:pPr>
-            <a:r>
-              <a:rPr sz="1100">
-                <a:latin typeface="Avenir Next" panose="020B0503020202020204" pitchFamily="34" charset="0"/>
-              </a:rPr>
-              <a:t>Gap 1</a:t>
-            </a:r>
-          </a:p>
-        </p:txBody>
-      </p:sp>
-      <p:sp>
-        <p:nvSpPr>
           <p:cNvPr id="7" name="TextBox 6"/>
           <p:cNvSpPr txBox="1"/>
           <p:nvPr/>
         </p:nvSpPr>
         <p:spPr>
           <a:xfrm>
-            <a:off x="1475918" y="1930000"/>
-            <a:ext cx="4330521" cy="956672"/>
+            <a:off x="1004990" y="1408552"/>
+            <a:ext cx="10140803" cy="3960058"/>
           </a:xfrm>
           <a:prstGeom prst="rect">
             <a:avLst/>
@@ -24495,10 +24535,10 @@
               </a:defRPr>
             </a:pPr>
             <a:r>
-              <a:rPr dirty="0">
-                <a:latin typeface="Avenir Next" panose="020B0503020202020204" pitchFamily="34" charset="0"/>
-              </a:rPr>
-              <a:t>Board-Level Accountability</a:t>
+              <a:rPr lang="en-US" sz="1350" dirty="0">
+                <a:latin typeface="Avenir Next" panose="020B0503020202020204" pitchFamily="34" charset="0"/>
+              </a:rPr>
+              <a:t>Lack of an integrated analysis </a:t>
             </a:r>
           </a:p>
           <a:p>
@@ -24506,152 +24546,22 @@
               <a:defRPr sz="1050"/>
             </a:pPr>
             <a:r>
-              <a:rPr sz="1400" dirty="0">
-                <a:latin typeface="Avenir Next" panose="020B0503020202020204" pitchFamily="34" charset="0"/>
-              </a:rPr>
-              <a:t>Limited </a:t>
-            </a:r>
-            <a:r>
-              <a:rPr lang="en-US" sz="1400" dirty="0">
-                <a:latin typeface="Avenir Next" panose="020B0503020202020204" pitchFamily="34" charset="0"/>
-              </a:rPr>
-              <a:t>existing doctrinal </a:t>
-            </a:r>
-            <a:r>
-              <a:rPr sz="1400" dirty="0">
-                <a:latin typeface="Avenir Next" panose="020B0503020202020204" pitchFamily="34" charset="0"/>
-              </a:rPr>
-              <a:t>work on invoking Section 166(2) against misleading sustainability claims in corporate reports and ESG disclosures.</a:t>
-            </a:r>
-          </a:p>
-        </p:txBody>
-      </p:sp>
-      <p:sp>
-        <p:nvSpPr>
-          <p:cNvPr id="8" name="Rounded Rectangle 7"/>
-          <p:cNvSpPr/>
-          <p:nvPr/>
-        </p:nvSpPr>
-        <p:spPr>
-          <a:xfrm>
-            <a:off x="746974" y="3050000"/>
-            <a:ext cx="5196625" cy="1080000"/>
-          </a:xfrm>
-          <a:prstGeom prst="roundRect">
-            <a:avLst/>
-          </a:prstGeom>
-          <a:solidFill>
-            <a:srgbClr val="FFFFFF"/>
-          </a:solidFill>
-          <a:ln w="10160">
-            <a:solidFill>
-              <a:srgbClr val="DEE0E5"/>
-            </a:solidFill>
-          </a:ln>
-        </p:spPr>
-        <p:style>
-          <a:lnRef idx="1">
-            <a:schemeClr val="accent1"/>
-          </a:lnRef>
-          <a:fillRef idx="3">
-            <a:schemeClr val="accent1"/>
-          </a:fillRef>
-          <a:effectRef idx="2">
-            <a:schemeClr val="accent1"/>
-          </a:effectRef>
-          <a:fontRef idx="minor">
-            <a:schemeClr val="lt1"/>
-          </a:fontRef>
-        </p:style>
-        <p:txBody>
-          <a:bodyPr rtlCol="0" anchor="ctr"/>
-          <a:lstStyle/>
-          <a:p>
-            <a:pPr algn="ctr"/>
-            <a:endParaRPr sz="2800">
+              <a:rPr lang="en-IN" sz="1350" dirty="0">
+                <a:latin typeface="Avenir Next" panose="020B0503020202020204" pitchFamily="34" charset="0"/>
+              </a:rPr>
+              <a:t>The research gap is not the complete absence of laws or regulations tackling greenwashing, but the absence of an integrated analysis of how those rules translate into enforceable accountability.</a:t>
+            </a:r>
+          </a:p>
+          <a:p>
+            <a:pPr>
+              <a:defRPr sz="1050"/>
+            </a:pPr>
+            <a:endParaRPr lang="en-IN" sz="1350" dirty="0">
               <a:latin typeface="Avenir Next" panose="020B0503020202020204" pitchFamily="34" charset="0"/>
             </a:endParaRPr>
           </a:p>
-        </p:txBody>
-      </p:sp>
-      <p:sp>
-        <p:nvSpPr>
-          <p:cNvPr id="9" name="Rounded Rectangle 8"/>
-          <p:cNvSpPr/>
-          <p:nvPr/>
-        </p:nvSpPr>
-        <p:spPr>
-          <a:xfrm>
-            <a:off x="824586" y="3170000"/>
-            <a:ext cx="547013" cy="318828"/>
-          </a:xfrm>
-          <a:prstGeom prst="roundRect">
-            <a:avLst/>
-          </a:prstGeom>
-          <a:solidFill>
-            <a:srgbClr val="0E8A74"/>
-          </a:solidFill>
-          <a:ln>
-            <a:noFill/>
-          </a:ln>
-        </p:spPr>
-        <p:style>
-          <a:lnRef idx="1">
-            <a:schemeClr val="accent1"/>
-          </a:lnRef>
-          <a:fillRef idx="3">
-            <a:schemeClr val="accent1"/>
-          </a:fillRef>
-          <a:effectRef idx="2">
-            <a:schemeClr val="accent1"/>
-          </a:effectRef>
-          <a:fontRef idx="minor">
-            <a:schemeClr val="lt1"/>
-          </a:fontRef>
-        </p:style>
-        <p:txBody>
-          <a:bodyPr rtlCol="0" anchor="ctr"/>
-          <a:lstStyle/>
-          <a:p>
-            <a:pPr algn="ctr">
-              <a:defRPr sz="900" b="1">
-                <a:solidFill>
-                  <a:srgbClr val="FFFFFF"/>
-                </a:solidFill>
-              </a:defRPr>
-            </a:pPr>
-            <a:r>
-              <a:rPr sz="1100">
-                <a:latin typeface="Avenir Next" panose="020B0503020202020204" pitchFamily="34" charset="0"/>
-              </a:rPr>
-              <a:t>Gap 2</a:t>
-            </a:r>
-          </a:p>
-        </p:txBody>
-      </p:sp>
-      <p:sp>
-        <p:nvSpPr>
-          <p:cNvPr id="10" name="TextBox 9"/>
-          <p:cNvSpPr txBox="1"/>
-          <p:nvPr/>
-        </p:nvSpPr>
-        <p:spPr>
-          <a:xfrm>
-            <a:off x="1475918" y="3130000"/>
-            <a:ext cx="4330521" cy="956672"/>
-          </a:xfrm>
-          <a:prstGeom prst="rect">
-            <a:avLst/>
-          </a:prstGeom>
-          <a:noFill/>
-        </p:spPr>
-        <p:txBody>
-          <a:bodyPr wrap="square">
-            <a:spAutoFit/>
-          </a:bodyPr>
-          <a:lstStyle/>
-          <a:p>
-            <a:pPr algn="l">
+          <a:p>
+            <a:pPr>
               <a:spcAft>
                 <a:spcPts val="200"/>
               </a:spcAft>
@@ -24663,10 +24573,10 @@
               </a:defRPr>
             </a:pPr>
             <a:r>
-              <a:rPr dirty="0">
-                <a:latin typeface="Avenir Next" panose="020B0503020202020204" pitchFamily="34" charset="0"/>
-              </a:rPr>
-              <a:t>Regulatory Fragmentation</a:t>
+              <a:rPr lang="en-US" sz="1350" dirty="0">
+                <a:latin typeface="Avenir Next" panose="020B0503020202020204" pitchFamily="34" charset="0"/>
+              </a:rPr>
+              <a:t>Limited doctrinal work on board-level accountability for environmental claims</a:t>
             </a:r>
           </a:p>
           <a:p>
@@ -24674,140 +24584,22 @@
               <a:defRPr sz="1050"/>
             </a:pPr>
             <a:r>
-              <a:rPr sz="1400" dirty="0">
-                <a:latin typeface="Avenir Next" panose="020B0503020202020204" pitchFamily="34" charset="0"/>
-              </a:rPr>
-              <a:t>Green claims are policed across siloed regimes (MCA, SEBI, CCPA/ASCI), creating jurisdictional overlap and an accountability vacuum.</a:t>
-            </a:r>
-          </a:p>
-        </p:txBody>
-      </p:sp>
-      <p:sp>
-        <p:nvSpPr>
-          <p:cNvPr id="11" name="Rounded Rectangle 10"/>
-          <p:cNvSpPr/>
-          <p:nvPr/>
-        </p:nvSpPr>
-        <p:spPr>
-          <a:xfrm>
-            <a:off x="746974" y="4250000"/>
-            <a:ext cx="5196625" cy="1080000"/>
-          </a:xfrm>
-          <a:prstGeom prst="roundRect">
-            <a:avLst/>
-          </a:prstGeom>
-          <a:solidFill>
-            <a:srgbClr val="FFFFFF"/>
-          </a:solidFill>
-          <a:ln w="10160">
-            <a:solidFill>
-              <a:srgbClr val="DEE0E5"/>
-            </a:solidFill>
-          </a:ln>
-        </p:spPr>
-        <p:style>
-          <a:lnRef idx="1">
-            <a:schemeClr val="accent1"/>
-          </a:lnRef>
-          <a:fillRef idx="3">
-            <a:schemeClr val="accent1"/>
-          </a:fillRef>
-          <a:effectRef idx="2">
-            <a:schemeClr val="accent1"/>
-          </a:effectRef>
-          <a:fontRef idx="minor">
-            <a:schemeClr val="lt1"/>
-          </a:fontRef>
-        </p:style>
-        <p:txBody>
-          <a:bodyPr rtlCol="0" anchor="ctr"/>
-          <a:lstStyle/>
-          <a:p>
-            <a:pPr algn="ctr"/>
-            <a:endParaRPr sz="2800">
+              <a:rPr lang="en-US" sz="1350" dirty="0">
+                <a:latin typeface="Avenir Next" panose="020B0503020202020204" pitchFamily="34" charset="0"/>
+              </a:rPr>
+              <a:t>Section 166(2) of the Companies Act, 2013 creates a statutory expectation that remains under-studied.</a:t>
+            </a:r>
+          </a:p>
+          <a:p>
+            <a:pPr>
+              <a:defRPr sz="1050"/>
+            </a:pPr>
+            <a:endParaRPr lang="en-US" sz="1350" dirty="0">
               <a:latin typeface="Avenir Next" panose="020B0503020202020204" pitchFamily="34" charset="0"/>
             </a:endParaRPr>
           </a:p>
-        </p:txBody>
-      </p:sp>
-      <p:sp>
-        <p:nvSpPr>
-          <p:cNvPr id="12" name="Rounded Rectangle 11"/>
-          <p:cNvSpPr/>
-          <p:nvPr/>
-        </p:nvSpPr>
-        <p:spPr>
-          <a:xfrm>
-            <a:off x="824586" y="4370000"/>
-            <a:ext cx="547013" cy="318828"/>
-          </a:xfrm>
-          <a:prstGeom prst="roundRect">
-            <a:avLst/>
-          </a:prstGeom>
-          <a:solidFill>
-            <a:srgbClr val="0E8A74"/>
-          </a:solidFill>
-          <a:ln>
-            <a:noFill/>
-          </a:ln>
-        </p:spPr>
-        <p:style>
-          <a:lnRef idx="1">
-            <a:schemeClr val="accent1"/>
-          </a:lnRef>
-          <a:fillRef idx="3">
-            <a:schemeClr val="accent1"/>
-          </a:fillRef>
-          <a:effectRef idx="2">
-            <a:schemeClr val="accent1"/>
-          </a:effectRef>
-          <a:fontRef idx="minor">
-            <a:schemeClr val="lt1"/>
-          </a:fontRef>
-        </p:style>
-        <p:txBody>
-          <a:bodyPr rtlCol="0" anchor="ctr"/>
-          <a:lstStyle/>
-          <a:p>
-            <a:pPr algn="ctr">
-              <a:defRPr sz="900" b="1">
-                <a:solidFill>
-                  <a:srgbClr val="FFFFFF"/>
-                </a:solidFill>
-              </a:defRPr>
-            </a:pPr>
-            <a:r>
-              <a:rPr sz="1100">
-                <a:latin typeface="Avenir Next" panose="020B0503020202020204" pitchFamily="34" charset="0"/>
-              </a:rPr>
-              <a:t>Gap 3</a:t>
-            </a:r>
-          </a:p>
-        </p:txBody>
-      </p:sp>
-      <p:sp>
-        <p:nvSpPr>
-          <p:cNvPr id="13" name="TextBox 12"/>
-          <p:cNvSpPr txBox="1"/>
-          <p:nvPr/>
-        </p:nvSpPr>
-        <p:spPr>
-          <a:xfrm>
-            <a:off x="1475918" y="4330000"/>
-            <a:ext cx="4330521" cy="956672"/>
-          </a:xfrm>
-          <a:prstGeom prst="rect">
-            <a:avLst/>
-          </a:prstGeom>
-          <a:noFill/>
-        </p:spPr>
-        <p:txBody>
-          <a:bodyPr wrap="square">
-            <a:spAutoFit/>
-          </a:bodyPr>
-          <a:lstStyle/>
-          <a:p>
-            <a:pPr algn="l">
+          <a:p>
+            <a:pPr>
               <a:spcAft>
                 <a:spcPts val="200"/>
               </a:spcAft>
@@ -24819,10 +24611,10 @@
               </a:defRPr>
             </a:pPr>
             <a:r>
-              <a:rPr>
-                <a:latin typeface="Avenir Next" panose="020B0503020202020204" pitchFamily="34" charset="0"/>
-              </a:rPr>
-              <a:t>Verification &amp; Assurance Gap</a:t>
+              <a:rPr lang="en-IN" sz="1350" dirty="0">
+                <a:latin typeface="Avenir Next" panose="020B0503020202020204" pitchFamily="34" charset="0"/>
+              </a:rPr>
+              <a:t>Regulatory Fragmentation</a:t>
             </a:r>
           </a:p>
           <a:p>
@@ -24830,140 +24622,22 @@
               <a:defRPr sz="1050"/>
             </a:pPr>
             <a:r>
-              <a:rPr sz="1400">
-                <a:latin typeface="Avenir Next" panose="020B0503020202020204" pitchFamily="34" charset="0"/>
-              </a:rPr>
-              <a:t>Mandatory ESG disclosure has expanded without mandatory third-party verification, leaving claims unverified.</a:t>
-            </a:r>
-          </a:p>
-        </p:txBody>
-      </p:sp>
-      <p:sp>
-        <p:nvSpPr>
-          <p:cNvPr id="14" name="Rounded Rectangle 13"/>
-          <p:cNvSpPr/>
-          <p:nvPr/>
-        </p:nvSpPr>
-        <p:spPr>
-          <a:xfrm>
-            <a:off x="6233374" y="1850000"/>
-            <a:ext cx="5196625" cy="1080000"/>
-          </a:xfrm>
-          <a:prstGeom prst="roundRect">
-            <a:avLst/>
-          </a:prstGeom>
-          <a:solidFill>
-            <a:srgbClr val="FFFFFF"/>
-          </a:solidFill>
-          <a:ln w="10160">
-            <a:solidFill>
-              <a:srgbClr val="DEE0E5"/>
-            </a:solidFill>
-          </a:ln>
-        </p:spPr>
-        <p:style>
-          <a:lnRef idx="1">
-            <a:schemeClr val="accent1"/>
-          </a:lnRef>
-          <a:fillRef idx="3">
-            <a:schemeClr val="accent1"/>
-          </a:fillRef>
-          <a:effectRef idx="2">
-            <a:schemeClr val="accent1"/>
-          </a:effectRef>
-          <a:fontRef idx="minor">
-            <a:schemeClr val="lt1"/>
-          </a:fontRef>
-        </p:style>
-        <p:txBody>
-          <a:bodyPr rtlCol="0" anchor="ctr"/>
-          <a:lstStyle/>
-          <a:p>
-            <a:pPr algn="ctr"/>
-            <a:endParaRPr sz="2800">
+              <a:rPr lang="en-IN" sz="1350" dirty="0">
+                <a:latin typeface="Avenir Next" panose="020B0503020202020204" pitchFamily="34" charset="0"/>
+              </a:rPr>
+              <a:t>The regulatory fragmentation problem has not been sufficiently examined as a structural cause of greenwashing. Green claims are policed across siloed regimes (MCA, SEBI, CCPA/ASCI), creating jurisdictional overlap and an accountability vacuum.</a:t>
+            </a:r>
+          </a:p>
+          <a:p>
+            <a:pPr>
+              <a:defRPr sz="1050"/>
+            </a:pPr>
+            <a:endParaRPr lang="en-IN" sz="1350" dirty="0">
               <a:latin typeface="Avenir Next" panose="020B0503020202020204" pitchFamily="34" charset="0"/>
             </a:endParaRPr>
           </a:p>
-        </p:txBody>
-      </p:sp>
-      <p:sp>
-        <p:nvSpPr>
-          <p:cNvPr id="15" name="Rounded Rectangle 14"/>
-          <p:cNvSpPr/>
-          <p:nvPr/>
-        </p:nvSpPr>
-        <p:spPr>
-          <a:xfrm>
-            <a:off x="6310986" y="1970000"/>
-            <a:ext cx="547013" cy="318828"/>
-          </a:xfrm>
-          <a:prstGeom prst="roundRect">
-            <a:avLst/>
-          </a:prstGeom>
-          <a:solidFill>
-            <a:srgbClr val="0E8A74"/>
-          </a:solidFill>
-          <a:ln>
-            <a:noFill/>
-          </a:ln>
-        </p:spPr>
-        <p:style>
-          <a:lnRef idx="1">
-            <a:schemeClr val="accent1"/>
-          </a:lnRef>
-          <a:fillRef idx="3">
-            <a:schemeClr val="accent1"/>
-          </a:fillRef>
-          <a:effectRef idx="2">
-            <a:schemeClr val="accent1"/>
-          </a:effectRef>
-          <a:fontRef idx="minor">
-            <a:schemeClr val="lt1"/>
-          </a:fontRef>
-        </p:style>
-        <p:txBody>
-          <a:bodyPr rtlCol="0" anchor="ctr"/>
-          <a:lstStyle/>
-          <a:p>
-            <a:pPr algn="ctr">
-              <a:defRPr sz="900" b="1">
-                <a:solidFill>
-                  <a:srgbClr val="FFFFFF"/>
-                </a:solidFill>
-              </a:defRPr>
-            </a:pPr>
-            <a:r>
-              <a:rPr sz="1100">
-                <a:latin typeface="Avenir Next" panose="020B0503020202020204" pitchFamily="34" charset="0"/>
-              </a:rPr>
-              <a:t>Gap 4</a:t>
-            </a:r>
-          </a:p>
-        </p:txBody>
-      </p:sp>
-      <p:sp>
-        <p:nvSpPr>
-          <p:cNvPr id="16" name="TextBox 15"/>
-          <p:cNvSpPr txBox="1"/>
-          <p:nvPr/>
-        </p:nvSpPr>
-        <p:spPr>
-          <a:xfrm>
-            <a:off x="6962318" y="1930000"/>
-            <a:ext cx="4330521" cy="956672"/>
-          </a:xfrm>
-          <a:prstGeom prst="rect">
-            <a:avLst/>
-          </a:prstGeom>
-          <a:noFill/>
-        </p:spPr>
-        <p:txBody>
-          <a:bodyPr wrap="square">
-            <a:spAutoFit/>
-          </a:bodyPr>
-          <a:lstStyle/>
-          <a:p>
-            <a:pPr algn="l">
+          <a:p>
+            <a:pPr>
               <a:spcAft>
                 <a:spcPts val="200"/>
               </a:spcAft>
@@ -24975,160 +24649,33 @@
               </a:defRPr>
             </a:pPr>
             <a:r>
-              <a:rPr dirty="0">
-                <a:latin typeface="Avenir Next" panose="020B0503020202020204" pitchFamily="34" charset="0"/>
-              </a:rPr>
-              <a:t>Evolving </a:t>
-            </a:r>
-            <a:r>
-              <a:rPr lang="en-US" dirty="0">
-                <a:latin typeface="Avenir Next" panose="020B0503020202020204" pitchFamily="34" charset="0"/>
-              </a:rPr>
-              <a:t>Forms of Greenwashing: Legal Vacuum</a:t>
-            </a:r>
-            <a:endParaRPr dirty="0">
+              <a:rPr lang="en-US" sz="1350" dirty="0">
+                <a:latin typeface="Avenir Next" panose="020B0503020202020204" pitchFamily="34" charset="0"/>
+              </a:rPr>
+              <a:t>Limited analysis on finding structural reasons for low Enforcement</a:t>
+            </a:r>
+          </a:p>
+          <a:p>
+            <a:pPr>
+              <a:defRPr sz="1050"/>
+            </a:pPr>
+            <a:r>
+              <a:rPr lang="en-US" sz="1350" dirty="0">
+                <a:latin typeface="Avenir Next" panose="020B0503020202020204" pitchFamily="34" charset="0"/>
+              </a:rPr>
+              <a:t>The available discussion on the enforcement of section 166(2) of Companies Act remains thin. Beyond Companies Act also, there is lack of doctrinal studies evaluating why regulators rarely bring deterrent enforcement actions against greenwashing.</a:t>
+            </a:r>
+          </a:p>
+          <a:p>
+            <a:pPr>
+              <a:defRPr sz="1050"/>
+            </a:pPr>
+            <a:endParaRPr lang="en-IN" sz="1350" dirty="0">
               <a:latin typeface="Avenir Next" panose="020B0503020202020204" pitchFamily="34" charset="0"/>
             </a:endParaRPr>
           </a:p>
           <a:p>
             <a:pPr>
-              <a:defRPr sz="1050"/>
-            </a:pPr>
-            <a:r>
-              <a:rPr sz="1400" dirty="0">
-                <a:latin typeface="Avenir Next" panose="020B0503020202020204" pitchFamily="34" charset="0"/>
-              </a:rPr>
-              <a:t>Distant net-zero pledges (e.g. 2070) and questionable carbon-offset claims remain unaddressed in current frameworks.</a:t>
-            </a:r>
-          </a:p>
-        </p:txBody>
-      </p:sp>
-      <p:sp>
-        <p:nvSpPr>
-          <p:cNvPr id="17" name="Rounded Rectangle 16"/>
-          <p:cNvSpPr/>
-          <p:nvPr/>
-        </p:nvSpPr>
-        <p:spPr>
-          <a:xfrm>
-            <a:off x="6233374" y="3050000"/>
-            <a:ext cx="5196625" cy="1080000"/>
-          </a:xfrm>
-          <a:prstGeom prst="roundRect">
-            <a:avLst/>
-          </a:prstGeom>
-          <a:solidFill>
-            <a:srgbClr val="FFFFFF"/>
-          </a:solidFill>
-          <a:ln w="10160">
-            <a:solidFill>
-              <a:srgbClr val="DEE0E5"/>
-            </a:solidFill>
-          </a:ln>
-        </p:spPr>
-        <p:style>
-          <a:lnRef idx="1">
-            <a:schemeClr val="accent1"/>
-          </a:lnRef>
-          <a:fillRef idx="3">
-            <a:schemeClr val="accent1"/>
-          </a:fillRef>
-          <a:effectRef idx="2">
-            <a:schemeClr val="accent1"/>
-          </a:effectRef>
-          <a:fontRef idx="minor">
-            <a:schemeClr val="lt1"/>
-          </a:fontRef>
-        </p:style>
-        <p:txBody>
-          <a:bodyPr rtlCol="0" anchor="ctr"/>
-          <a:lstStyle/>
-          <a:p>
-            <a:pPr algn="ctr"/>
-            <a:endParaRPr sz="2800">
-              <a:latin typeface="Avenir Next" panose="020B0503020202020204" pitchFamily="34" charset="0"/>
-            </a:endParaRPr>
-          </a:p>
-        </p:txBody>
-      </p:sp>
-      <p:sp>
-        <p:nvSpPr>
-          <p:cNvPr id="18" name="Rounded Rectangle 17"/>
-          <p:cNvSpPr/>
-          <p:nvPr/>
-        </p:nvSpPr>
-        <p:spPr>
-          <a:xfrm>
-            <a:off x="6310986" y="3170000"/>
-            <a:ext cx="547013" cy="318828"/>
-          </a:xfrm>
-          <a:prstGeom prst="roundRect">
-            <a:avLst/>
-          </a:prstGeom>
-          <a:solidFill>
-            <a:srgbClr val="0E8A74"/>
-          </a:solidFill>
-          <a:ln>
-            <a:noFill/>
-          </a:ln>
-        </p:spPr>
-        <p:style>
-          <a:lnRef idx="1">
-            <a:schemeClr val="accent1"/>
-          </a:lnRef>
-          <a:fillRef idx="3">
-            <a:schemeClr val="accent1"/>
-          </a:fillRef>
-          <a:effectRef idx="2">
-            <a:schemeClr val="accent1"/>
-          </a:effectRef>
-          <a:fontRef idx="minor">
-            <a:schemeClr val="lt1"/>
-          </a:fontRef>
-        </p:style>
-        <p:txBody>
-          <a:bodyPr rtlCol="0" anchor="ctr"/>
-          <a:lstStyle/>
-          <a:p>
-            <a:pPr algn="ctr">
-              <a:defRPr sz="900" b="1">
-                <a:solidFill>
-                  <a:srgbClr val="FFFFFF"/>
-                </a:solidFill>
-              </a:defRPr>
-            </a:pPr>
-            <a:r>
-              <a:rPr sz="1100">
-                <a:latin typeface="Avenir Next" panose="020B0503020202020204" pitchFamily="34" charset="0"/>
-              </a:rPr>
-              <a:t>Gap 5</a:t>
-            </a:r>
-          </a:p>
-        </p:txBody>
-      </p:sp>
-      <p:sp>
-        <p:nvSpPr>
-          <p:cNvPr id="19" name="TextBox 18"/>
-          <p:cNvSpPr txBox="1"/>
-          <p:nvPr/>
-        </p:nvSpPr>
-        <p:spPr>
-          <a:xfrm>
-            <a:off x="6962318" y="3130000"/>
-            <a:ext cx="4330521" cy="956672"/>
-          </a:xfrm>
-          <a:prstGeom prst="rect">
-            <a:avLst/>
-          </a:prstGeom>
-          <a:noFill/>
-        </p:spPr>
-        <p:txBody>
-          <a:bodyPr wrap="square">
-            <a:spAutoFit/>
-          </a:bodyPr>
-          <a:lstStyle/>
-          <a:p>
-            <a:pPr algn="l">
               <a:spcAft>
                 <a:spcPts val="200"/>
               </a:spcAft>
@@ -25140,10 +24687,10 @@
               </a:defRPr>
             </a:pPr>
             <a:r>
-              <a:rPr dirty="0">
-                <a:latin typeface="Avenir Next" panose="020B0503020202020204" pitchFamily="34" charset="0"/>
-              </a:rPr>
-              <a:t>Real-World Enforcement Analysis</a:t>
+              <a:rPr lang="en-IN" sz="1350" dirty="0">
+                <a:latin typeface="Avenir Next" panose="020B0503020202020204" pitchFamily="34" charset="0"/>
+              </a:rPr>
+              <a:t>Limited study on Verification &amp; Assurance Gap</a:t>
             </a:r>
           </a:p>
           <a:p>
@@ -25151,22 +24698,10 @@
               <a:defRPr sz="1050"/>
             </a:pPr>
             <a:r>
-              <a:rPr sz="1400" dirty="0">
-                <a:latin typeface="Avenir Next" panose="020B0503020202020204" pitchFamily="34" charset="0"/>
-              </a:rPr>
-              <a:t>Lack of </a:t>
-            </a:r>
-            <a:r>
-              <a:rPr lang="en-US" sz="1400" dirty="0">
-                <a:latin typeface="Avenir Next" panose="020B0503020202020204" pitchFamily="34" charset="0"/>
-              </a:rPr>
-              <a:t>doctrinal </a:t>
-            </a:r>
-            <a:r>
-              <a:rPr sz="1400" dirty="0">
-                <a:latin typeface="Avenir Next" panose="020B0503020202020204" pitchFamily="34" charset="0"/>
-              </a:rPr>
-              <a:t>studies evaluating why regulators rarely bring deterrent enforcement actions against greenwashing.</a:t>
+              <a:rPr lang="en-IN" sz="1350" dirty="0">
+                <a:latin typeface="Avenir Next" panose="020B0503020202020204" pitchFamily="34" charset="0"/>
+              </a:rPr>
+              <a:t>Mandatory ESG disclosure has expanded without corresponding third-party verification capacity, resulting in unverified violations and meagre enforcement of regulation.</a:t>
             </a:r>
           </a:p>
         </p:txBody>
@@ -25179,7 +24714,7 @@
         </p:nvSpPr>
         <p:spPr>
           <a:xfrm>
-            <a:off x="731520" y="5665372"/>
+            <a:off x="676302" y="5754490"/>
             <a:ext cx="10698480" cy="944444"/>
           </a:xfrm>
           <a:prstGeom prst="roundRect">
@@ -25227,7 +24762,7 @@
         </p:nvSpPr>
         <p:spPr>
           <a:xfrm>
-            <a:off x="914400" y="5711092"/>
+            <a:off x="1042062" y="5824178"/>
             <a:ext cx="10332720" cy="820738"/>
           </a:xfrm>
           <a:prstGeom prst="rect">
@@ -25367,8 +24902,8 @@
         </p:nvSpPr>
         <p:spPr>
           <a:xfrm>
-            <a:off x="730846" y="357075"/>
-            <a:ext cx="10058400" cy="877163"/>
+            <a:off x="619633" y="161231"/>
+            <a:ext cx="10058400" cy="1123384"/>
           </a:xfrm>
           <a:prstGeom prst="rect">
             <a:avLst/>
@@ -25382,6 +24917,9 @@
           <a:lstStyle/>
           <a:p>
             <a:pPr>
+              <a:lnSpc>
+                <a:spcPct val="150000"/>
+              </a:lnSpc>
               <a:spcAft>
                 <a:spcPts val="600"/>
               </a:spcAft>
@@ -25401,6 +24939,12 @@
               </a:rPr>
               <a:t>Research Methodology</a:t>
             </a:r>
+            <a:endParaRPr sz="1200" b="1" dirty="0">
+              <a:solidFill>
+                <a:srgbClr val="173F35"/>
+              </a:solidFill>
+              <a:latin typeface="Avenir Next Demi Bold"/>
+            </a:endParaRPr>
           </a:p>
           <a:p>
             <a:pPr>
@@ -25412,18 +24956,18 @@
               </a:defRPr>
             </a:pPr>
             <a:r>
-              <a:rPr lang="en-US" sz="1400" dirty="0">
+              <a:rPr lang="en-US" sz="1400" b="1" dirty="0">
                 <a:latin typeface="Avenir Next" panose="020B0503020202020204" pitchFamily="34" charset="0"/>
               </a:rPr>
               <a:t>Comparative and Analytical </a:t>
             </a:r>
             <a:r>
-              <a:rPr sz="1400" dirty="0">
+              <a:rPr sz="1400" b="1" dirty="0">
                 <a:latin typeface="Avenir Next" panose="020B0503020202020204" pitchFamily="34" charset="0"/>
               </a:rPr>
               <a:t>Legal Research</a:t>
             </a:r>
-            <a:endParaRPr sz="1400" dirty="0">
+            <a:endParaRPr sz="1400" b="1" dirty="0">
               <a:latin typeface="Avenir Next" panose="020B0503020202020204" pitchFamily="34" charset="0"/>
               <a:ea typeface="Calibri"/>
               <a:cs typeface="Calibri"/>
@@ -25540,7 +25084,7 @@
         <p:spPr>
           <a:xfrm>
             <a:off x="1005840" y="1600200"/>
-            <a:ext cx="2926080" cy="2385268"/>
+            <a:ext cx="2967598" cy="2385268"/>
           </a:xfrm>
           <a:prstGeom prst="rect">
             <a:avLst/>
@@ -25584,7 +25128,7 @@
               <a:rPr lang="en-IN" sz="1400" dirty="0">
                 <a:latin typeface="Avenir Next" panose="020B0503020202020204" pitchFamily="34" charset="0"/>
               </a:rPr>
-              <a:t>Indian statutes, judicial decisions (Supreme Court, NGT, foreign courts), regulatory instruments (SEBI BRSR, CCPA Guidelines, ASCI Guidelines, etc.), parliamentary reports, research papers.</a:t>
+              <a:t>Indian statutes, judicial decisions (Supreme Court, NGT, SEBI, foreign courts), regulatory instruments (SEBI BRSR, CCPA Guidelines, ASCI Guidelines, etc.), parliamentary reports, research papers.</a:t>
             </a:r>
             <a:endParaRPr lang="en-IN" sz="1400" dirty="0">
               <a:latin typeface="Avenir Next" panose="020B0503020202020204" pitchFamily="34" charset="0"/>
@@ -25719,7 +25263,7 @@
         <p:spPr>
           <a:xfrm>
             <a:off x="4663440" y="1600200"/>
-            <a:ext cx="2926080" cy="1708160"/>
+            <a:ext cx="2926080" cy="1923604"/>
           </a:xfrm>
           <a:prstGeom prst="rect">
             <a:avLst/>
@@ -25765,6 +25309,19 @@
               </a:rPr>
               <a:t>Hohfeldian decomposition of corporate duties into precise legal relations. </a:t>
             </a:r>
+            <a:endParaRPr lang="en-US" sz="1400" dirty="0">
+              <a:latin typeface="Avenir Next" panose="020B0503020202020204" pitchFamily="34" charset="0"/>
+            </a:endParaRPr>
+          </a:p>
+          <a:p>
+            <a:pPr>
+              <a:defRPr sz="1200" b="0">
+                <a:solidFill>
+                  <a:srgbClr val="3A3A4A"/>
+                </a:solidFill>
+                <a:latin typeface="Calibri"/>
+              </a:defRPr>
+            </a:pPr>
             <a:endParaRPr lang="en-US" sz="1400" dirty="0">
               <a:latin typeface="Avenir Next" panose="020B0503020202020204" pitchFamily="34" charset="0"/>
             </a:endParaRPr>
@@ -25902,7 +25459,7 @@
         <p:spPr>
           <a:xfrm>
             <a:off x="8321040" y="1600200"/>
-            <a:ext cx="2926080" cy="1492716"/>
+            <a:ext cx="2926080" cy="1061829"/>
           </a:xfrm>
           <a:prstGeom prst="rect">
             <a:avLst/>
@@ -25946,7 +25503,7 @@
               <a:rPr sz="1400" dirty="0">
                 <a:latin typeface="Avenir Next" panose="020B0503020202020204" pitchFamily="34" charset="0"/>
               </a:rPr>
-              <a:t>Cross-jurisdictional study of EU (CSRD, Green Claims Directive), US (SEC Rules, FTC Green Guides), UK (FCA Rule, CMA),</a:t>
+              <a:t>Cross-jurisdictional study of EU, US, UK,</a:t>
             </a:r>
             <a:r>
               <a:rPr lang="en-US" sz="1400" dirty="0">
@@ -25958,7 +25515,19 @@
               <a:rPr sz="1400" dirty="0">
                 <a:latin typeface="Avenir Next" panose="020B0503020202020204" pitchFamily="34" charset="0"/>
               </a:rPr>
-              <a:t>Australia, and others.</a:t>
+              <a:t>Australia, and </a:t>
+            </a:r>
+            <a:r>
+              <a:rPr lang="en-US" sz="1400" dirty="0">
+                <a:latin typeface="Avenir Next" panose="020B0503020202020204" pitchFamily="34" charset="0"/>
+              </a:rPr>
+              <a:t>also developing countries</a:t>
+            </a:r>
+            <a:r>
+              <a:rPr sz="1400" dirty="0">
+                <a:latin typeface="Avenir Next" panose="020B0503020202020204" pitchFamily="34" charset="0"/>
+              </a:rPr>
+              <a:t>.</a:t>
             </a:r>
           </a:p>
         </p:txBody>
@@ -26172,7 +25741,7 @@
         <p:spPr>
           <a:xfrm>
             <a:off x="960223" y="4080669"/>
-            <a:ext cx="2926080" cy="1708160"/>
+            <a:ext cx="2926080" cy="1492716"/>
           </a:xfrm>
           <a:prstGeom prst="rect">
             <a:avLst/>
@@ -26216,7 +25785,7 @@
               <a:rPr lang="en-IN" sz="1400" dirty="0">
                 <a:latin typeface="Avenir Next" panose="020B0503020202020204" pitchFamily="34" charset="0"/>
               </a:rPr>
-              <a:t>Textual, contextual and purposive analysis of the Companies Act 2013, Consumer Protection Act 2019, Environment Protection Act 1986 (EPA), and SEBI LODR Regulations.</a:t>
+              <a:t>Textual, contextual and purposive analysis of relevant sections of the Companies Act 2013, Consumer Protection Act 2019. And of relevant SEBI Regulations.</a:t>
             </a:r>
             <a:endParaRPr lang="en-IN" sz="1400" dirty="0">
               <a:latin typeface="Avenir Next" panose="020B0503020202020204" pitchFamily="34" charset="0"/>
@@ -26382,7 +25951,19 @@
               <a:rPr sz="1400" dirty="0">
                 <a:latin typeface="Avenir Next" panose="020B0503020202020204" pitchFamily="34" charset="0"/>
               </a:rPr>
-              <a:t>Explicit distinction between what the law currently provides (analysis) and what it should provide (normative reform proposals).</a:t>
+              <a:t>Explicit distinction</a:t>
+            </a:r>
+            <a:r>
+              <a:rPr lang="en-US" sz="1400" dirty="0">
+                <a:latin typeface="Avenir Next" panose="020B0503020202020204" pitchFamily="34" charset="0"/>
+              </a:rPr>
+              <a:t> maintained</a:t>
+            </a:r>
+            <a:r>
+              <a:rPr sz="1400" dirty="0">
+                <a:latin typeface="Avenir Next" panose="020B0503020202020204" pitchFamily="34" charset="0"/>
+              </a:rPr>
+              <a:t> between what the law currently provides and what it should provide (normative reform proposals).</a:t>
             </a:r>
           </a:p>
         </p:txBody>
@@ -26492,7 +26073,19 @@
               <a:rPr sz="1400" dirty="0">
                 <a:latin typeface="Avenir Next" panose="020B0503020202020204" pitchFamily="34" charset="0"/>
               </a:rPr>
-              <a:t>between MCA, SEBI, CCPA, ASCI, FSSAI, NGT, and BIS — identifying gaps, penalty arbitrage, and regulatory backsliding.</a:t>
+              <a:t>between MCA, SEBI, CCPA, ASCI</a:t>
+            </a:r>
+            <a:r>
+              <a:rPr lang="en-US" sz="1400" dirty="0">
+                <a:latin typeface="Avenir Next" panose="020B0503020202020204" pitchFamily="34" charset="0"/>
+              </a:rPr>
+              <a:t>, </a:t>
+            </a:r>
+            <a:r>
+              <a:rPr sz="1400" dirty="0">
+                <a:latin typeface="Avenir Next" panose="020B0503020202020204" pitchFamily="34" charset="0"/>
+              </a:rPr>
+              <a:t>identifying gaps, penalty arbitrage, and regulatory backsliding.</a:t>
             </a:r>
           </a:p>
         </p:txBody>

</xml_diff>

<commit_message>
refactor: update and refine presentation narration script and accompanying slides
</commit_message>
<xml_diff>
--- a/Thesis Defence Presentation Final.pptx
+++ b/Thesis Defence Presentation Final.pptx
@@ -508,6 +508,90 @@
 </file>
 
 <file path=ppt/notesSlides/notesSlide1.xml><?xml version="1.0" encoding="utf-8"?>
+<p:notes xmlns:a="http://schemas.openxmlformats.org/drawingml/2006/main" xmlns:r="http://schemas.openxmlformats.org/officeDocument/2006/relationships" xmlns:p="http://schemas.openxmlformats.org/presentationml/2006/main">
+  <p:cSld>
+    <p:spTree>
+      <p:nvGrpSpPr>
+        <p:cNvPr id="1" name=""/>
+        <p:cNvGrpSpPr/>
+        <p:nvPr/>
+      </p:nvGrpSpPr>
+      <p:grpSpPr>
+        <a:xfrm>
+          <a:off x="0" y="0"/>
+          <a:ext cx="0" cy="0"/>
+          <a:chOff x="0" y="0"/>
+          <a:chExt cx="0" cy="0"/>
+        </a:xfrm>
+      </p:grpSpPr>
+      <p:sp>
+        <p:nvSpPr>
+          <p:cNvPr id="2" name="Slide Image Placeholder 1"/>
+          <p:cNvSpPr>
+            <a:spLocks noGrp="1" noRot="1" noChangeAspect="1"/>
+          </p:cNvSpPr>
+          <p:nvPr>
+            <p:ph type="sldImg"/>
+          </p:nvPr>
+        </p:nvSpPr>
+        <p:spPr/>
+      </p:sp>
+      <p:sp>
+        <p:nvSpPr>
+          <p:cNvPr id="3" name="Notes Placeholder 2"/>
+          <p:cNvSpPr>
+            <a:spLocks noGrp="1"/>
+          </p:cNvSpPr>
+          <p:nvPr>
+            <p:ph type="body" idx="1"/>
+          </p:nvPr>
+        </p:nvSpPr>
+        <p:spPr/>
+        <p:txBody>
+          <a:bodyPr/>
+          <a:lstStyle/>
+          <a:p>
+            <a:endParaRPr lang="en-US"/>
+          </a:p>
+        </p:txBody>
+      </p:sp>
+      <p:sp>
+        <p:nvSpPr>
+          <p:cNvPr id="4" name="Slide Number Placeholder 3"/>
+          <p:cNvSpPr>
+            <a:spLocks noGrp="1"/>
+          </p:cNvSpPr>
+          <p:nvPr>
+            <p:ph type="sldNum" sz="quarter" idx="5"/>
+          </p:nvPr>
+        </p:nvSpPr>
+        <p:spPr/>
+        <p:txBody>
+          <a:bodyPr/>
+          <a:lstStyle/>
+          <a:p>
+            <a:fld id="{C762F6BD-97DA-5F40-B046-A0BF2F554C1C}" type="slidenum">
+              <a:rPr lang="en-US" smtClean="0"/>
+              <a:t>1</a:t>
+            </a:fld>
+            <a:endParaRPr lang="en-US"/>
+          </a:p>
+        </p:txBody>
+      </p:sp>
+    </p:spTree>
+    <p:extLst>
+      <p:ext uri="{BB962C8B-B14F-4D97-AF65-F5344CB8AC3E}">
+        <p14:creationId xmlns:p14="http://schemas.microsoft.com/office/powerpoint/2010/main" val="394336565"/>
+      </p:ext>
+    </p:extLst>
+  </p:cSld>
+  <p:clrMapOvr>
+    <a:masterClrMapping/>
+  </p:clrMapOvr>
+</p:notes>
+</file>
+
+<file path=ppt/notesSlides/notesSlide2.xml><?xml version="1.0" encoding="utf-8"?>
 <p:notes xmlns:a="http://schemas.openxmlformats.org/drawingml/2006/main" xmlns:r="http://schemas.openxmlformats.org/officeDocument/2006/relationships" xmlns:p="http://schemas.openxmlformats.org/presentationml/2006/main">
   <p:cSld>
     <p:spTree>
@@ -3710,7 +3794,7 @@
           <p:nvPr/>
         </p:nvPicPr>
         <p:blipFill>
-          <a:blip r:embed="rId2">
+          <a:blip r:embed="rId3">
             <a:extLst>
               <a:ext uri="{28A0092B-C50C-407E-A947-70E740481C1C}">
                 <a14:useLocalDpi xmlns:a14="http://schemas.microsoft.com/office/drawing/2010/main" val="0"/>
@@ -6074,8 +6158,17 @@
               <a:rPr sz="1600" dirty="0">
                 <a:latin typeface="Avenir Next" panose="020B0503020202020204" pitchFamily="34" charset="0"/>
               </a:rPr>
-              <a:t>The Corporate Governance Solution</a:t>
-            </a:r>
+              <a:t>The Corporate Governance </a:t>
+            </a:r>
+            <a:r>
+              <a:rPr lang="en-US" sz="1600" dirty="0">
+                <a:latin typeface="Avenir Next" panose="020B0503020202020204" pitchFamily="34" charset="0"/>
+              </a:rPr>
+              <a:t>Pathway</a:t>
+            </a:r>
+            <a:endParaRPr sz="1600" dirty="0">
+              <a:latin typeface="Avenir Next" panose="020B0503020202020204" pitchFamily="34" charset="0"/>
+            </a:endParaRPr>
           </a:p>
           <a:p>
             <a:pPr>
@@ -6693,7 +6786,7 @@
                 <a:ea typeface="Calibri"/>
                 <a:cs typeface="Calibri"/>
               </a:rPr>
-              <a:t>may not stand legal test</a:t>
+              <a:t>may not stand legal test.</a:t>
             </a:r>
           </a:p>
           <a:p>
@@ -9276,7 +9369,7 @@
         </p:nvSpPr>
         <p:spPr>
           <a:xfrm>
-            <a:off x="799190" y="1015812"/>
+            <a:off x="790823" y="5206916"/>
             <a:ext cx="10587831" cy="605058"/>
           </a:xfrm>
           <a:prstGeom prst="roundRect">
@@ -9324,7 +9417,7 @@
         </p:nvSpPr>
         <p:spPr>
           <a:xfrm>
-            <a:off x="917115" y="1106717"/>
+            <a:off x="908748" y="5297821"/>
             <a:ext cx="10186416" cy="523220"/>
           </a:xfrm>
           <a:prstGeom prst="rect">
@@ -9363,8 +9456,8 @@
         </p:nvSpPr>
         <p:spPr>
           <a:xfrm>
-            <a:off x="822960" y="4953252"/>
-            <a:ext cx="2468880" cy="896112"/>
+            <a:off x="790823" y="3918240"/>
+            <a:ext cx="2468880" cy="1067934"/>
           </a:xfrm>
           <a:prstGeom prst="roundRect">
             <a:avLst/>
@@ -9424,7 +9517,19 @@
               <a:rPr dirty="0">
                 <a:latin typeface="Avenir Next" panose="020B0503020202020204" pitchFamily="34" charset="0"/>
               </a:rPr>
-              <a:t>BRSR becomes mandatory for the top 1000 listed entities</a:t>
+              <a:t>BRSR </a:t>
+            </a:r>
+            <a:r>
+              <a:rPr lang="en-US" dirty="0">
+                <a:latin typeface="Avenir Next" panose="020B0503020202020204" pitchFamily="34" charset="0"/>
+              </a:rPr>
+              <a:t>introduced: </a:t>
+            </a:r>
+            <a:r>
+              <a:rPr dirty="0">
+                <a:latin typeface="Avenir Next" panose="020B0503020202020204" pitchFamily="34" charset="0"/>
+              </a:rPr>
+              <a:t> mandatory for the top 1000 listed entities</a:t>
             </a:r>
           </a:p>
         </p:txBody>
@@ -9437,8 +9542,8 @@
         </p:nvSpPr>
         <p:spPr>
           <a:xfrm>
-            <a:off x="3438144" y="4953252"/>
-            <a:ext cx="2468880" cy="896112"/>
+            <a:off x="3406007" y="3918240"/>
+            <a:ext cx="2468880" cy="1067934"/>
           </a:xfrm>
           <a:prstGeom prst="roundRect">
             <a:avLst/>
@@ -9479,7 +9584,7 @@
               </a:defRPr>
             </a:pPr>
             <a:r>
-              <a:rPr>
+              <a:rPr dirty="0">
                 <a:latin typeface="Avenir Next" panose="020B0503020202020204" pitchFamily="34" charset="0"/>
               </a:rPr>
               <a:t>2023</a:t>
@@ -9495,10 +9600,34 @@
               </a:defRPr>
             </a:pPr>
             <a:r>
-              <a:rPr>
-                <a:latin typeface="Avenir Next" panose="020B0503020202020204" pitchFamily="34" charset="0"/>
-              </a:rPr>
-              <a:t>BRSR Core adds key KPIs, assurance track, and value-chain reporting</a:t>
+              <a:rPr dirty="0">
+                <a:latin typeface="Avenir Next" panose="020B0503020202020204" pitchFamily="34" charset="0"/>
+              </a:rPr>
+              <a:t>BRSR Core</a:t>
+            </a:r>
+            <a:r>
+              <a:rPr lang="en-US" dirty="0">
+                <a:latin typeface="Avenir Next" panose="020B0503020202020204" pitchFamily="34" charset="0"/>
+              </a:rPr>
+              <a:t> introduced: stricter,</a:t>
+            </a:r>
+            <a:r>
+              <a:rPr dirty="0">
+                <a:latin typeface="Avenir Next" panose="020B0503020202020204" pitchFamily="34" charset="0"/>
+              </a:rPr>
+              <a:t> adds KPIs, </a:t>
+            </a:r>
+            <a:r>
+              <a:rPr lang="en-US" dirty="0">
+                <a:latin typeface="Avenir Next" panose="020B0503020202020204" pitchFamily="34" charset="0"/>
+              </a:rPr>
+              <a:t>mandatory reasonable </a:t>
+            </a:r>
+            <a:r>
+              <a:rPr dirty="0">
+                <a:latin typeface="Avenir Next" panose="020B0503020202020204" pitchFamily="34" charset="0"/>
+              </a:rPr>
+              <a:t>assurance and value-chain reporting</a:t>
             </a:r>
           </a:p>
         </p:txBody>
@@ -9511,8 +9640,8 @@
         </p:nvSpPr>
         <p:spPr>
           <a:xfrm>
-            <a:off x="6053328" y="4953252"/>
-            <a:ext cx="2468880" cy="896112"/>
+            <a:off x="6021191" y="3918240"/>
+            <a:ext cx="2468880" cy="1067934"/>
           </a:xfrm>
           <a:prstGeom prst="roundRect">
             <a:avLst/>
@@ -9584,7 +9713,19 @@
               <a:rPr dirty="0">
                 <a:latin typeface="Avenir Next" panose="020B0503020202020204" pitchFamily="34" charset="0"/>
               </a:rPr>
-              <a:t>assurance diluted and value-chain disclosure deferred and made voluntary</a:t>
+              <a:t>assurance diluted </a:t>
+            </a:r>
+            <a:r>
+              <a:rPr lang="en-US" dirty="0">
+                <a:latin typeface="Avenir Next" panose="020B0503020202020204" pitchFamily="34" charset="0"/>
+              </a:rPr>
+              <a:t>to assessment </a:t>
+            </a:r>
+            <a:r>
+              <a:rPr dirty="0">
+                <a:latin typeface="Avenir Next" panose="020B0503020202020204" pitchFamily="34" charset="0"/>
+              </a:rPr>
+              <a:t>and value-chain disclosure deferred and made voluntary</a:t>
             </a:r>
           </a:p>
         </p:txBody>
@@ -9597,8 +9738,8 @@
         </p:nvSpPr>
         <p:spPr>
           <a:xfrm>
-            <a:off x="8668512" y="4953252"/>
-            <a:ext cx="2468880" cy="896112"/>
+            <a:off x="8636375" y="3918240"/>
+            <a:ext cx="2468880" cy="1067934"/>
           </a:xfrm>
           <a:prstGeom prst="roundRect">
             <a:avLst/>
@@ -9639,7 +9780,7 @@
               </a:defRPr>
             </a:pPr>
             <a:r>
-              <a:rPr>
+              <a:rPr dirty="0">
                 <a:latin typeface="Avenir Next" panose="020B0503020202020204" pitchFamily="34" charset="0"/>
               </a:rPr>
               <a:t>2025</a:t>
@@ -9655,10 +9796,10 @@
               </a:defRPr>
             </a:pPr>
             <a:r>
-              <a:rPr>
-                <a:latin typeface="Avenir Next" panose="020B0503020202020204" pitchFamily="34" charset="0"/>
-              </a:rPr>
-              <a:t>scope narrowed further even as the debt framework expands</a:t>
+              <a:rPr dirty="0">
+                <a:latin typeface="Avenir Next" panose="020B0503020202020204" pitchFamily="34" charset="0"/>
+              </a:rPr>
+              <a:t>scope narrowed further</a:t>
             </a:r>
           </a:p>
         </p:txBody>
@@ -9671,8 +9812,8 @@
         </p:nvSpPr>
         <p:spPr>
           <a:xfrm>
-            <a:off x="803750" y="1906551"/>
-            <a:ext cx="3292762" cy="2740563"/>
+            <a:off x="771613" y="1043361"/>
+            <a:ext cx="3292762" cy="2765038"/>
           </a:xfrm>
           <a:prstGeom prst="roundRect">
             <a:avLst/>
@@ -9719,7 +9860,7 @@
         </p:nvSpPr>
         <p:spPr>
           <a:xfrm>
-            <a:off x="972901" y="1986055"/>
+            <a:off x="777805" y="1050441"/>
             <a:ext cx="1389888" cy="400229"/>
           </a:xfrm>
           <a:prstGeom prst="roundRect">
@@ -9775,7 +9916,7 @@
         </p:nvSpPr>
         <p:spPr>
           <a:xfrm>
-            <a:off x="1009476" y="2470475"/>
+            <a:off x="977339" y="1607285"/>
             <a:ext cx="2906923" cy="2108269"/>
           </a:xfrm>
           <a:prstGeom prst="rect">
@@ -9845,8 +9986,8 @@
         </p:nvSpPr>
         <p:spPr>
           <a:xfrm>
-            <a:off x="4468675" y="1900148"/>
-            <a:ext cx="3267149" cy="2869841"/>
+            <a:off x="4436538" y="1036959"/>
+            <a:ext cx="3267149" cy="2197358"/>
           </a:xfrm>
           <a:prstGeom prst="roundRect">
             <a:avLst/>
@@ -9893,7 +10034,7 @@
         </p:nvSpPr>
         <p:spPr>
           <a:xfrm>
-            <a:off x="4612213" y="1986055"/>
+            <a:off x="4417117" y="1050441"/>
             <a:ext cx="1719072" cy="400229"/>
           </a:xfrm>
           <a:prstGeom prst="roundRect">
@@ -9952,8 +10093,8 @@
         </p:nvSpPr>
         <p:spPr>
           <a:xfrm>
-            <a:off x="4648789" y="2470475"/>
-            <a:ext cx="2921592" cy="1892826"/>
+            <a:off x="4616652" y="1607285"/>
+            <a:ext cx="2921592" cy="1423467"/>
           </a:xfrm>
           <a:prstGeom prst="rect">
             <a:avLst/>
@@ -9989,20 +10130,6 @@
           </a:p>
           <a:p>
             <a:pPr>
-              <a:spcAft>
-                <a:spcPts val="300"/>
-              </a:spcAft>
-              <a:defRPr sz="1000"/>
-            </a:pPr>
-            <a:r>
-              <a:rPr sz="1400" dirty="0">
-                <a:latin typeface="Avenir Next" panose="020B0503020202020204" pitchFamily="34" charset="0"/>
-              </a:rPr>
-              <a:t>• Rollout delays leave most ESG data effectively self-certified.</a:t>
-            </a:r>
-          </a:p>
-          <a:p>
-            <a:pPr>
               <a:defRPr sz="1000"/>
             </a:pPr>
             <a:r>
@@ -10022,8 +10149,8 @@
         </p:nvSpPr>
         <p:spPr>
           <a:xfrm>
-            <a:off x="8101583" y="1900149"/>
-            <a:ext cx="3279955" cy="2843082"/>
+            <a:off x="8069446" y="1036959"/>
+            <a:ext cx="3279955" cy="2745599"/>
           </a:xfrm>
           <a:prstGeom prst="roundRect">
             <a:avLst/>
@@ -10070,7 +10197,7 @@
         </p:nvSpPr>
         <p:spPr>
           <a:xfrm>
-            <a:off x="8251524" y="1986056"/>
+            <a:off x="8038322" y="1050442"/>
             <a:ext cx="1997376" cy="467266"/>
           </a:xfrm>
           <a:prstGeom prst="roundRect">
@@ -10138,8 +10265,8 @@
         </p:nvSpPr>
         <p:spPr>
           <a:xfrm>
-            <a:off x="8288099" y="2470475"/>
-            <a:ext cx="2968921" cy="2108269"/>
+            <a:off x="8255962" y="1607285"/>
+            <a:ext cx="2968921" cy="1892826"/>
           </a:xfrm>
           <a:prstGeom prst="rect">
             <a:avLst/>
@@ -10207,8 +10334,29 @@
               <a:rPr sz="1400" dirty="0">
                 <a:latin typeface="Avenir Next" panose="020B0503020202020204" pitchFamily="34" charset="0"/>
               </a:rPr>
-              <a:t>• Still lacks a dedicated ESG enforcement team or cross-checks with pollution data.</a:t>
-            </a:r>
+              <a:t>• S</a:t>
+            </a:r>
+            <a:r>
+              <a:rPr lang="en-US" sz="1400" dirty="0">
+                <a:latin typeface="Avenir Next" panose="020B0503020202020204" pitchFamily="34" charset="0"/>
+              </a:rPr>
+              <a:t>EBI s</a:t>
+            </a:r>
+            <a:r>
+              <a:rPr sz="1400" dirty="0">
+                <a:latin typeface="Avenir Next" panose="020B0503020202020204" pitchFamily="34" charset="0"/>
+              </a:rPr>
+              <a:t>till lacks a dedicated ESG enforcement team</a:t>
+            </a:r>
+            <a:r>
+              <a:rPr lang="en-US" sz="1400" dirty="0">
+                <a:latin typeface="Avenir Next" panose="020B0503020202020204" pitchFamily="34" charset="0"/>
+              </a:rPr>
+              <a:t>.</a:t>
+            </a:r>
+            <a:endParaRPr sz="1400" dirty="0">
+              <a:latin typeface="Avenir Next" panose="020B0503020202020204" pitchFamily="34" charset="0"/>
+            </a:endParaRPr>
           </a:p>
         </p:txBody>
       </p:sp>
@@ -10220,7 +10368,7 @@
         </p:nvSpPr>
         <p:spPr>
           <a:xfrm>
-            <a:off x="11336710" y="5407297"/>
+            <a:off x="11304573" y="4544107"/>
             <a:ext cx="184730" cy="261610"/>
           </a:xfrm>
           <a:prstGeom prst="rect">
@@ -22997,7 +23145,7 @@
         </p:nvSpPr>
         <p:spPr>
           <a:xfrm>
-            <a:off x="548639" y="384048"/>
+            <a:off x="548639" y="289919"/>
             <a:ext cx="9612791" cy="584775"/>
           </a:xfrm>
           <a:prstGeom prst="rect">
@@ -23060,8 +23208,8 @@
         </p:nvSpPr>
         <p:spPr>
           <a:xfrm>
-            <a:off x="783524" y="1614768"/>
-            <a:ext cx="3009045" cy="2574173"/>
+            <a:off x="783524" y="1345828"/>
+            <a:ext cx="3009045" cy="2688290"/>
           </a:xfrm>
           <a:prstGeom prst="roundRect">
             <a:avLst/>
@@ -23108,7 +23256,7 @@
         </p:nvSpPr>
         <p:spPr>
           <a:xfrm>
-            <a:off x="713336" y="1560889"/>
+            <a:off x="713336" y="1291949"/>
             <a:ext cx="2782636" cy="553533"/>
           </a:xfrm>
           <a:prstGeom prst="roundRect">
@@ -23173,7 +23321,7 @@
         </p:nvSpPr>
         <p:spPr>
           <a:xfrm>
-            <a:off x="987552" y="2268243"/>
+            <a:off x="987552" y="1970728"/>
             <a:ext cx="1893914" cy="461665"/>
           </a:xfrm>
           <a:prstGeom prst="rect">
@@ -23212,8 +23360,8 @@
         </p:nvSpPr>
         <p:spPr>
           <a:xfrm>
-            <a:off x="783524" y="2693225"/>
-            <a:ext cx="2712448" cy="1292662"/>
+            <a:off x="783524" y="2424285"/>
+            <a:ext cx="2712448" cy="1431161"/>
           </a:xfrm>
           <a:prstGeom prst="rect">
             <a:avLst/>
@@ -23226,7 +23374,7 @@
           </a:bodyPr>
           <a:lstStyle/>
           <a:p>
-            <a:pPr marL="285750" indent="-285750" algn="just">
+            <a:pPr marL="285750" indent="-285750">
               <a:buFont typeface="Arial" panose="020B0604020202020204" pitchFamily="34" charset="0"/>
               <a:buChar char="•"/>
               <a:defRPr sz="1150" b="0">
@@ -23250,7 +23398,20 @@
             </a:r>
           </a:p>
           <a:p>
-            <a:pPr marL="285750" indent="-285750" algn="just">
+            <a:pPr>
+              <a:defRPr sz="1150" b="0">
+                <a:solidFill>
+                  <a:srgbClr val="2A2A2A"/>
+                </a:solidFill>
+                <a:latin typeface="Avenir Next"/>
+              </a:defRPr>
+            </a:pPr>
+            <a:endParaRPr lang="en-US" sz="800" b="1" dirty="0">
+              <a:latin typeface="Avenir Next" panose="020B0503020202020204" pitchFamily="34" charset="0"/>
+            </a:endParaRPr>
+          </a:p>
+          <a:p>
+            <a:pPr marL="285750" indent="-285750">
               <a:buFont typeface="Arial" panose="020B0604020202020204" pitchFamily="34" charset="0"/>
               <a:buChar char="•"/>
               <a:defRPr sz="1150" b="0">
@@ -23295,8 +23456,8 @@
         </p:nvSpPr>
         <p:spPr>
           <a:xfrm>
-            <a:off x="4133087" y="1614768"/>
-            <a:ext cx="3127248" cy="3150618"/>
+            <a:off x="4133087" y="1345828"/>
+            <a:ext cx="3127248" cy="3365920"/>
           </a:xfrm>
           <a:prstGeom prst="roundRect">
             <a:avLst/>
@@ -23329,7 +23490,7 @@
           <a:lstStyle/>
           <a:p>
             <a:pPr algn="ctr"/>
-            <a:endParaRPr>
+            <a:endParaRPr dirty="0">
               <a:latin typeface="Avenir Next" panose="020B0503020202020204" pitchFamily="34" charset="0"/>
             </a:endParaRPr>
           </a:p>
@@ -23343,7 +23504,7 @@
         </p:nvSpPr>
         <p:spPr>
           <a:xfrm>
-            <a:off x="4068831" y="1548531"/>
+            <a:off x="4068831" y="1279591"/>
             <a:ext cx="2542032" cy="553189"/>
           </a:xfrm>
           <a:prstGeom prst="roundRect">
@@ -23419,8 +23580,8 @@
         </p:nvSpPr>
         <p:spPr>
           <a:xfrm>
-            <a:off x="4169811" y="2221724"/>
-            <a:ext cx="2945376" cy="2492990"/>
+            <a:off x="4169811" y="1952784"/>
+            <a:ext cx="3009972" cy="692497"/>
           </a:xfrm>
           <a:prstGeom prst="rect">
             <a:avLst/>
@@ -23433,9 +23594,7 @@
           </a:bodyPr>
           <a:lstStyle/>
           <a:p>
-            <a:pPr marL="285750" indent="-285750" algn="just">
-              <a:buFont typeface="Arial" panose="020B0604020202020204" pitchFamily="34" charset="0"/>
-              <a:buChar char="•"/>
+            <a:pPr>
               <a:defRPr sz="1150" b="1">
                 <a:solidFill>
                   <a:srgbClr val="2A2A2A"/>
@@ -23444,75 +23603,22 @@
               </a:defRPr>
             </a:pPr>
             <a:r>
+              <a:rPr lang="en-US" sz="1300" dirty="0">
+                <a:latin typeface="Avenir Next" panose="020B0503020202020204" pitchFamily="34" charset="0"/>
+              </a:rPr>
+              <a:t>We looked at two peer reviewed studies highlighting greenwashing of same Nifty 50 </a:t>
+            </a:r>
+            <a:r>
               <a:rPr sz="1300" dirty="0">
                 <a:latin typeface="Avenir Next" panose="020B0503020202020204" pitchFamily="34" charset="0"/>
               </a:rPr>
-              <a:t>54% of NSE-listed firms in one study engaged in greenwashing.</a:t>
-            </a:r>
-            <a:endParaRPr lang="en-US" sz="1300" dirty="0">
-              <a:latin typeface="Avenir Next" panose="020B0503020202020204" pitchFamily="34" charset="0"/>
-            </a:endParaRPr>
-          </a:p>
-          <a:p>
-            <a:pPr algn="just">
-              <a:defRPr sz="1150" b="1">
-                <a:solidFill>
-                  <a:srgbClr val="2A2A2A"/>
-                </a:solidFill>
-                <a:latin typeface="Avenir Next"/>
-              </a:defRPr>
-            </a:pPr>
-            <a:endParaRPr lang="en-US" sz="1050" dirty="0">
-              <a:latin typeface="Avenir Next" panose="020B0503020202020204" pitchFamily="34" charset="0"/>
-            </a:endParaRPr>
-          </a:p>
-          <a:p>
-            <a:pPr marL="285750" indent="-285750" algn="just">
-              <a:buFont typeface="Arial" panose="020B0604020202020204" pitchFamily="34" charset="0"/>
-              <a:buChar char="•"/>
-              <a:defRPr sz="1150" b="1">
-                <a:solidFill>
-                  <a:srgbClr val="2A2A2A"/>
-                </a:solidFill>
-                <a:latin typeface="Avenir Next"/>
-              </a:defRPr>
-            </a:pPr>
-            <a:r>
-              <a:rPr lang="en-IN" sz="1300" dirty="0">
-                <a:latin typeface="Avenir Next" panose="020B0503020202020204" pitchFamily="34" charset="0"/>
-              </a:rPr>
-              <a:t>47% of NIFTY 50 companies were flagged in another research.</a:t>
-            </a:r>
-          </a:p>
-          <a:p>
-            <a:pPr algn="just">
-              <a:defRPr sz="1150" b="1">
-                <a:solidFill>
-                  <a:srgbClr val="2A2A2A"/>
-                </a:solidFill>
-                <a:latin typeface="Avenir Next"/>
-              </a:defRPr>
-            </a:pPr>
-            <a:endParaRPr lang="en-IN" sz="1050" dirty="0">
-              <a:latin typeface="Avenir Next" panose="020B0503020202020204" pitchFamily="34" charset="0"/>
-            </a:endParaRPr>
-          </a:p>
-          <a:p>
-            <a:pPr marL="285750" indent="-285750" algn="just">
-              <a:buFont typeface="Arial" panose="020B0604020202020204" pitchFamily="34" charset="0"/>
-              <a:buChar char="•"/>
-              <a:defRPr sz="1150" b="1">
-                <a:solidFill>
-                  <a:srgbClr val="2A2A2A"/>
-                </a:solidFill>
-                <a:latin typeface="Avenir Next"/>
-              </a:defRPr>
-            </a:pPr>
-            <a:r>
-              <a:rPr lang="en-IN" sz="1300" dirty="0">
-                <a:latin typeface="Avenir Next" panose="020B0503020202020204" pitchFamily="34" charset="0"/>
-              </a:rPr>
-              <a:t>CRISIL also found nearly 80% of 586 companies scored below average or weak on ESG parameters.</a:t>
+              <a:t>firms</a:t>
+            </a:r>
+            <a:r>
+              <a:rPr lang="en-US" sz="1300" dirty="0">
+                <a:latin typeface="Avenir Next" panose="020B0503020202020204" pitchFamily="34" charset="0"/>
+              </a:rPr>
+              <a:t>:</a:t>
             </a:r>
           </a:p>
         </p:txBody>
@@ -23525,7 +23631,7 @@
         </p:nvSpPr>
         <p:spPr>
           <a:xfrm>
-            <a:off x="7588036" y="1614769"/>
+            <a:off x="7588036" y="1345829"/>
             <a:ext cx="4079708" cy="3352221"/>
           </a:xfrm>
           <a:prstGeom prst="roundRect">
@@ -23573,8 +23679,8 @@
         </p:nvSpPr>
         <p:spPr>
           <a:xfrm>
-            <a:off x="7496101" y="1560889"/>
-            <a:ext cx="1792223" cy="426572"/>
+            <a:off x="7473965" y="1291949"/>
+            <a:ext cx="3780707" cy="426572"/>
           </a:xfrm>
           <a:prstGeom prst="roundRect">
             <a:avLst/>
@@ -23613,14 +23719,38 @@
               </a:defRPr>
             </a:pPr>
             <a:r>
-              <a:rPr sz="1400" dirty="0">
+              <a:rPr lang="en-US" sz="1500" dirty="0">
                 <a:solidFill>
                   <a:schemeClr val="bg1"/>
                 </a:solidFill>
                 <a:latin typeface="Avenir Next" panose="020B0503020202020204" pitchFamily="34" charset="0"/>
               </a:rPr>
-              <a:t>ESG market scale</a:t>
-            </a:r>
+              <a:t>Market Scale of </a:t>
+            </a:r>
+            <a:r>
+              <a:rPr sz="1500" dirty="0">
+                <a:solidFill>
+                  <a:schemeClr val="bg1"/>
+                </a:solidFill>
+                <a:latin typeface="Avenir Next" panose="020B0503020202020204" pitchFamily="34" charset="0"/>
+              </a:rPr>
+              <a:t>ESG </a:t>
+            </a:r>
+            <a:r>
+              <a:rPr lang="en-US" sz="1500" dirty="0">
+                <a:solidFill>
+                  <a:schemeClr val="bg1"/>
+                </a:solidFill>
+                <a:latin typeface="Avenir Next" panose="020B0503020202020204" pitchFamily="34" charset="0"/>
+              </a:rPr>
+              <a:t>Equity and Debt</a:t>
+            </a:r>
+            <a:endParaRPr sz="1500" dirty="0">
+              <a:solidFill>
+                <a:schemeClr val="bg1"/>
+              </a:solidFill>
+              <a:latin typeface="Avenir Next" panose="020B0503020202020204" pitchFamily="34" charset="0"/>
+            </a:endParaRPr>
           </a:p>
         </p:txBody>
       </p:sp>
@@ -23632,8 +23762,8 @@
         </p:nvSpPr>
         <p:spPr>
           <a:xfrm>
-            <a:off x="7588036" y="2166020"/>
-            <a:ext cx="1591056" cy="400110"/>
+            <a:off x="7626136" y="1897080"/>
+            <a:ext cx="2134188" cy="400110"/>
           </a:xfrm>
           <a:prstGeom prst="rect">
             <a:avLst/>
@@ -23655,14 +23785,11 @@
               </a:defRPr>
             </a:pPr>
             <a:r>
-              <a:rPr sz="2000" dirty="0">
-                <a:latin typeface="Avenir Next" panose="020B0503020202020204" pitchFamily="34" charset="0"/>
-              </a:rPr>
-              <a:t>USD 1.2B</a:t>
-            </a:r>
-            <a:endParaRPr lang="en-US" sz="2000" dirty="0">
-              <a:latin typeface="Avenir Next" panose="020B0503020202020204" pitchFamily="34" charset="0"/>
-            </a:endParaRPr>
+              <a:rPr lang="en-IN" sz="2000" dirty="0">
+                <a:latin typeface="Avenir Next" panose="020B0503020202020204" pitchFamily="34" charset="0"/>
+              </a:rPr>
+              <a:t>ESG fund AUM</a:t>
+            </a:r>
           </a:p>
         </p:txBody>
       </p:sp>
@@ -23674,8 +23801,8 @@
         </p:nvSpPr>
         <p:spPr>
           <a:xfrm>
-            <a:off x="7719478" y="2510668"/>
-            <a:ext cx="1591056" cy="830997"/>
+            <a:off x="7699865" y="2254266"/>
+            <a:ext cx="1859039" cy="1015663"/>
           </a:xfrm>
           <a:prstGeom prst="rect">
             <a:avLst/>
@@ -23688,7 +23815,7 @@
           </a:bodyPr>
           <a:lstStyle/>
           <a:p>
-            <a:pPr algn="just">
+            <a:pPr>
               <a:defRPr sz="1050" b="0">
                 <a:solidFill>
                   <a:srgbClr val="2A2A2A"/>
@@ -23697,11 +23824,24 @@
               </a:defRPr>
             </a:pPr>
             <a:r>
-              <a:rPr sz="1200" dirty="0">
-                <a:latin typeface="Avenir Next" panose="020B0503020202020204" pitchFamily="34" charset="0"/>
-              </a:rPr>
-              <a:t>ESG fund assets by March 2024, up from USD 331M in 2020.</a:t>
-            </a:r>
+              <a:rPr lang="en-US" sz="1200" dirty="0">
+                <a:latin typeface="Avenir Next" panose="020B0503020202020204" pitchFamily="34" charset="0"/>
+              </a:rPr>
+              <a:t>Grew from US$ 331 million in January 2020 to US$ 1.2 billion by March 2024</a:t>
+            </a:r>
+          </a:p>
+          <a:p>
+            <a:pPr>
+              <a:defRPr sz="1050" b="0">
+                <a:solidFill>
+                  <a:srgbClr val="2A2A2A"/>
+                </a:solidFill>
+                <a:latin typeface="Avenir Next"/>
+              </a:defRPr>
+            </a:pPr>
+            <a:endParaRPr sz="1200" dirty="0">
+              <a:latin typeface="Avenir Next" panose="020B0503020202020204" pitchFamily="34" charset="0"/>
+            </a:endParaRPr>
           </a:p>
         </p:txBody>
       </p:sp>
@@ -23713,8 +23853,8 @@
         </p:nvSpPr>
         <p:spPr>
           <a:xfrm>
-            <a:off x="9400032" y="2166020"/>
-            <a:ext cx="1792224" cy="400110"/>
+            <a:off x="9707819" y="1897080"/>
+            <a:ext cx="1551672" cy="400110"/>
           </a:xfrm>
           <a:prstGeom prst="rect">
             <a:avLst/>
@@ -23736,14 +23876,11 @@
               </a:defRPr>
             </a:pPr>
             <a:r>
-              <a:rPr sz="2000" dirty="0">
-                <a:latin typeface="Avenir Next" panose="020B0503020202020204" pitchFamily="34" charset="0"/>
-              </a:rPr>
-              <a:t>USD 55.9B</a:t>
-            </a:r>
-            <a:endParaRPr lang="en-US" sz="2000" dirty="0">
-              <a:latin typeface="Avenir Next" panose="020B0503020202020204" pitchFamily="34" charset="0"/>
-            </a:endParaRPr>
+              <a:rPr lang="en-US" sz="2000" dirty="0">
+                <a:latin typeface="Avenir Next" panose="020B0503020202020204" pitchFamily="34" charset="0"/>
+              </a:rPr>
+              <a:t>ESG Debt</a:t>
+            </a:r>
           </a:p>
         </p:txBody>
       </p:sp>
@@ -23755,8 +23892,8 @@
         </p:nvSpPr>
         <p:spPr>
           <a:xfrm>
-            <a:off x="9586796" y="2528674"/>
-            <a:ext cx="1591056" cy="830997"/>
+            <a:off x="9838484" y="2259734"/>
+            <a:ext cx="1634637" cy="830997"/>
           </a:xfrm>
           <a:prstGeom prst="rect">
             <a:avLst/>
@@ -23769,7 +23906,7 @@
           </a:bodyPr>
           <a:lstStyle/>
           <a:p>
-            <a:pPr algn="just">
+            <a:pPr>
               <a:defRPr sz="1050" b="0">
                 <a:solidFill>
                   <a:srgbClr val="2A2A2A"/>
@@ -23778,10 +23915,10 @@
               </a:defRPr>
             </a:pPr>
             <a:r>
-              <a:rPr sz="1200" dirty="0">
-                <a:latin typeface="Avenir Next" panose="020B0503020202020204" pitchFamily="34" charset="0"/>
-              </a:rPr>
-              <a:t>Cumulative green, social, and sustainability-linked debt by Dec 2024.</a:t>
+              <a:rPr lang="en-US" sz="1200" dirty="0">
+                <a:latin typeface="Avenir Next" panose="020B0503020202020204" pitchFamily="34" charset="0"/>
+              </a:rPr>
+              <a:t>Reached US$ 56 billion by Dec. 2024, a 186% increase since 2021</a:t>
             </a:r>
           </a:p>
         </p:txBody>
@@ -23794,7 +23931,7 @@
         </p:nvSpPr>
         <p:spPr>
           <a:xfrm>
-            <a:off x="7702107" y="3461824"/>
+            <a:off x="7702107" y="3192884"/>
             <a:ext cx="3657600" cy="1431161"/>
           </a:xfrm>
           <a:prstGeom prst="rect">
@@ -23808,7 +23945,7 @@
           </a:bodyPr>
           <a:lstStyle/>
           <a:p>
-            <a:pPr marL="285750" indent="-285750" algn="just">
+            <a:pPr marL="285750" indent="-285750">
               <a:buFont typeface="Arial" panose="020B0604020202020204" pitchFamily="34" charset="0"/>
               <a:buChar char="•"/>
               <a:defRPr sz="1070" b="1">
@@ -23828,20 +23965,47 @@
                 </a:solidFill>
                 <a:latin typeface="Avenir Next" panose="020B0503020202020204" pitchFamily="34" charset="0"/>
               </a:rPr>
-              <a:t>India is already the fourth-largest emerging-market source of sustainable debt globally, </a:t>
-            </a:r>
-            <a:endParaRPr lang="en-US" sz="1300" dirty="0">
-              <a:solidFill>
-                <a:schemeClr val="tx1">
-                  <a:lumMod val="95000"/>
-                  <a:lumOff val="5000"/>
-                </a:schemeClr>
-              </a:solidFill>
-              <a:latin typeface="Avenir Next" panose="020B0503020202020204" pitchFamily="34" charset="0"/>
-            </a:endParaRPr>
-          </a:p>
-          <a:p>
-            <a:pPr algn="just">
+              <a:t>India is already the fourth-largest emerging</a:t>
+            </a:r>
+            <a:r>
+              <a:rPr lang="en-US" sz="1300" dirty="0">
+                <a:solidFill>
+                  <a:schemeClr val="tx1">
+                    <a:lumMod val="95000"/>
+                    <a:lumOff val="5000"/>
+                  </a:schemeClr>
+                </a:solidFill>
+                <a:latin typeface="Avenir Next" panose="020B0503020202020204" pitchFamily="34" charset="0"/>
+              </a:rPr>
+              <a:t> </a:t>
+            </a:r>
+            <a:r>
+              <a:rPr sz="1300" dirty="0">
+                <a:solidFill>
+                  <a:schemeClr val="tx1">
+                    <a:lumMod val="95000"/>
+                    <a:lumOff val="5000"/>
+                  </a:schemeClr>
+                </a:solidFill>
+                <a:latin typeface="Avenir Next" panose="020B0503020202020204" pitchFamily="34" charset="0"/>
+              </a:rPr>
+              <a:t>market source of sustainable debt globally</a:t>
+            </a:r>
+            <a:r>
+              <a:rPr lang="en-US" sz="1300" dirty="0">
+                <a:solidFill>
+                  <a:schemeClr val="tx1">
+                    <a:lumMod val="95000"/>
+                    <a:lumOff val="5000"/>
+                  </a:schemeClr>
+                </a:solidFill>
+                <a:latin typeface="Avenir Next" panose="020B0503020202020204" pitchFamily="34" charset="0"/>
+              </a:rPr>
+              <a:t>.</a:t>
+            </a:r>
+          </a:p>
+          <a:p>
+            <a:pPr>
               <a:defRPr sz="1070" b="1">
                 <a:solidFill>
                   <a:srgbClr val="A23E2A"/>
@@ -23860,7 +24024,7 @@
             </a:endParaRPr>
           </a:p>
           <a:p>
-            <a:pPr marL="285750" indent="-285750" algn="just">
+            <a:pPr marL="285750" indent="-285750">
               <a:buFont typeface="Arial" panose="020B0604020202020204" pitchFamily="34" charset="0"/>
               <a:buChar char="•"/>
               <a:defRPr sz="1070" b="1">
@@ -23871,7 +24035,7 @@
               </a:defRPr>
             </a:pPr>
             <a:r>
-              <a:rPr lang="en-US" sz="1300" dirty="0">
+              <a:rPr sz="1300" dirty="0">
                 <a:solidFill>
                   <a:schemeClr val="tx1">
                     <a:lumMod val="95000"/>
@@ -23880,10 +24044,10 @@
                 </a:solidFill>
                 <a:latin typeface="Avenir Next" panose="020B0503020202020204" pitchFamily="34" charset="0"/>
               </a:rPr>
-              <a:t>And</a:t>
-            </a:r>
-            <a:r>
-              <a:rPr sz="1300" dirty="0">
+              <a:t>RBI</a:t>
+            </a:r>
+            <a:r>
+              <a:rPr lang="en-US" sz="1300" dirty="0">
                 <a:solidFill>
                   <a:schemeClr val="tx1">
                     <a:lumMod val="95000"/>
@@ -23892,10 +24056,10 @@
                 </a:solidFill>
                 <a:latin typeface="Avenir Next" panose="020B0503020202020204" pitchFamily="34" charset="0"/>
               </a:rPr>
-              <a:t> RBI research finds ESG </a:t>
-            </a:r>
-            <a:r>
-              <a:rPr lang="en-US" sz="1300" dirty="0">
+              <a:t>’s 2023</a:t>
+            </a:r>
+            <a:r>
+              <a:rPr sz="1300" dirty="0">
                 <a:solidFill>
                   <a:schemeClr val="tx1">
                     <a:lumMod val="95000"/>
@@ -23904,10 +24068,10 @@
                 </a:solidFill>
                 <a:latin typeface="Avenir Next" panose="020B0503020202020204" pitchFamily="34" charset="0"/>
               </a:rPr>
-              <a:t>claim based stocks have returns</a:t>
-            </a:r>
-            <a:r>
-              <a:rPr sz="1300" dirty="0">
+              <a:t> research</a:t>
+            </a:r>
+            <a:r>
+              <a:rPr lang="en-US" sz="1300" dirty="0">
                 <a:solidFill>
                   <a:schemeClr val="tx1">
                     <a:lumMod val="95000"/>
@@ -23916,179 +24080,91 @@
                 </a:solidFill>
                 <a:latin typeface="Avenir Next" panose="020B0503020202020204" pitchFamily="34" charset="0"/>
               </a:rPr>
-              <a:t> above market predictions.</a:t>
-            </a:r>
-          </a:p>
-        </p:txBody>
-      </p:sp>
-      <p:sp>
-        <p:nvSpPr>
-          <p:cNvPr id="25" name="Rounded Rectangle 24"/>
-          <p:cNvSpPr/>
-          <p:nvPr/>
-        </p:nvSpPr>
-        <p:spPr>
-          <a:xfrm>
-            <a:off x="770037" y="4909763"/>
-            <a:ext cx="4931936" cy="1553965"/>
-          </a:xfrm>
-          <a:prstGeom prst="roundRect">
-            <a:avLst/>
-          </a:prstGeom>
-          <a:solidFill>
-            <a:srgbClr val="FFFDF8"/>
-          </a:solidFill>
-          <a:ln w="12700">
-            <a:solidFill>
-              <a:srgbClr val="D8D1C6"/>
-            </a:solidFill>
-          </a:ln>
-        </p:spPr>
-        <p:style>
-          <a:lnRef idx="1">
-            <a:schemeClr val="accent1"/>
-          </a:lnRef>
-          <a:fillRef idx="3">
-            <a:schemeClr val="accent1"/>
-          </a:fillRef>
-          <a:effectRef idx="2">
-            <a:schemeClr val="accent1"/>
-          </a:effectRef>
-          <a:fontRef idx="minor">
-            <a:schemeClr val="lt1"/>
-          </a:fontRef>
-        </p:style>
-        <p:txBody>
-          <a:bodyPr rtlCol="0" anchor="ctr"/>
-          <a:lstStyle/>
-          <a:p>
-            <a:pPr algn="ctr"/>
-            <a:endParaRPr>
-              <a:latin typeface="Avenir Next" panose="020B0503020202020204" pitchFamily="34" charset="0"/>
-            </a:endParaRPr>
-          </a:p>
-        </p:txBody>
-      </p:sp>
-      <p:sp>
-        <p:nvSpPr>
-          <p:cNvPr id="26" name="Rounded Rectangle 25"/>
-          <p:cNvSpPr/>
-          <p:nvPr/>
-        </p:nvSpPr>
-        <p:spPr>
-          <a:xfrm>
-            <a:off x="713336" y="4865699"/>
-            <a:ext cx="3459291" cy="487833"/>
-          </a:xfrm>
-          <a:prstGeom prst="roundRect">
-            <a:avLst/>
-          </a:prstGeom>
-          <a:solidFill>
-            <a:srgbClr val="A23E2A"/>
-          </a:solidFill>
-          <a:ln>
-            <a:noFill/>
-          </a:ln>
-        </p:spPr>
-        <p:style>
-          <a:lnRef idx="1">
-            <a:schemeClr val="accent1"/>
-          </a:lnRef>
-          <a:fillRef idx="3">
-            <a:schemeClr val="accent1"/>
-          </a:fillRef>
-          <a:effectRef idx="2">
-            <a:schemeClr val="accent1"/>
-          </a:effectRef>
-          <a:fontRef idx="minor">
-            <a:schemeClr val="lt1"/>
-          </a:fontRef>
-        </p:style>
-        <p:txBody>
-          <a:bodyPr lIns="91440" tIns="45720" rIns="91440" bIns="45720" rtlCol="0" anchor="ctr"/>
-          <a:lstStyle/>
-          <a:p>
-            <a:pPr algn="ctr">
-              <a:defRPr sz="1000" b="1">
-                <a:solidFill>
-                  <a:srgbClr val="FFFFFF"/>
-                </a:solidFill>
-                <a:latin typeface="Avenir Next"/>
-              </a:defRPr>
-            </a:pPr>
-            <a:r>
-              <a:rPr sz="1400" dirty="0">
-                <a:latin typeface="Avenir Next" panose="020B0503020202020204" pitchFamily="34" charset="0"/>
-              </a:rPr>
-              <a:t>Compliance </a:t>
-            </a:r>
-            <a:r>
-              <a:rPr lang="en-US" sz="1400" dirty="0">
-                <a:latin typeface="Avenir Next" panose="020B0503020202020204" pitchFamily="34" charset="0"/>
-              </a:rPr>
-              <a:t>infrastructure in India lacks substance</a:t>
-            </a:r>
-            <a:endParaRPr sz="1400" dirty="0">
-              <a:latin typeface="Avenir Next" panose="020B0503020202020204" pitchFamily="34" charset="0"/>
-            </a:endParaRPr>
-          </a:p>
-        </p:txBody>
-      </p:sp>
-      <p:sp>
-        <p:nvSpPr>
-          <p:cNvPr id="27" name="TextBox 26"/>
-          <p:cNvSpPr txBox="1"/>
-          <p:nvPr/>
-        </p:nvSpPr>
-        <p:spPr>
-          <a:xfrm>
-            <a:off x="770037" y="5417225"/>
-            <a:ext cx="4918449" cy="892552"/>
-          </a:xfrm>
-          <a:prstGeom prst="rect">
-            <a:avLst/>
-          </a:prstGeom>
-          <a:noFill/>
-        </p:spPr>
-        <p:txBody>
-          <a:bodyPr wrap="square" lIns="91440" tIns="45720" rIns="91440" bIns="45720" anchor="t">
-            <a:spAutoFit/>
-          </a:bodyPr>
-          <a:lstStyle/>
-          <a:p>
-            <a:pPr marL="171450" indent="-171450" algn="just">
-              <a:buFont typeface="Arial" panose="020B0604020202020204" pitchFamily="34" charset="0"/>
-              <a:buChar char="•"/>
-              <a:defRPr sz="1100" b="0">
-                <a:solidFill>
-                  <a:srgbClr val="2A2A2A"/>
-                </a:solidFill>
-                <a:latin typeface="Avenir Next"/>
-              </a:defRPr>
-            </a:pPr>
-            <a:r>
-              <a:rPr sz="1300" b="1" dirty="0">
-                <a:latin typeface="Avenir Next" panose="020B0503020202020204" pitchFamily="34" charset="0"/>
-              </a:rPr>
-              <a:t>CPCB uncovered about 600,000 fake EPR certificates in 2024, </a:t>
-            </a:r>
-            <a:r>
-              <a:rPr lang="en-US" sz="1300" b="1" dirty="0">
-                <a:latin typeface="Avenir Next" panose="020B0503020202020204" pitchFamily="34" charset="0"/>
-              </a:rPr>
-              <a:t>and NGT took </a:t>
-            </a:r>
-            <a:r>
-              <a:rPr lang="en-US" sz="1300" b="1" dirty="0" err="1">
-                <a:latin typeface="Avenir Next" panose="020B0503020202020204" pitchFamily="34" charset="0"/>
-              </a:rPr>
-              <a:t>suo</a:t>
-            </a:r>
-            <a:r>
-              <a:rPr lang="en-US" sz="1300" b="1" dirty="0">
-                <a:latin typeface="Avenir Next" panose="020B0503020202020204" pitchFamily="34" charset="0"/>
-              </a:rPr>
-              <a:t> moto cognizance of it; showing that the verification deficit reaches the infrastructure of environmental compliance itself.</a:t>
+              <a:t> study</a:t>
+            </a:r>
+            <a:r>
+              <a:rPr sz="1300" dirty="0">
+                <a:solidFill>
+                  <a:schemeClr val="tx1">
+                    <a:lumMod val="95000"/>
+                    <a:lumOff val="5000"/>
+                  </a:schemeClr>
+                </a:solidFill>
+                <a:latin typeface="Avenir Next" panose="020B0503020202020204" pitchFamily="34" charset="0"/>
+              </a:rPr>
+              <a:t> </a:t>
+            </a:r>
+            <a:r>
+              <a:rPr lang="en-US" sz="1300" dirty="0">
+                <a:solidFill>
+                  <a:schemeClr val="tx1">
+                    <a:lumMod val="95000"/>
+                    <a:lumOff val="5000"/>
+                  </a:schemeClr>
+                </a:solidFill>
+                <a:latin typeface="Avenir Next" panose="020B0503020202020204" pitchFamily="34" charset="0"/>
+              </a:rPr>
+              <a:t>found that </a:t>
+            </a:r>
+            <a:r>
+              <a:rPr sz="1300" dirty="0">
+                <a:solidFill>
+                  <a:schemeClr val="tx1">
+                    <a:lumMod val="95000"/>
+                    <a:lumOff val="5000"/>
+                  </a:schemeClr>
+                </a:solidFill>
+                <a:latin typeface="Avenir Next" panose="020B0503020202020204" pitchFamily="34" charset="0"/>
+              </a:rPr>
+              <a:t>ESG </a:t>
+            </a:r>
+            <a:r>
+              <a:rPr lang="en-US" sz="1300" dirty="0">
+                <a:solidFill>
+                  <a:schemeClr val="tx1">
+                    <a:lumMod val="95000"/>
+                    <a:lumOff val="5000"/>
+                  </a:schemeClr>
+                </a:solidFill>
+                <a:latin typeface="Avenir Next" panose="020B0503020202020204" pitchFamily="34" charset="0"/>
+              </a:rPr>
+              <a:t>based stocks have higher returns</a:t>
+            </a:r>
+            <a:r>
+              <a:rPr sz="1300" dirty="0">
+                <a:solidFill>
+                  <a:schemeClr val="tx1">
+                    <a:lumMod val="95000"/>
+                    <a:lumOff val="5000"/>
+                  </a:schemeClr>
+                </a:solidFill>
+                <a:latin typeface="Avenir Next" panose="020B0503020202020204" pitchFamily="34" charset="0"/>
+              </a:rPr>
+              <a:t> </a:t>
+            </a:r>
+            <a:r>
+              <a:rPr lang="en-US" sz="1300" dirty="0">
+                <a:solidFill>
+                  <a:schemeClr val="tx1">
+                    <a:lumMod val="95000"/>
+                    <a:lumOff val="5000"/>
+                  </a:schemeClr>
+                </a:solidFill>
+                <a:latin typeface="Avenir Next" panose="020B0503020202020204" pitchFamily="34" charset="0"/>
+              </a:rPr>
+              <a:t>compared to </a:t>
+            </a:r>
+            <a:r>
+              <a:rPr sz="1300" dirty="0">
+                <a:solidFill>
+                  <a:schemeClr val="tx1">
+                    <a:lumMod val="95000"/>
+                    <a:lumOff val="5000"/>
+                  </a:schemeClr>
+                </a:solidFill>
+                <a:latin typeface="Avenir Next" panose="020B0503020202020204" pitchFamily="34" charset="0"/>
+              </a:rPr>
+              <a:t>market.</a:t>
             </a:r>
           </a:p>
         </p:txBody>
@@ -24101,8 +24177,8 @@
         </p:nvSpPr>
         <p:spPr>
           <a:xfrm>
-            <a:off x="5925312" y="5390971"/>
-            <a:ext cx="5742432" cy="993388"/>
+            <a:off x="1515292" y="5390971"/>
+            <a:ext cx="9013372" cy="993388"/>
           </a:xfrm>
           <a:prstGeom prst="roundRect">
             <a:avLst/>
@@ -24149,8 +24225,8 @@
         </p:nvSpPr>
         <p:spPr>
           <a:xfrm>
-            <a:off x="5987728" y="5464473"/>
-            <a:ext cx="5266944" cy="861774"/>
+            <a:off x="987552" y="5546637"/>
+            <a:ext cx="10267120" cy="615553"/>
           </a:xfrm>
           <a:prstGeom prst="rect">
             <a:avLst/>
@@ -24221,7 +24297,7 @@
         <p:spPr>
           <a:xfrm>
             <a:off x="643329" y="6557535"/>
-            <a:ext cx="8112927" cy="307777"/>
+            <a:ext cx="8981177" cy="307777"/>
           </a:xfrm>
           <a:prstGeom prst="rect">
             <a:avLst/>
@@ -24251,7 +24327,7 @@
                   </a:schemeClr>
                 </a:solidFill>
               </a:rPr>
-              <a:t>Source base: </a:t>
+              <a:t>Source: </a:t>
             </a:r>
             <a:r>
               <a:rPr lang="en-US" sz="1400" dirty="0">
@@ -24262,7 +24338,7 @@
                   </a:schemeClr>
                 </a:solidFill>
               </a:rPr>
-              <a:t>ASCI</a:t>
+              <a:t>Section 2.5 of Thesis. ASCI</a:t>
             </a:r>
             <a:r>
               <a:rPr sz="1400" dirty="0">
@@ -24284,7 +24360,7 @@
                   </a:schemeClr>
                 </a:solidFill>
               </a:rPr>
-              <a:t> CRISIL,</a:t>
+              <a:t> CRISIL, </a:t>
             </a:r>
             <a:r>
               <a:rPr sz="1400" dirty="0">
@@ -24295,7 +24371,7 @@
                   </a:schemeClr>
                 </a:solidFill>
               </a:rPr>
-              <a:t> CPCB figures</a:t>
+              <a:t> figures</a:t>
             </a:r>
             <a:r>
               <a:rPr lang="en-US" sz="1400" dirty="0">
@@ -24336,7 +24412,7 @@
         </p:nvSpPr>
         <p:spPr>
           <a:xfrm>
-            <a:off x="695718" y="1039482"/>
+            <a:off x="695718" y="864671"/>
             <a:ext cx="5464894" cy="338554"/>
           </a:xfrm>
           <a:prstGeom prst="rect">
@@ -24366,6 +24442,147 @@
                 <a:latin typeface="Avenir Next" panose="020B0503020202020204" pitchFamily="34" charset="0"/>
               </a:rPr>
               <a:t>Based on available data from authority-based sources</a:t>
+            </a:r>
+          </a:p>
+        </p:txBody>
+      </p:sp>
+      <p:sp>
+        <p:nvSpPr>
+          <p:cNvPr id="6" name="TextBox 5">
+            <a:extLst>
+              <a:ext uri="{FF2B5EF4-FFF2-40B4-BE49-F238E27FC236}">
+                <a16:creationId xmlns:a16="http://schemas.microsoft.com/office/drawing/2014/main" id="{5E4D6379-FB21-ECB8-430A-DD00BE2CA29F}"/>
+              </a:ext>
+            </a:extLst>
+          </p:cNvPr>
+          <p:cNvSpPr txBox="1"/>
+          <p:nvPr/>
+        </p:nvSpPr>
+        <p:spPr>
+          <a:xfrm>
+            <a:off x="4169811" y="3832835"/>
+            <a:ext cx="3204595" cy="692497"/>
+          </a:xfrm>
+          <a:prstGeom prst="rect">
+            <a:avLst/>
+          </a:prstGeom>
+          <a:noFill/>
+        </p:spPr>
+        <p:txBody>
+          <a:bodyPr wrap="square">
+            <a:spAutoFit/>
+          </a:bodyPr>
+          <a:lstStyle/>
+          <a:p>
+            <a:pPr>
+              <a:defRPr sz="1150" b="1">
+                <a:solidFill>
+                  <a:srgbClr val="2A2A2A"/>
+                </a:solidFill>
+                <a:latin typeface="Avenir Next"/>
+              </a:defRPr>
+            </a:pPr>
+            <a:r>
+              <a:rPr lang="en-IN" sz="1300" dirty="0">
+                <a:latin typeface="Avenir Next" panose="020B0503020202020204" pitchFamily="34" charset="0"/>
+              </a:rPr>
+              <a:t>A CRISIL Report in 2022, discovered that nearly 80% of 586 companies scored weak on ESG parameters.</a:t>
+            </a:r>
+          </a:p>
+        </p:txBody>
+      </p:sp>
+      <p:sp>
+        <p:nvSpPr>
+          <p:cNvPr id="12" name="TextBox 11">
+            <a:extLst>
+              <a:ext uri="{FF2B5EF4-FFF2-40B4-BE49-F238E27FC236}">
+                <a16:creationId xmlns:a16="http://schemas.microsoft.com/office/drawing/2014/main" id="{03976511-B45A-D9C6-7CF1-E7DF1798451D}"/>
+              </a:ext>
+            </a:extLst>
+          </p:cNvPr>
+          <p:cNvSpPr txBox="1"/>
+          <p:nvPr/>
+        </p:nvSpPr>
+        <p:spPr>
+          <a:xfrm>
+            <a:off x="4429684" y="2912847"/>
+            <a:ext cx="1153453" cy="830997"/>
+          </a:xfrm>
+          <a:prstGeom prst="rect">
+            <a:avLst/>
+          </a:prstGeom>
+          <a:noFill/>
+        </p:spPr>
+        <p:txBody>
+          <a:bodyPr wrap="square">
+            <a:spAutoFit/>
+          </a:bodyPr>
+          <a:lstStyle/>
+          <a:p>
+            <a:pPr>
+              <a:defRPr sz="1150" b="1">
+                <a:solidFill>
+                  <a:srgbClr val="2A2A2A"/>
+                </a:solidFill>
+                <a:latin typeface="Avenir Next"/>
+              </a:defRPr>
+            </a:pPr>
+            <a:r>
+              <a:rPr lang="en-US" sz="1600" dirty="0">
+                <a:solidFill>
+                  <a:srgbClr val="2A6334"/>
+                </a:solidFill>
+                <a:latin typeface="Avenir Next" panose="020B0503020202020204" pitchFamily="34" charset="0"/>
+              </a:rPr>
+              <a:t>54% of Nifty 50 (2022)</a:t>
+            </a:r>
+          </a:p>
+        </p:txBody>
+      </p:sp>
+      <p:sp>
+        <p:nvSpPr>
+          <p:cNvPr id="31" name="TextBox 30">
+            <a:extLst>
+              <a:ext uri="{FF2B5EF4-FFF2-40B4-BE49-F238E27FC236}">
+                <a16:creationId xmlns:a16="http://schemas.microsoft.com/office/drawing/2014/main" id="{13EBFC7C-4502-5C27-2F3A-49DBCBD283E7}"/>
+              </a:ext>
+            </a:extLst>
+          </p:cNvPr>
+          <p:cNvSpPr txBox="1"/>
+          <p:nvPr/>
+        </p:nvSpPr>
+        <p:spPr>
+          <a:xfrm>
+            <a:off x="5891174" y="2918695"/>
+            <a:ext cx="1020207" cy="830997"/>
+          </a:xfrm>
+          <a:prstGeom prst="rect">
+            <a:avLst/>
+          </a:prstGeom>
+          <a:noFill/>
+        </p:spPr>
+        <p:txBody>
+          <a:bodyPr wrap="square">
+            <a:spAutoFit/>
+          </a:bodyPr>
+          <a:lstStyle/>
+          <a:p>
+            <a:pPr>
+              <a:defRPr sz="1150" b="1">
+                <a:solidFill>
+                  <a:srgbClr val="2A2A2A"/>
+                </a:solidFill>
+                <a:latin typeface="Avenir Next"/>
+              </a:defRPr>
+            </a:pPr>
+            <a:r>
+              <a:rPr lang="en-US" sz="1600" dirty="0">
+                <a:solidFill>
+                  <a:srgbClr val="2A6334"/>
+                </a:solidFill>
+                <a:latin typeface="Avenir Next" panose="020B0503020202020204" pitchFamily="34" charset="0"/>
+              </a:rPr>
+              <a:t>47% of Nifty 50 (2025)</a:t>
             </a:r>
           </a:p>
         </p:txBody>
@@ -24663,7 +24880,7 @@
               <a:rPr lang="en-US" sz="1350" dirty="0">
                 <a:latin typeface="Avenir Next" panose="020B0503020202020204" pitchFamily="34" charset="0"/>
               </a:rPr>
-              <a:t>The available discussion on the enforcement of section 166(2) of Companies Act remains thin. Beyond Companies Act also, there is lack of doctrinal studies evaluating why regulators rarely bring deterrent enforcement actions against greenwashing.</a:t>
+              <a:t>The available discussion on the enforcement of section 166(2) of Companies Act remains thin. Beyond Companies Act also, there is lack of doctrinal studies evaluating why SEBI rarely brings deterrent enforcement action against greenwashing.</a:t>
             </a:r>
           </a:p>
           <a:p>
@@ -24788,10 +25005,16 @@
               </a:defRPr>
             </a:pPr>
             <a:r>
+              <a:rPr lang="en-US" sz="1600" dirty="0">
+                <a:latin typeface="Avenir Next" panose="020B0503020202020204" pitchFamily="34" charset="0"/>
+              </a:rPr>
+              <a:t>MY</a:t>
+            </a:r>
+            <a:r>
               <a:rPr sz="1600" dirty="0">
                 <a:latin typeface="Avenir Next" panose="020B0503020202020204" pitchFamily="34" charset="0"/>
               </a:rPr>
-              <a:t>THIS STUDY ADDRESSES THESE GAPS BY:</a:t>
+              <a:t> STUDY ADDRESSES THESE GAPS BY:</a:t>
             </a:r>
           </a:p>
           <a:p>
@@ -24802,7 +25025,19 @@
               <a:rPr sz="1400" dirty="0">
                 <a:latin typeface="Avenir Next" panose="020B0503020202020204" pitchFamily="34" charset="0"/>
               </a:rPr>
-              <a:t>Treating greenwashing as a corporate governance failure at the intersection of company law, securities disclosure, and consumer protection</a:t>
+              <a:t>Treating greenwashing as a corporate governance failure at the intersection of company law, securities disclosure</a:t>
+            </a:r>
+            <a:r>
+              <a:rPr lang="en-US" sz="1400" dirty="0">
+                <a:latin typeface="Avenir Next" panose="020B0503020202020204" pitchFamily="34" charset="0"/>
+              </a:rPr>
+              <a:t> </a:t>
+            </a:r>
+            <a:r>
+              <a:rPr sz="1400" dirty="0">
+                <a:latin typeface="Avenir Next" panose="020B0503020202020204" pitchFamily="34" charset="0"/>
+              </a:rPr>
+              <a:t>and consumer protection</a:t>
             </a:r>
             <a:r>
               <a:rPr lang="en-US" sz="1400" dirty="0">
@@ -27479,13 +27714,22 @@
               </a:defRPr>
             </a:pPr>
             <a:r>
+              <a:rPr lang="en-US" sz="3200" b="1" dirty="0">
+                <a:solidFill>
+                  <a:srgbClr val="173F35"/>
+                </a:solidFill>
+                <a:latin typeface="Avenir Next Demi Bold"/>
+              </a:rPr>
+              <a:t>How </a:t>
+            </a:r>
+            <a:r>
               <a:rPr sz="3200" b="1" dirty="0">
                 <a:solidFill>
                   <a:srgbClr val="173F35"/>
                 </a:solidFill>
                 <a:latin typeface="Avenir Next Demi Bold"/>
               </a:rPr>
-              <a:t>How Greenwashing evolved and why it matters</a:t>
+              <a:t>Greenwashing </a:t>
             </a:r>
             <a:r>
               <a:rPr lang="en-US" sz="3200" b="1" dirty="0">
@@ -27494,7 +27738,25 @@
                 </a:solidFill>
                 <a:latin typeface="Avenir Next Demi Bold"/>
               </a:rPr>
-              <a:t> </a:t>
+              <a:t>has </a:t>
+            </a:r>
+            <a:r>
+              <a:rPr sz="3200" b="1" dirty="0">
+                <a:solidFill>
+                  <a:srgbClr val="173F35"/>
+                </a:solidFill>
+                <a:latin typeface="Avenir Next Demi Bold"/>
+              </a:rPr>
+              <a:t>evolved and </a:t>
+            </a:r>
+            <a:r>
+              <a:rPr lang="en-US" sz="3200" b="1" dirty="0">
+                <a:solidFill>
+                  <a:srgbClr val="173F35"/>
+                </a:solidFill>
+                <a:latin typeface="Avenir Next Demi Bold"/>
+              </a:rPr>
+              <a:t>its consequences</a:t>
             </a:r>
             <a:r>
               <a:rPr sz="3200" b="1" dirty="0">
@@ -27937,7 +28199,7 @@
                 </a:solidFill>
                 <a:latin typeface="Avenir Next"/>
               </a:rPr>
-              <a:t>2. HOW IT HAS GROWN</a:t>
+              <a:t>2. HOW IT HAS EVOLVED</a:t>
             </a:r>
           </a:p>
         </p:txBody>

</xml_diff>

<commit_message>
refactor: update presentation narration and slides to align with thesis structure and legal analysis frameworks
</commit_message>
<xml_diff>
--- a/Thesis Defence Presentation Final.pptx
+++ b/Thesis Defence Presentation Final.pptx
@@ -238,7 +238,7 @@
           <a:p>
             <a:fld id="{5D16D8C7-7ACE-0E43-ADC6-5E8A68AC397B}" type="datetimeFigureOut">
               <a:rPr lang="en-US" smtClean="0"/>
-              <a:t>8/19/26</a:t>
+              <a:t>8/20/26</a:t>
             </a:fld>
             <a:endParaRPr lang="en-US"/>
           </a:p>
@@ -1021,7 +1021,7 @@
           <a:p>
             <a:fld id="{5BCAD085-E8A6-8845-BD4E-CB4CCA059FC4}" type="datetimeFigureOut">
               <a:rPr lang="en-US" smtClean="0"/>
-              <a:t>8/19/26</a:t>
+              <a:t>8/20/26</a:t>
             </a:fld>
             <a:endParaRPr lang="en-US"/>
           </a:p>
@@ -1189,7 +1189,7 @@
           <a:p>
             <a:fld id="{5BCAD085-E8A6-8845-BD4E-CB4CCA059FC4}" type="datetimeFigureOut">
               <a:rPr lang="en-US" smtClean="0"/>
-              <a:t>8/19/26</a:t>
+              <a:t>8/20/26</a:t>
             </a:fld>
             <a:endParaRPr lang="en-US"/>
           </a:p>
@@ -1367,7 +1367,7 @@
           <a:p>
             <a:fld id="{5BCAD085-E8A6-8845-BD4E-CB4CCA059FC4}" type="datetimeFigureOut">
               <a:rPr lang="en-US" smtClean="0"/>
-              <a:t>8/19/26</a:t>
+              <a:t>8/20/26</a:t>
             </a:fld>
             <a:endParaRPr lang="en-US"/>
           </a:p>
@@ -1535,7 +1535,7 @@
           <a:p>
             <a:fld id="{5BCAD085-E8A6-8845-BD4E-CB4CCA059FC4}" type="datetimeFigureOut">
               <a:rPr lang="en-US" smtClean="0"/>
-              <a:t>8/19/26</a:t>
+              <a:t>8/20/26</a:t>
             </a:fld>
             <a:endParaRPr lang="en-US"/>
           </a:p>
@@ -1780,7 +1780,7 @@
           <a:p>
             <a:fld id="{5BCAD085-E8A6-8845-BD4E-CB4CCA059FC4}" type="datetimeFigureOut">
               <a:rPr lang="en-US" smtClean="0"/>
-              <a:t>8/19/26</a:t>
+              <a:t>8/20/26</a:t>
             </a:fld>
             <a:endParaRPr lang="en-US"/>
           </a:p>
@@ -2065,7 +2065,7 @@
           <a:p>
             <a:fld id="{5BCAD085-E8A6-8845-BD4E-CB4CCA059FC4}" type="datetimeFigureOut">
               <a:rPr lang="en-US" smtClean="0"/>
-              <a:t>8/19/26</a:t>
+              <a:t>8/20/26</a:t>
             </a:fld>
             <a:endParaRPr lang="en-US"/>
           </a:p>
@@ -2484,7 +2484,7 @@
           <a:p>
             <a:fld id="{5BCAD085-E8A6-8845-BD4E-CB4CCA059FC4}" type="datetimeFigureOut">
               <a:rPr lang="en-US" smtClean="0"/>
-              <a:t>8/19/26</a:t>
+              <a:t>8/20/26</a:t>
             </a:fld>
             <a:endParaRPr lang="en-US"/>
           </a:p>
@@ -2601,7 +2601,7 @@
           <a:p>
             <a:fld id="{5BCAD085-E8A6-8845-BD4E-CB4CCA059FC4}" type="datetimeFigureOut">
               <a:rPr lang="en-US" smtClean="0"/>
-              <a:t>8/19/26</a:t>
+              <a:t>8/20/26</a:t>
             </a:fld>
             <a:endParaRPr lang="en-US"/>
           </a:p>
@@ -2696,7 +2696,7 @@
           <a:p>
             <a:fld id="{5BCAD085-E8A6-8845-BD4E-CB4CCA059FC4}" type="datetimeFigureOut">
               <a:rPr lang="en-US" smtClean="0"/>
-              <a:t>8/19/26</a:t>
+              <a:t>8/20/26</a:t>
             </a:fld>
             <a:endParaRPr lang="en-US"/>
           </a:p>
@@ -2971,7 +2971,7 @@
           <a:p>
             <a:fld id="{5BCAD085-E8A6-8845-BD4E-CB4CCA059FC4}" type="datetimeFigureOut">
               <a:rPr lang="en-US" smtClean="0"/>
-              <a:t>8/19/26</a:t>
+              <a:t>8/20/26</a:t>
             </a:fld>
             <a:endParaRPr lang="en-US"/>
           </a:p>
@@ -3223,7 +3223,7 @@
           <a:p>
             <a:fld id="{5BCAD085-E8A6-8845-BD4E-CB4CCA059FC4}" type="datetimeFigureOut">
               <a:rPr lang="en-US" smtClean="0"/>
-              <a:t>8/19/26</a:t>
+              <a:t>8/20/26</a:t>
             </a:fld>
             <a:endParaRPr lang="en-US"/>
           </a:p>
@@ -3434,7 +3434,7 @@
           <a:p>
             <a:fld id="{5BCAD085-E8A6-8845-BD4E-CB4CCA059FC4}" type="datetimeFigureOut">
               <a:rPr lang="en-US" smtClean="0"/>
-              <a:t>8/19/26</a:t>
+              <a:t>8/20/26</a:t>
             </a:fld>
             <a:endParaRPr lang="en-US"/>
           </a:p>
@@ -6486,7 +6486,7 @@
         <p:spPr>
           <a:xfrm>
             <a:off x="646996" y="1054085"/>
-            <a:ext cx="6678424" cy="4627128"/>
+            <a:ext cx="6678424" cy="3876261"/>
           </a:xfrm>
           <a:prstGeom prst="roundRect">
             <a:avLst/>
@@ -6633,8 +6633,8 @@
         </p:nvSpPr>
         <p:spPr>
           <a:xfrm>
-            <a:off x="1012755" y="1344127"/>
-            <a:ext cx="6089793" cy="4337085"/>
+            <a:off x="913899" y="1405912"/>
+            <a:ext cx="6089793" cy="3159839"/>
           </a:xfrm>
           <a:prstGeom prst="rect">
             <a:avLst/>
@@ -6789,6 +6789,21 @@
               </a:rPr>
               <a:t>Intervenes only after deceptive claims enter the market.</a:t>
             </a:r>
+            <a:r>
+              <a:rPr lang="en-US" sz="1600" dirty="0">
+                <a:solidFill>
+                  <a:srgbClr val="2D2D2D"/>
+                </a:solidFill>
+                <a:latin typeface="Avenir Next" panose="020B0503020202020204" pitchFamily="34" charset="0"/>
+              </a:rPr>
+              <a:t> Rather than proactive systemic regulation.</a:t>
+            </a:r>
+            <a:endParaRPr lang="en-IN" sz="1600" dirty="0">
+              <a:solidFill>
+                <a:srgbClr val="2D2D2D"/>
+              </a:solidFill>
+              <a:latin typeface="Avenir Next" panose="020B0503020202020204" pitchFamily="34" charset="0"/>
+            </a:endParaRPr>
           </a:p>
           <a:p>
             <a:pPr>
@@ -6800,23 +6815,29 @@
               </a:spcAft>
             </a:pPr>
             <a:r>
-              <a:rPr sz="1600" b="1" dirty="0">
+              <a:rPr lang="en-IN" sz="1600" b="1" dirty="0">
                 <a:solidFill>
                   <a:srgbClr val="22704E"/>
                 </a:solidFill>
                 <a:latin typeface="Avenir Next" panose="020B0503020202020204" pitchFamily="34" charset="0"/>
               </a:rPr>
-              <a:t>2. Individual Harm Focus: </a:t>
-            </a:r>
-            <a:r>
-              <a:rPr sz="1600" dirty="0">
+              <a:t>2. No Upstream Boardroom Mandates: </a:t>
+            </a:r>
+            <a:r>
+              <a:rPr lang="en-IN" sz="1600" dirty="0">
                 <a:solidFill>
                   <a:srgbClr val="2D2D2D"/>
                 </a:solidFill>
                 <a:latin typeface="Avenir Next" panose="020B0503020202020204" pitchFamily="34" charset="0"/>
               </a:rPr>
-              <a:t>Treats greenwashing as single consumer disputes, not systemic governance failure.</a:t>
-            </a:r>
+              <a:t>Regulates ad copy, does not guide internal corporate systems or decision-making.</a:t>
+            </a:r>
+            <a:endParaRPr sz="1600" dirty="0">
+              <a:solidFill>
+                <a:srgbClr val="2D2D2D"/>
+              </a:solidFill>
+              <a:latin typeface="Avenir Next" panose="020B0503020202020204" pitchFamily="34" charset="0"/>
+            </a:endParaRPr>
           </a:p>
           <a:p>
             <a:pPr>
@@ -6828,13 +6849,22 @@
               </a:spcAft>
             </a:pPr>
             <a:r>
+              <a:rPr lang="en-US" sz="1600" b="1" dirty="0">
+                <a:solidFill>
+                  <a:srgbClr val="22704E"/>
+                </a:solidFill>
+                <a:latin typeface="Avenir Next" panose="020B0503020202020204" pitchFamily="34" charset="0"/>
+              </a:rPr>
+              <a:t>3</a:t>
+            </a:r>
+            <a:r>
               <a:rPr sz="1600" b="1" dirty="0">
                 <a:solidFill>
                   <a:srgbClr val="22704E"/>
                 </a:solidFill>
                 <a:latin typeface="Avenir Next" panose="020B0503020202020204" pitchFamily="34" charset="0"/>
               </a:rPr>
-              <a:t>3. Information Asymmetry: </a:t>
+              <a:t>. Individual Harm Focus: </a:t>
             </a:r>
             <a:r>
               <a:rPr sz="1600" dirty="0">
@@ -6843,8 +6873,50 @@
                 </a:solidFill>
                 <a:latin typeface="Avenir Next" panose="020B0503020202020204" pitchFamily="34" charset="0"/>
               </a:rPr>
-              <a:t>Burden of proof falls on ordinary consumers who lack technical data.</a:t>
-            </a:r>
+              <a:t>Treats greenwashing </a:t>
+            </a:r>
+            <a:r>
+              <a:rPr lang="en-US" sz="1600" dirty="0">
+                <a:solidFill>
+                  <a:srgbClr val="2D2D2D"/>
+                </a:solidFill>
+                <a:latin typeface="Avenir Next" panose="020B0503020202020204" pitchFamily="34" charset="0"/>
+              </a:rPr>
+              <a:t>merely </a:t>
+            </a:r>
+            <a:r>
+              <a:rPr sz="1600" dirty="0">
+                <a:solidFill>
+                  <a:srgbClr val="2D2D2D"/>
+                </a:solidFill>
+                <a:latin typeface="Avenir Next" panose="020B0503020202020204" pitchFamily="34" charset="0"/>
+              </a:rPr>
+              <a:t>consumer </a:t>
+            </a:r>
+            <a:r>
+              <a:rPr lang="en-US" sz="1600" dirty="0">
+                <a:solidFill>
+                  <a:srgbClr val="2D2D2D"/>
+                </a:solidFill>
+                <a:latin typeface="Avenir Next" panose="020B0503020202020204" pitchFamily="34" charset="0"/>
+              </a:rPr>
+              <a:t>harm</a:t>
+            </a:r>
+            <a:r>
+              <a:rPr sz="1600" dirty="0">
+                <a:solidFill>
+                  <a:srgbClr val="2D2D2D"/>
+                </a:solidFill>
+                <a:latin typeface="Avenir Next" panose="020B0503020202020204" pitchFamily="34" charset="0"/>
+              </a:rPr>
+              <a:t>, not systemic governance failure.</a:t>
+            </a:r>
+            <a:endParaRPr lang="en-US" sz="1600" dirty="0">
+              <a:solidFill>
+                <a:srgbClr val="2D2D2D"/>
+              </a:solidFill>
+              <a:latin typeface="Avenir Next" panose="020B0503020202020204" pitchFamily="34" charset="0"/>
+            </a:endParaRPr>
           </a:p>
           <a:p>
             <a:pPr>
@@ -6856,13 +6928,31 @@
               </a:spcAft>
             </a:pPr>
             <a:r>
+              <a:rPr lang="en-US" sz="1600" b="1" dirty="0">
+                <a:solidFill>
+                  <a:srgbClr val="22704E"/>
+                </a:solidFill>
+                <a:latin typeface="Avenir Next" panose="020B0503020202020204" pitchFamily="34" charset="0"/>
+              </a:rPr>
+              <a:t>4. </a:t>
+            </a:r>
+            <a:r>
               <a:rPr sz="1600" b="1" dirty="0">
                 <a:solidFill>
                   <a:srgbClr val="22704E"/>
                 </a:solidFill>
                 <a:latin typeface="Avenir Next" panose="020B0503020202020204" pitchFamily="34" charset="0"/>
               </a:rPr>
-              <a:t>4. No Boardroom Mandates: </a:t>
+              <a:t>Puffery Loophole: </a:t>
+            </a:r>
+            <a:r>
+              <a:rPr lang="en-US" sz="1600" dirty="0">
+                <a:solidFill>
+                  <a:srgbClr val="2D2D2D"/>
+                </a:solidFill>
+                <a:latin typeface="Avenir Next" panose="020B0503020202020204" pitchFamily="34" charset="0"/>
+              </a:rPr>
+              <a:t>Scope for </a:t>
             </a:r>
             <a:r>
               <a:rPr sz="1600" dirty="0">
@@ -6871,7 +6961,25 @@
                 </a:solidFill>
                 <a:latin typeface="Avenir Next" panose="020B0503020202020204" pitchFamily="34" charset="0"/>
               </a:rPr>
-              <a:t>Regulates ad copy, not internal corporate systems or decision-making.</a:t>
+              <a:t>exaggerations </a:t>
+            </a:r>
+            <a:r>
+              <a:rPr lang="en-US" sz="1600" dirty="0">
+                <a:solidFill>
+                  <a:srgbClr val="2D2D2D"/>
+                </a:solidFill>
+                <a:latin typeface="Avenir Next" panose="020B0503020202020204" pitchFamily="34" charset="0"/>
+              </a:rPr>
+              <a:t>creates </a:t>
+            </a:r>
+            <a:r>
+              <a:rPr sz="1600" dirty="0">
+                <a:solidFill>
+                  <a:srgbClr val="2D2D2D"/>
+                </a:solidFill>
+                <a:latin typeface="Avenir Next" panose="020B0503020202020204" pitchFamily="34" charset="0"/>
+              </a:rPr>
+              <a:t>loopholes for vague green buzzwords.</a:t>
             </a:r>
           </a:p>
           <a:p>
@@ -6884,13 +6992,58 @@
               </a:spcAft>
             </a:pPr>
             <a:r>
+              <a:rPr lang="en-US" sz="1600" b="1" dirty="0">
+                <a:solidFill>
+                  <a:srgbClr val="22704E"/>
+                </a:solidFill>
+                <a:latin typeface="Avenir Next" panose="020B0503020202020204" pitchFamily="34" charset="0"/>
+              </a:rPr>
+              <a:t>5</a:t>
+            </a:r>
+            <a:r>
               <a:rPr sz="1600" b="1" dirty="0">
                 <a:solidFill>
                   <a:srgbClr val="22704E"/>
                 </a:solidFill>
                 <a:latin typeface="Avenir Next" panose="020B0503020202020204" pitchFamily="34" charset="0"/>
               </a:rPr>
-              <a:t>5. The Puffery Loophole: </a:t>
+              <a:t>. </a:t>
+            </a:r>
+            <a:r>
+              <a:rPr lang="en-US" sz="1600" b="1" dirty="0">
+                <a:solidFill>
+                  <a:srgbClr val="22704E"/>
+                </a:solidFill>
+                <a:latin typeface="Avenir Next" panose="020B0503020202020204" pitchFamily="34" charset="0"/>
+              </a:rPr>
+              <a:t>Fixed cap penalties</a:t>
+            </a:r>
+            <a:r>
+              <a:rPr sz="1600" b="1" dirty="0">
+                <a:solidFill>
+                  <a:srgbClr val="22704E"/>
+                </a:solidFill>
+                <a:latin typeface="Avenir Next" panose="020B0503020202020204" pitchFamily="34" charset="0"/>
+              </a:rPr>
+              <a:t>: </a:t>
+            </a:r>
+            <a:r>
+              <a:rPr lang="en-IN" sz="1600" dirty="0">
+                <a:solidFill>
+                  <a:srgbClr val="2D2D2D"/>
+                </a:solidFill>
+                <a:latin typeface="Avenir Next" panose="020B0503020202020204" pitchFamily="34" charset="0"/>
+              </a:rPr>
+              <a:t>Not turnover linked</a:t>
+            </a:r>
+            <a:r>
+              <a:rPr sz="1600" dirty="0">
+                <a:solidFill>
+                  <a:srgbClr val="2D2D2D"/>
+                </a:solidFill>
+                <a:latin typeface="Avenir Next" panose="020B0503020202020204" pitchFamily="34" charset="0"/>
+              </a:rPr>
+              <a:t>.</a:t>
             </a:r>
             <a:r>
               <a:rPr lang="en-US" sz="1600" dirty="0">
@@ -6899,102 +7052,12 @@
                 </a:solidFill>
                 <a:latin typeface="Avenir Next" panose="020B0503020202020204" pitchFamily="34" charset="0"/>
               </a:rPr>
-              <a:t>Allowing scope for </a:t>
-            </a:r>
-            <a:r>
-              <a:rPr sz="1600" dirty="0">
-                <a:solidFill>
-                  <a:srgbClr val="2D2D2D"/>
-                </a:solidFill>
-                <a:latin typeface="Avenir Next" panose="020B0503020202020204" pitchFamily="34" charset="0"/>
-              </a:rPr>
-              <a:t>exaggerations creates loopholes for vague green buzzwords.</a:t>
-            </a:r>
-          </a:p>
-          <a:p>
-            <a:pPr>
-              <a:spcBef>
-                <a:spcPts val="200"/>
-              </a:spcBef>
-              <a:spcAft>
-                <a:spcPts val="300"/>
-              </a:spcAft>
-            </a:pPr>
-            <a:r>
-              <a:rPr sz="1600" b="1" dirty="0">
-                <a:solidFill>
-                  <a:srgbClr val="22704E"/>
-                </a:solidFill>
-                <a:latin typeface="Avenir Next" panose="020B0503020202020204" pitchFamily="34" charset="0"/>
-              </a:rPr>
-              <a:t>6. Entity-Only Fines: </a:t>
-            </a:r>
-            <a:r>
-              <a:rPr sz="1600" dirty="0">
-                <a:solidFill>
-                  <a:srgbClr val="2D2D2D"/>
-                </a:solidFill>
-                <a:latin typeface="Avenir Next" panose="020B0503020202020204" pitchFamily="34" charset="0"/>
-              </a:rPr>
-              <a:t>Fines the company budget rather than holding directors accountable.</a:t>
+              <a:t> Limited deterrence for big companies.</a:t>
             </a:r>
             <a:endParaRPr lang="en-US" sz="1600" dirty="0">
-              <a:solidFill>
-                <a:srgbClr val="2D2D2D"/>
-              </a:solidFill>
               <a:latin typeface="Avenir Next" panose="020B0503020202020204" pitchFamily="34" charset="0"/>
-            </a:endParaRPr>
-          </a:p>
-          <a:p>
-            <a:pPr>
-              <a:spcBef>
-                <a:spcPts val="200"/>
-              </a:spcBef>
-              <a:spcAft>
-                <a:spcPts val="300"/>
-              </a:spcAft>
-            </a:pPr>
-            <a:r>
-              <a:rPr lang="en-IN" sz="1600" b="1" dirty="0">
-                <a:solidFill>
-                  <a:srgbClr val="22704E"/>
-                </a:solidFill>
-                <a:latin typeface="Avenir Next" panose="020B0503020202020204" pitchFamily="34" charset="0"/>
-              </a:rPr>
-              <a:t>7. </a:t>
-            </a:r>
-            <a:r>
-              <a:rPr lang="en-US" sz="1600" b="1" dirty="0">
-                <a:solidFill>
-                  <a:srgbClr val="22704E"/>
-                </a:solidFill>
-                <a:latin typeface="Avenir Next" panose="020B0503020202020204" pitchFamily="34" charset="0"/>
-              </a:rPr>
-              <a:t>Guidelines only: </a:t>
-            </a:r>
-            <a:r>
-              <a:rPr lang="en-US" sz="1600" dirty="0">
-                <a:latin typeface="Avenir Next" panose="020B0503020202020204" pitchFamily="34" charset="0"/>
-                <a:ea typeface="Calibri"/>
-                <a:cs typeface="Calibri"/>
-              </a:rPr>
-              <a:t>may not stand legal test.</a:t>
-            </a:r>
-          </a:p>
-          <a:p>
-            <a:pPr>
-              <a:spcBef>
-                <a:spcPts val="200"/>
-              </a:spcBef>
-              <a:spcAft>
-                <a:spcPts val="300"/>
-              </a:spcAft>
-            </a:pPr>
-            <a:endParaRPr sz="1600" dirty="0">
-              <a:solidFill>
-                <a:srgbClr val="2D2D2D"/>
-              </a:solidFill>
-              <a:latin typeface="Avenir Next" panose="020B0503020202020204" pitchFamily="34" charset="0"/>
+              <a:ea typeface="Calibri"/>
+              <a:cs typeface="Calibri"/>
             </a:endParaRPr>
           </a:p>
         </p:txBody>
@@ -7013,7 +7076,7 @@
         </p:nvSpPr>
         <p:spPr>
           <a:xfrm>
-            <a:off x="646996" y="6042920"/>
+            <a:off x="646996" y="5845210"/>
             <a:ext cx="11073384" cy="584775"/>
           </a:xfrm>
           <a:prstGeom prst="roundRect">

</xml_diff>

<commit_message>
refactor: update presentation narration with refined institutional and legal reform recommendations and add backup file
</commit_message>
<xml_diff>
--- a/Thesis Defence Presentation Final.pptx
+++ b/Thesis Defence Presentation Final.pptx
@@ -18918,17 +18918,14 @@
           <a:lstStyle/>
           <a:p>
             <a:pPr algn="l">
-              <a:defRPr sz="1250" b="1">
+              <a:defRPr sz="1500" b="1">
                 <a:solidFill>
                   <a:srgbClr val="12402D"/>
                 </a:solidFill>
-                <a:latin typeface="Avenir Next Demi Bold"/>
-              </a:defRPr>
-            </a:pPr>
-            <a:r>
-              <a:rPr sz="1600">
-                <a:latin typeface="Avenir Next" panose="020B0503020202020204" pitchFamily="34" charset="0"/>
-              </a:rPr>
+                <a:latin typeface="Avenir Next"/>
+              </a:defRPr>
+            </a:pPr>
+            <a:r>
               <a:t>1. Institutional Integration</a:t>
             </a:r>
           </a:p>
@@ -18957,7 +18954,7 @@
           <a:lstStyle/>
           <a:p>
             <a:pPr algn="l">
-              <a:defRPr sz="1150" b="0">
+              <a:defRPr sz="1350" b="0">
                 <a:solidFill>
                   <a:srgbClr val="2D2D2D"/>
                 </a:solidFill>
@@ -18965,10 +18962,7 @@
               </a:defRPr>
             </a:pPr>
             <a:r>
-              <a:rPr sz="1600">
-                <a:latin typeface="Avenir Next" panose="020B0503020202020204" pitchFamily="34" charset="0"/>
-              </a:rPr>
-              <a:t>Establish a standing inter-regulatory council linking MCA, SEBI, CCPA, MoEFCC, CPCB, and BIS.</a:t>
+              <a:t>Establish a permanent inter-regulatory council linking MCA, SEBI, CCPA, MoEFCC, CPCB, BIS, and FSSAI.</a:t>
             </a:r>
           </a:p>
         </p:txBody>
@@ -19090,17 +19084,14 @@
           <a:lstStyle/>
           <a:p>
             <a:pPr algn="l">
-              <a:defRPr sz="1250" b="1">
+              <a:defRPr sz="1500" b="1">
                 <a:solidFill>
                   <a:srgbClr val="12402D"/>
                 </a:solidFill>
-                <a:latin typeface="Avenir Next Demi Bold"/>
-              </a:defRPr>
-            </a:pPr>
-            <a:r>
-              <a:rPr sz="1600">
-                <a:latin typeface="Avenir Next" panose="020B0503020202020204" pitchFamily="34" charset="0"/>
-              </a:rPr>
+                <a:latin typeface="Avenir Next"/>
+              </a:defRPr>
+            </a:pPr>
+            <a:r>
               <a:t>2. Lead Regulator Model</a:t>
             </a:r>
           </a:p>
@@ -19129,7 +19120,7 @@
           <a:lstStyle/>
           <a:p>
             <a:pPr algn="l">
-              <a:defRPr sz="1150" b="0">
+              <a:defRPr sz="1350" b="0">
                 <a:solidFill>
                   <a:srgbClr val="2D2D2D"/>
                 </a:solidFill>
@@ -19137,10 +19128,7 @@
               </a:defRPr>
             </a:pPr>
             <a:r>
-              <a:rPr sz="1600" dirty="0">
-                <a:latin typeface="Avenir Next" panose="020B0503020202020204" pitchFamily="34" charset="0"/>
-              </a:rPr>
-              <a:t>Designate a coordinating agency with mandatory cross-referral and shared evidence protocols.</a:t>
+              <a:t>Designate a coordinating agency with mandatory cross-referral, shared evidence protocols, and harmonised definitions.</a:t>
             </a:r>
           </a:p>
         </p:txBody>
@@ -19262,17 +19250,14 @@
           <a:lstStyle/>
           <a:p>
             <a:pPr algn="l">
-              <a:defRPr sz="1250" b="1">
+              <a:defRPr sz="1500" b="1">
                 <a:solidFill>
                   <a:srgbClr val="12402D"/>
                 </a:solidFill>
-                <a:latin typeface="Avenir Next Demi Bold"/>
-              </a:defRPr>
-            </a:pPr>
-            <a:r>
-              <a:rPr sz="1600">
-                <a:latin typeface="Avenir Next" panose="020B0503020202020204" pitchFamily="34" charset="0"/>
-              </a:rPr>
+                <a:latin typeface="Avenir Next"/>
+              </a:defRPr>
+            </a:pPr>
+            <a:r>
               <a:t>3. Standardised Verification</a:t>
             </a:r>
           </a:p>
@@ -19301,7 +19286,7 @@
           <a:lstStyle/>
           <a:p>
             <a:pPr algn="l">
-              <a:defRPr sz="1150" b="0">
+              <a:defRPr sz="1350" b="0">
                 <a:solidFill>
                   <a:srgbClr val="2D2D2D"/>
                 </a:solidFill>
@@ -19309,10 +19294,7 @@
               </a:defRPr>
             </a:pPr>
             <a:r>
-              <a:rPr sz="1600">
-                <a:latin typeface="Avenir Next" panose="020B0503020202020204" pitchFamily="34" charset="0"/>
-              </a:rPr>
-              <a:t>Mandate lifecycle verification (LCA), product-category benchmarks, and accredited verifiers.</a:t>
+              <a:t>Mandate ex-ante substantiation, lifecycle assessment (LCA), product-category rules (PCRs), and accredited verifiers.</a:t>
             </a:r>
           </a:p>
         </p:txBody>
@@ -19434,17 +19416,14 @@
           <a:lstStyle/>
           <a:p>
             <a:pPr algn="l">
-              <a:defRPr sz="1250" b="1">
+              <a:defRPr sz="1500" b="1">
                 <a:solidFill>
                   <a:srgbClr val="12402D"/>
                 </a:solidFill>
-                <a:latin typeface="Avenir Next Demi Bold"/>
-              </a:defRPr>
-            </a:pPr>
-            <a:r>
-              <a:rPr sz="1600">
-                <a:latin typeface="Avenir Next" panose="020B0503020202020204" pitchFamily="34" charset="0"/>
-              </a:rPr>
+                <a:latin typeface="Avenir Next"/>
+              </a:defRPr>
+            </a:pPr>
+            <a:r>
               <a:t>4. Proactive Surveillance</a:t>
             </a:r>
           </a:p>
@@ -19473,7 +19452,7 @@
           <a:lstStyle/>
           <a:p>
             <a:pPr algn="l">
-              <a:defRPr sz="1150" b="0">
+              <a:defRPr sz="1350" b="0">
                 <a:solidFill>
                   <a:srgbClr val="2D2D2D"/>
                 </a:solidFill>
@@ -19481,10 +19460,7 @@
               </a:defRPr>
             </a:pPr>
             <a:r>
-              <a:rPr sz="1600">
-                <a:latin typeface="Avenir Next" panose="020B0503020202020204" pitchFamily="34" charset="0"/>
-              </a:rPr>
-              <a:t>Run regular market sweeps in high-risk sectors; cross-check ESG claims against pollution records.</a:t>
+              <a:t>Conduct routine market sweeps; cross-check corporate sustainability claims against CPCB/SPCB pollution records.</a:t>
             </a:r>
           </a:p>
         </p:txBody>
@@ -19606,17 +19582,14 @@
           <a:lstStyle/>
           <a:p>
             <a:pPr algn="l">
-              <a:defRPr sz="1250" b="1">
+              <a:defRPr sz="1500" b="1">
                 <a:solidFill>
                   <a:srgbClr val="12402D"/>
                 </a:solidFill>
-                <a:latin typeface="Avenir Next Demi Bold"/>
-              </a:defRPr>
-            </a:pPr>
-            <a:r>
-              <a:rPr sz="1600">
-                <a:latin typeface="Avenir Next" panose="020B0503020202020204" pitchFamily="34" charset="0"/>
-              </a:rPr>
+                <a:latin typeface="Avenir Next"/>
+              </a:defRPr>
+            </a:pPr>
+            <a:r>
               <a:t>5. Enforcement Capacity</a:t>
             </a:r>
           </a:p>
@@ -19645,7 +19618,7 @@
           <a:lstStyle/>
           <a:p>
             <a:pPr algn="l">
-              <a:defRPr sz="1150" b="0">
+              <a:defRPr sz="1350" b="0">
                 <a:solidFill>
                   <a:srgbClr val="2D2D2D"/>
                 </a:solidFill>
@@ -19653,10 +19626,7 @@
               </a:defRPr>
             </a:pPr>
             <a:r>
-              <a:rPr sz="1600">
-                <a:latin typeface="Avenir Next" panose="020B0503020202020204" pitchFamily="34" charset="0"/>
-              </a:rPr>
-              <a:t>Build shared in-house expertise in carbon accounting, GHG scopes, and ESG assurance.</a:t>
+              <a:t>Build dedicated in-house ESG surveillance capacity and shared expertise in carbon accounting and GHG assurance.</a:t>
             </a:r>
           </a:p>
         </p:txBody>
@@ -20079,8 +20049,8 @@
         </p:nvSpPr>
         <p:spPr>
           <a:xfrm>
-            <a:off x="762418" y="2169567"/>
-            <a:ext cx="3255264" cy="2882840"/>
+            <a:off x="762418" y="2061088"/>
+            <a:ext cx="3255264" cy="3171124"/>
           </a:xfrm>
           <a:prstGeom prst="rect">
             <a:avLst/>
@@ -20094,8 +20064,11 @@
           <a:lstStyle/>
           <a:p>
             <a:pPr algn="l">
+              <a:lnSpc>
+                <a:spcPct val="105000"/>
+              </a:lnSpc>
               <a:spcAft>
-                <a:spcPts val="800"/>
+                <a:spcPts val="600"/>
               </a:spcAft>
               <a:defRPr sz="1150" b="0">
                 <a:solidFill>
@@ -20105,43 +20078,82 @@
               </a:defRPr>
             </a:pPr>
             <a:r>
-              <a:rPr sz="1400" dirty="0">
-                <a:latin typeface="Avenir Next" panose="020B0503020202020204" pitchFamily="34" charset="0"/>
-              </a:rPr>
-              <a:t>• Turnover-Linked Penalties: Amend Section 166(7) so fines scale with company revenue rather than fixed ₹1–5L caps.</a:t>
+              <a:rPr sz="1100" b="1">
+                <a:latin typeface="Avenir Next"/>
+              </a:rPr>
+              <a:t>• Turnover Penalties &amp; Disqualification: </a:t>
+            </a:r>
+            <a:r>
+              <a:rPr sz="1100" b="0">
+                <a:latin typeface="Avenir Next"/>
+              </a:rPr>
+              <a:t>Amend Sec 166(7) to penalise misleading claims up to 1% turnover (min ₹5 Cr) + up to 3-year Director Disqualification under Sec 164(2)(b).</a:t>
             </a:r>
           </a:p>
           <a:p>
             <a:pPr>
+              <a:lnSpc>
+                <a:spcPct val="105000"/>
+              </a:lnSpc>
               <a:spcAft>
-                <a:spcPts val="800"/>
+                <a:spcPts val="600"/>
               </a:spcAft>
-              <a:defRPr sz="1150">
-                <a:solidFill>
-                  <a:srgbClr val="2D2D2D"/>
-                </a:solidFill>
-              </a:defRPr>
-            </a:pPr>
-            <a:r>
-              <a:rPr sz="1400" dirty="0">
-                <a:latin typeface="Avenir Next" panose="020B0503020202020204" pitchFamily="34" charset="0"/>
-              </a:rPr>
-              <a:t>• Expanded Standing: Give affected stakeholders and civil society standing to enforce Section 166(2) duties.</a:t>
+            </a:pPr>
+            <a:r>
+              <a:rPr sz="1100" b="1">
+                <a:latin typeface="Avenir Next"/>
+              </a:rPr>
+              <a:t>• Direct Statutory Standing: </a:t>
+            </a:r>
+            <a:r>
+              <a:rPr sz="1100" b="0">
+                <a:latin typeface="Avenir Next"/>
+              </a:rPr>
+              <a:t>Insert Sec 166(8) empowering affected persons, creditors, and consumer NGOs before NCLT without Sec 244 shareholding caps.</a:t>
             </a:r>
           </a:p>
           <a:p>
             <a:pPr>
-              <a:defRPr sz="1150">
-                <a:solidFill>
-                  <a:srgbClr val="2D2D2D"/>
-                </a:solidFill>
-              </a:defRPr>
-            </a:pPr>
-            <a:r>
-              <a:rPr sz="1400" dirty="0">
-                <a:latin typeface="Avenir Next" panose="020B0503020202020204" pitchFamily="34" charset="0"/>
-              </a:rPr>
-              <a:t>• Boardroom Oversight: Require dedicated Board ESG Committees and environmental whistleblower protections.</a:t>
+              <a:lnSpc>
+                <a:spcPct val="105000"/>
+              </a:lnSpc>
+              <a:spcAft>
+                <a:spcPts val="600"/>
+              </a:spcAft>
+            </a:pPr>
+            <a:r>
+              <a:rPr sz="1100" b="1">
+                <a:latin typeface="Avenir Next"/>
+              </a:rPr>
+              <a:t>• Mandatory ESG Committee: </a:t>
+            </a:r>
+            <a:r>
+              <a:rPr sz="1100" b="0">
+                <a:latin typeface="Avenir Next"/>
+              </a:rPr>
+              <a:t>Insert Sec 135A requiring Board ESG Committee (with carbon/ESG expert) for ex-ante claim pre-approval.</a:t>
+            </a:r>
+          </a:p>
+          <a:p>
+            <a:pPr>
+              <a:lnSpc>
+                <a:spcPct val="105000"/>
+              </a:lnSpc>
+              <a:spcAft>
+                <a:spcPts val="600"/>
+              </a:spcAft>
+            </a:pPr>
+            <a:r>
+              <a:rPr sz="1100" b="1">
+                <a:latin typeface="Avenir Next"/>
+              </a:rPr>
+              <a:t>• Whistleblower Protection: </a:t>
+            </a:r>
+            <a:r>
+              <a:rPr sz="1100" b="0">
+                <a:latin typeface="Avenir Next"/>
+              </a:rPr>
+              <a:t>Amend Sec 177(9) vigil mechanism to explicitly cover environmental misrepresentations under Sec 166(2).</a:t>
             </a:r>
           </a:p>
         </p:txBody>
@@ -20287,8 +20299,8 @@
         </p:nvSpPr>
         <p:spPr>
           <a:xfrm>
-            <a:off x="4389385" y="2142135"/>
-            <a:ext cx="3255264" cy="2667397"/>
+            <a:off x="4389385" y="2035028"/>
+            <a:ext cx="3255264" cy="2934136"/>
           </a:xfrm>
           <a:prstGeom prst="rect">
             <a:avLst/>
@@ -20302,8 +20314,11 @@
           <a:lstStyle/>
           <a:p>
             <a:pPr algn="l">
+              <a:lnSpc>
+                <a:spcPct val="105000"/>
+              </a:lnSpc>
               <a:spcAft>
-                <a:spcPts val="800"/>
+                <a:spcPts val="600"/>
               </a:spcAft>
               <a:defRPr sz="1150" b="0">
                 <a:solidFill>
@@ -20313,43 +20328,82 @@
               </a:defRPr>
             </a:pPr>
             <a:r>
-              <a:rPr sz="1400">
-                <a:latin typeface="Avenir Next" panose="020B0503020202020204" pitchFamily="34" charset="0"/>
-              </a:rPr>
-              <a:t>• Mandatory Reasonable Audits: Return to the time-bound path for full financial-grade ESG audits.</a:t>
+              <a:rPr sz="1100" b="1">
+                <a:latin typeface="Avenir Next"/>
+              </a:rPr>
+              <a:t>• Repeal Backsliding / Restore Rigour: </a:t>
+            </a:r>
+            <a:r>
+              <a:rPr sz="1100" b="0">
+                <a:latin typeface="Avenir Next"/>
+              </a:rPr>
+              <a:t>Amend BRSR to mandate Reasonable Assurance (ISAE 3000) &amp; full Scope 3 Value Chain (repealing 75% cap &amp; 2% threshold).</a:t>
             </a:r>
           </a:p>
           <a:p>
             <a:pPr>
+              <a:lnSpc>
+                <a:spcPct val="105000"/>
+              </a:lnSpc>
               <a:spcAft>
-                <a:spcPts val="800"/>
+                <a:spcPts val="600"/>
               </a:spcAft>
-              <a:defRPr sz="1150">
-                <a:solidFill>
-                  <a:srgbClr val="2D2D2D"/>
-                </a:solidFill>
-              </a:defRPr>
-            </a:pPr>
-            <a:r>
-              <a:rPr sz="1400">
-                <a:latin typeface="Avenir Next" panose="020B0503020202020204" pitchFamily="34" charset="0"/>
-              </a:rPr>
-              <a:t>• Full Scope 3 Value Chain: Restore comprehensive supply-chain emissions reporting without loopholes.</a:t>
+            </a:pPr>
+            <a:r>
+              <a:rPr sz="1100" b="1">
+                <a:latin typeface="Avenir Next"/>
+              </a:rPr>
+              <a:t>• PFUTP Fraud &amp; Referral Bridge: </a:t>
+            </a:r>
+            <a:r>
+              <a:rPr sz="1100" b="0">
+                <a:latin typeface="Avenir Next"/>
+              </a:rPr>
+              <a:t>Classify material ESG misstatements as fraud under PFUTP (Sec 15HA: ₹25 Cr / 3x profit) + mandatory referral to MCA.</a:t>
             </a:r>
           </a:p>
           <a:p>
             <a:pPr>
-              <a:defRPr sz="1150">
-                <a:solidFill>
-                  <a:srgbClr val="2D2D2D"/>
-                </a:solidFill>
-              </a:defRPr>
-            </a:pPr>
-            <a:r>
-              <a:rPr sz="1400">
-                <a:latin typeface="Avenir Next" panose="020B0503020202020204" pitchFamily="34" charset="0"/>
-              </a:rPr>
-              <a:t>• Fraud Classification: Explicitly classify material ESG misstatements as fraudulent under PFUTP regulations.</a:t>
+              <a:lnSpc>
+                <a:spcPct val="105000"/>
+              </a:lnSpc>
+              <a:spcAft>
+                <a:spcPts val="600"/>
+              </a:spcAft>
+            </a:pPr>
+            <a:r>
+              <a:rPr sz="1100" b="1">
+                <a:latin typeface="Avenir Next"/>
+              </a:rPr>
+              <a:t>• Double Materiality &amp; Sector Maps: </a:t>
+            </a:r>
+            <a:r>
+              <a:rPr sz="1100" b="0">
+                <a:latin typeface="Avenir Next"/>
+              </a:rPr>
+              <a:t>Mandate Impact Materiality alongside Financial Materiality, with sector-specific maps for high-impact sectors (Energy, Cement, FMCG).</a:t>
+            </a:r>
+          </a:p>
+          <a:p>
+            <a:pPr>
+              <a:lnSpc>
+                <a:spcPct val="105000"/>
+              </a:lnSpc>
+              <a:spcAft>
+                <a:spcPts val="600"/>
+              </a:spcAft>
+            </a:pPr>
+            <a:r>
+              <a:rPr sz="1100" b="1">
+                <a:latin typeface="Avenir Next"/>
+              </a:rPr>
+              <a:t>• ESG Rating Providers (ERPs): </a:t>
+            </a:r>
+            <a:r>
+              <a:rPr sz="1100" b="0">
+                <a:latin typeface="Avenir Next"/>
+              </a:rPr>
+              <a:t>Introduce monetary penalties under Sec 15HB and minimum competence standards for ESG analysts.</a:t>
             </a:r>
           </a:p>
         </p:txBody>
@@ -20495,8 +20549,8 @@
         </p:nvSpPr>
         <p:spPr>
           <a:xfrm>
-            <a:off x="7937257" y="2114703"/>
-            <a:ext cx="3255264" cy="2882840"/>
+            <a:off x="7937257" y="2008967"/>
+            <a:ext cx="3255264" cy="3171124"/>
           </a:xfrm>
           <a:prstGeom prst="rect">
             <a:avLst/>
@@ -20510,8 +20564,11 @@
           <a:lstStyle/>
           <a:p>
             <a:pPr algn="l">
+              <a:lnSpc>
+                <a:spcPct val="105000"/>
+              </a:lnSpc>
               <a:spcAft>
-                <a:spcPts val="800"/>
+                <a:spcPts val="600"/>
               </a:spcAft>
               <a:defRPr sz="1150" b="0">
                 <a:solidFill>
@@ -20521,43 +20578,82 @@
               </a:defRPr>
             </a:pPr>
             <a:r>
-              <a:rPr sz="1400">
-                <a:latin typeface="Avenir Next" panose="020B0503020202020204" pitchFamily="34" charset="0"/>
-              </a:rPr>
-              <a:t>• Binding Regulations: Elevate the 2024 Guidelines into formal binding rules under the Consumer Protection Act.</a:t>
+              <a:rPr sz="1100" b="1">
+                <a:latin typeface="Avenir Next"/>
+              </a:rPr>
+              <a:t>• Binding Sec 101 Rules: </a:t>
+            </a:r>
+            <a:r>
+              <a:rPr sz="1100" b="0">
+                <a:latin typeface="Avenir Next"/>
+              </a:rPr>
+              <a:t>Elevate 2024 Guidelines into formal delegated legislation with parliamentary oversight and statutory penalty schedules.</a:t>
             </a:r>
           </a:p>
           <a:p>
             <a:pPr>
+              <a:lnSpc>
+                <a:spcPct val="105000"/>
+              </a:lnSpc>
               <a:spcAft>
-                <a:spcPts val="800"/>
+                <a:spcPts val="600"/>
               </a:spcAft>
-              <a:defRPr sz="1150">
-                <a:solidFill>
-                  <a:srgbClr val="2D2D2D"/>
-                </a:solidFill>
-              </a:defRPr>
-            </a:pPr>
-            <a:r>
-              <a:rPr sz="1400">
-                <a:latin typeface="Avenir Next" panose="020B0503020202020204" pitchFamily="34" charset="0"/>
-              </a:rPr>
-              <a:t>• Corrective Advertising: Require public correction notices and turnover-based fines for major deceptive claims.</a:t>
+            </a:pPr>
+            <a:r>
+              <a:rPr sz="1100" b="1">
+                <a:latin typeface="Avenir Next"/>
+              </a:rPr>
+              <a:t>• Turnover Fines &amp; Corrective Ads: </a:t>
+            </a:r>
+            <a:r>
+              <a:rPr sz="1100" b="0">
+                <a:latin typeface="Avenir Next"/>
+              </a:rPr>
+              <a:t>Amend Sec 21 to impose 1% to 4% turnover penalties + Mandatory Corrective Advertising of equal prominence and duration.</a:t>
             </a:r>
           </a:p>
           <a:p>
             <a:pPr>
-              <a:defRPr sz="1150">
-                <a:solidFill>
-                  <a:srgbClr val="2D2D2D"/>
-                </a:solidFill>
-              </a:defRPr>
-            </a:pPr>
-            <a:r>
-              <a:rPr sz="1400">
-                <a:latin typeface="Avenir Next" panose="020B0503020202020204" pitchFamily="34" charset="0"/>
-              </a:rPr>
-              <a:t>• Narrow Puffery Exception: Disallow vague green buzzwords ('eco-friendly', 'sustainable') as mere puffery.</a:t>
+              <a:lnSpc>
+                <a:spcPct val="105000"/>
+              </a:lnSpc>
+              <a:spcAft>
+                <a:spcPts val="600"/>
+              </a:spcAft>
+            </a:pPr>
+            <a:r>
+              <a:rPr sz="1100" b="1">
+                <a:latin typeface="Avenir Next"/>
+              </a:rPr>
+              <a:t>• Narrow Puffery (Guideline 3(h)): </a:t>
+            </a:r>
+            <a:r>
+              <a:rPr sz="1100" b="0">
+                <a:latin typeface="Avenir Next"/>
+              </a:rPr>
+              <a:t>Measurable claims require published transition plans and budgets; green imagery carries rebuttable presumption of claim.</a:t>
+            </a:r>
+          </a:p>
+          <a:p>
+            <a:pPr>
+              <a:lnSpc>
+                <a:spcPct val="105000"/>
+              </a:lnSpc>
+              <a:spcAft>
+                <a:spcPts val="600"/>
+              </a:spcAft>
+            </a:pPr>
+            <a:r>
+              <a:rPr sz="1100" b="1">
+                <a:latin typeface="Avenir Next"/>
+              </a:rPr>
+              <a:t>• Claim-Specific Schedules: </a:t>
+            </a:r>
+            <a:r>
+              <a:rPr sz="1100" b="0">
+                <a:latin typeface="Avenir Next"/>
+              </a:rPr>
+              <a:t>Prescribe statutory testing benchmarks (ISO 14855 for biodegradable; offset caps for net-zero) + CCPA whistleblower channel.</a:t>
             </a:r>
           </a:p>
         </p:txBody>

</xml_diff>

<commit_message>
feat: add presentation narration and update final thesis defense slides
</commit_message>
<xml_diff>
--- a/Thesis Defence Presentation Final.pptx
+++ b/Thesis Defence Presentation Final.pptx
@@ -236,7 +236,7 @@
           <a:p>
             <a:fld id="{5D16D8C7-7ACE-0E43-ADC6-5E8A68AC397B}" type="datetimeFigureOut">
               <a:rPr lang="en-US" smtClean="0"/>
-              <a:t>8/20/26</a:t>
+              <a:t>8/21/26</a:t>
             </a:fld>
             <a:endParaRPr lang="en-US"/>
           </a:p>
@@ -1019,7 +1019,7 @@
           <a:p>
             <a:fld id="{5BCAD085-E8A6-8845-BD4E-CB4CCA059FC4}" type="datetimeFigureOut">
               <a:rPr lang="en-US" smtClean="0"/>
-              <a:t>8/20/26</a:t>
+              <a:t>8/21/26</a:t>
             </a:fld>
             <a:endParaRPr lang="en-US"/>
           </a:p>
@@ -1187,7 +1187,7 @@
           <a:p>
             <a:fld id="{5BCAD085-E8A6-8845-BD4E-CB4CCA059FC4}" type="datetimeFigureOut">
               <a:rPr lang="en-US" smtClean="0"/>
-              <a:t>8/20/26</a:t>
+              <a:t>8/21/26</a:t>
             </a:fld>
             <a:endParaRPr lang="en-US"/>
           </a:p>
@@ -1365,7 +1365,7 @@
           <a:p>
             <a:fld id="{5BCAD085-E8A6-8845-BD4E-CB4CCA059FC4}" type="datetimeFigureOut">
               <a:rPr lang="en-US" smtClean="0"/>
-              <a:t>8/20/26</a:t>
+              <a:t>8/21/26</a:t>
             </a:fld>
             <a:endParaRPr lang="en-US"/>
           </a:p>
@@ -1533,7 +1533,7 @@
           <a:p>
             <a:fld id="{5BCAD085-E8A6-8845-BD4E-CB4CCA059FC4}" type="datetimeFigureOut">
               <a:rPr lang="en-US" smtClean="0"/>
-              <a:t>8/20/26</a:t>
+              <a:t>8/21/26</a:t>
             </a:fld>
             <a:endParaRPr lang="en-US"/>
           </a:p>
@@ -1778,7 +1778,7 @@
           <a:p>
             <a:fld id="{5BCAD085-E8A6-8845-BD4E-CB4CCA059FC4}" type="datetimeFigureOut">
               <a:rPr lang="en-US" smtClean="0"/>
-              <a:t>8/20/26</a:t>
+              <a:t>8/21/26</a:t>
             </a:fld>
             <a:endParaRPr lang="en-US"/>
           </a:p>
@@ -2063,7 +2063,7 @@
           <a:p>
             <a:fld id="{5BCAD085-E8A6-8845-BD4E-CB4CCA059FC4}" type="datetimeFigureOut">
               <a:rPr lang="en-US" smtClean="0"/>
-              <a:t>8/20/26</a:t>
+              <a:t>8/21/26</a:t>
             </a:fld>
             <a:endParaRPr lang="en-US"/>
           </a:p>
@@ -2482,7 +2482,7 @@
           <a:p>
             <a:fld id="{5BCAD085-E8A6-8845-BD4E-CB4CCA059FC4}" type="datetimeFigureOut">
               <a:rPr lang="en-US" smtClean="0"/>
-              <a:t>8/20/26</a:t>
+              <a:t>8/21/26</a:t>
             </a:fld>
             <a:endParaRPr lang="en-US"/>
           </a:p>
@@ -2599,7 +2599,7 @@
           <a:p>
             <a:fld id="{5BCAD085-E8A6-8845-BD4E-CB4CCA059FC4}" type="datetimeFigureOut">
               <a:rPr lang="en-US" smtClean="0"/>
-              <a:t>8/20/26</a:t>
+              <a:t>8/21/26</a:t>
             </a:fld>
             <a:endParaRPr lang="en-US"/>
           </a:p>
@@ -2694,7 +2694,7 @@
           <a:p>
             <a:fld id="{5BCAD085-E8A6-8845-BD4E-CB4CCA059FC4}" type="datetimeFigureOut">
               <a:rPr lang="en-US" smtClean="0"/>
-              <a:t>8/20/26</a:t>
+              <a:t>8/21/26</a:t>
             </a:fld>
             <a:endParaRPr lang="en-US"/>
           </a:p>
@@ -2969,7 +2969,7 @@
           <a:p>
             <a:fld id="{5BCAD085-E8A6-8845-BD4E-CB4CCA059FC4}" type="datetimeFigureOut">
               <a:rPr lang="en-US" smtClean="0"/>
-              <a:t>8/20/26</a:t>
+              <a:t>8/21/26</a:t>
             </a:fld>
             <a:endParaRPr lang="en-US"/>
           </a:p>
@@ -3221,7 +3221,7 @@
           <a:p>
             <a:fld id="{5BCAD085-E8A6-8845-BD4E-CB4CCA059FC4}" type="datetimeFigureOut">
               <a:rPr lang="en-US" smtClean="0"/>
-              <a:t>8/20/26</a:t>
+              <a:t>8/21/26</a:t>
             </a:fld>
             <a:endParaRPr lang="en-US"/>
           </a:p>
@@ -3432,7 +3432,7 @@
           <a:p>
             <a:fld id="{5BCAD085-E8A6-8845-BD4E-CB4CCA059FC4}" type="datetimeFigureOut">
               <a:rPr lang="en-US" smtClean="0"/>
-              <a:t>8/20/26</a:t>
+              <a:t>8/21/26</a:t>
             </a:fld>
             <a:endParaRPr lang="en-US"/>
           </a:p>
@@ -6231,8 +6231,8 @@
         </p:nvSpPr>
         <p:spPr>
           <a:xfrm>
-            <a:off x="152400" y="384048"/>
-            <a:ext cx="11644435" cy="584775"/>
+            <a:off x="566928" y="393978"/>
+            <a:ext cx="10082335" cy="584775"/>
           </a:xfrm>
           <a:prstGeom prst="rect">
             <a:avLst/>
@@ -6255,7 +6255,7 @@
             </a:pPr>
             <a:r>
               <a:rPr lang="en-US" sz="3200" dirty="0"/>
-              <a:t>Limitations of Consumer Law In Tackling Greenwashing</a:t>
+              <a:t>Main Limitations of CCPA Greenwashing Guidelines</a:t>
             </a:r>
           </a:p>
         </p:txBody>
@@ -6320,7 +6320,7 @@
         <p:spPr>
           <a:xfrm>
             <a:off x="7740502" y="2105439"/>
-            <a:ext cx="3934413" cy="2164695"/>
+            <a:ext cx="3934413" cy="1918474"/>
           </a:xfrm>
           <a:prstGeom prst="rect">
             <a:avLst/>
@@ -6414,7 +6414,19 @@
               <a:rPr sz="1600" dirty="0">
                 <a:latin typeface="Avenir Next" panose="020B0503020202020204" pitchFamily="34" charset="0"/>
               </a:rPr>
-              <a:t>• Uses Section 166(2) and audit committees to hold leadership personally responsible for truth in sustainability.</a:t>
+              <a:t>• Uses Section 166(2) and audit committees to hold leadership</a:t>
+            </a:r>
+            <a:r>
+              <a:rPr lang="en-US" sz="1600" dirty="0">
+                <a:latin typeface="Avenir Next" panose="020B0503020202020204" pitchFamily="34" charset="0"/>
+              </a:rPr>
+              <a:t> </a:t>
+            </a:r>
+            <a:r>
+              <a:rPr sz="1600" dirty="0">
+                <a:latin typeface="Avenir Next" panose="020B0503020202020204" pitchFamily="34" charset="0"/>
+              </a:rPr>
+              <a:t>responsible for truth in sustainability.</a:t>
             </a:r>
           </a:p>
         </p:txBody>
@@ -6483,8 +6495,8 @@
         </p:nvSpPr>
         <p:spPr>
           <a:xfrm>
-            <a:off x="646996" y="1054085"/>
-            <a:ext cx="6678424" cy="3876261"/>
+            <a:off x="608896" y="1206485"/>
+            <a:ext cx="6678424" cy="4153527"/>
           </a:xfrm>
           <a:prstGeom prst="roundRect">
             <a:avLst/>
@@ -6631,8 +6643,8 @@
         </p:nvSpPr>
         <p:spPr>
           <a:xfrm>
-            <a:off x="913899" y="1405912"/>
-            <a:ext cx="6089793" cy="3159839"/>
+            <a:off x="903211" y="1348657"/>
+            <a:ext cx="6089793" cy="4011355"/>
           </a:xfrm>
           <a:prstGeom prst="rect">
             <a:avLst/>
@@ -6739,98 +6751,69 @@
             </a:lvl9pPr>
           </a:lstStyle>
           <a:p>
-            <a:pPr>
-              <a:spcAft>
-                <a:spcPts val="600"/>
-              </a:spcAft>
-              <a:defRPr sz="1350" b="1">
-                <a:solidFill>
-                  <a:srgbClr val="12402D"/>
-                </a:solidFill>
-                <a:latin typeface="Calibri"/>
-              </a:defRPr>
-            </a:pPr>
-            <a:r>
-              <a:rPr sz="1600" dirty="0">
-                <a:latin typeface="Avenir Next" panose="020B0503020202020204" pitchFamily="34" charset="0"/>
-              </a:rPr>
-              <a:t>Limitations of Consumer Law (CPA 2019 / CCPA)</a:t>
-            </a:r>
-            <a:endParaRPr lang="en-US" sz="1600" dirty="0">
-              <a:latin typeface="Avenir Next" panose="020B0503020202020204" pitchFamily="34" charset="0"/>
-            </a:endParaRPr>
-          </a:p>
-          <a:p>
-            <a:pPr>
+            <a:pPr marL="342900" indent="-342900">
               <a:spcBef>
                 <a:spcPts val="200"/>
               </a:spcBef>
               <a:spcAft>
                 <a:spcPts val="300"/>
               </a:spcAft>
-            </a:pPr>
-            <a:r>
-              <a:rPr sz="1600" b="1" dirty="0">
+              <a:buAutoNum type="arabicPeriod"/>
+            </a:pPr>
+            <a:r>
+              <a:rPr lang="en-IN" sz="1400" b="1" dirty="0">
                 <a:solidFill>
                   <a:srgbClr val="22704E"/>
                 </a:solidFill>
                 <a:latin typeface="Avenir Next" panose="020B0503020202020204" pitchFamily="34" charset="0"/>
               </a:rPr>
-              <a:t>1. Reactive by Nature: </a:t>
-            </a:r>
-            <a:r>
-              <a:rPr sz="1600" dirty="0">
+              <a:t>Guidelines without Governance Obligations: </a:t>
+            </a:r>
+            <a:r>
+              <a:rPr lang="en-IN" sz="1400" dirty="0">
                 <a:solidFill>
                   <a:srgbClr val="2D2D2D"/>
                 </a:solidFill>
                 <a:latin typeface="Avenir Next" panose="020B0503020202020204" pitchFamily="34" charset="0"/>
               </a:rPr>
-              <a:t>Intervenes only after deceptive claims enter the market.</a:t>
-            </a:r>
-            <a:r>
-              <a:rPr lang="en-US" sz="1600" dirty="0">
-                <a:solidFill>
-                  <a:srgbClr val="2D2D2D"/>
-                </a:solidFill>
-                <a:latin typeface="Avenir Next" panose="020B0503020202020204" pitchFamily="34" charset="0"/>
-              </a:rPr>
-              <a:t> Rather than proactive systemic regulation.</a:t>
-            </a:r>
-            <a:endParaRPr lang="en-IN" sz="1600" dirty="0">
+              <a:t>They prescribe what environmental claims must demonstrate but not what internal governance or processes must exist to ensure such demonstration.</a:t>
+            </a:r>
+            <a:endParaRPr lang="en-IN" sz="1400" b="1" dirty="0">
               <a:solidFill>
-                <a:srgbClr val="2D2D2D"/>
+                <a:srgbClr val="22704E"/>
               </a:solidFill>
               <a:latin typeface="Avenir Next" panose="020B0503020202020204" pitchFamily="34" charset="0"/>
             </a:endParaRPr>
           </a:p>
           <a:p>
-            <a:pPr>
+            <a:pPr marL="342900" indent="-342900">
               <a:spcBef>
                 <a:spcPts val="200"/>
               </a:spcBef>
               <a:spcAft>
                 <a:spcPts val="300"/>
               </a:spcAft>
-            </a:pPr>
-            <a:r>
-              <a:rPr lang="en-IN" sz="1600" b="1" dirty="0">
+              <a:buAutoNum type="arabicPeriod"/>
+            </a:pPr>
+            <a:r>
+              <a:rPr lang="en-IN" sz="1400" b="1" dirty="0">
                 <a:solidFill>
                   <a:srgbClr val="22704E"/>
                 </a:solidFill>
                 <a:latin typeface="Avenir Next" panose="020B0503020202020204" pitchFamily="34" charset="0"/>
               </a:rPr>
-              <a:t>2. No Upstream Boardroom Mandates: </a:t>
-            </a:r>
-            <a:r>
-              <a:rPr lang="en-IN" sz="1600" dirty="0">
+              <a:t>No Board Level Deterrence: </a:t>
+            </a:r>
+            <a:r>
+              <a:rPr lang="en-IN" sz="1400" dirty="0">
                 <a:solidFill>
                   <a:srgbClr val="2D2D2D"/>
                 </a:solidFill>
                 <a:latin typeface="Avenir Next" panose="020B0503020202020204" pitchFamily="34" charset="0"/>
               </a:rPr>
-              <a:t>Regulates ad copy, does not guide internal corporate systems or decision-making.</a:t>
-            </a:r>
-            <a:endParaRPr sz="1600" dirty="0">
+              <a:t>Because its remit is restricted to consumer facing products and ads only; the institutional greenwashing such as corporate PR campaigns, annual sustainability overstatements that do not mention any specific product or service are allowed.</a:t>
+            </a:r>
+            <a:endParaRPr lang="en-US" sz="1400" dirty="0">
               <a:solidFill>
                 <a:srgbClr val="2D2D2D"/>
               </a:solidFill>
@@ -6838,195 +6821,96 @@
             </a:endParaRPr>
           </a:p>
           <a:p>
-            <a:pPr>
+            <a:pPr marL="342900" indent="-342900">
               <a:spcBef>
                 <a:spcPts val="200"/>
               </a:spcBef>
               <a:spcAft>
                 <a:spcPts val="300"/>
               </a:spcAft>
-            </a:pPr>
-            <a:r>
-              <a:rPr lang="en-US" sz="1600" b="1" dirty="0">
+              <a:buFontTx/>
+              <a:buAutoNum type="arabicPeriod"/>
+            </a:pPr>
+            <a:r>
+              <a:rPr lang="en-US" sz="1400" b="1" dirty="0">
                 <a:solidFill>
                   <a:srgbClr val="22704E"/>
                 </a:solidFill>
                 <a:latin typeface="Avenir Next" panose="020B0503020202020204" pitchFamily="34" charset="0"/>
               </a:rPr>
-              <a:t>3</a:t>
-            </a:r>
-            <a:r>
-              <a:rPr sz="1600" b="1" dirty="0">
-                <a:solidFill>
-                  <a:srgbClr val="22704E"/>
-                </a:solidFill>
-                <a:latin typeface="Avenir Next" panose="020B0503020202020204" pitchFamily="34" charset="0"/>
-              </a:rPr>
-              <a:t>. Individual Harm Focus: </a:t>
-            </a:r>
-            <a:r>
-              <a:rPr sz="1600" dirty="0">
+              <a:t>Weak Oversight on Future Claims: </a:t>
+            </a:r>
+            <a:r>
+              <a:rPr lang="en-US" sz="1400" dirty="0">
                 <a:solidFill>
                   <a:srgbClr val="2D2D2D"/>
                 </a:solidFill>
                 <a:latin typeface="Avenir Next" panose="020B0503020202020204" pitchFamily="34" charset="0"/>
               </a:rPr>
-              <a:t>Treats greenwashing </a:t>
-            </a:r>
-            <a:r>
-              <a:rPr lang="en-US" sz="1600" dirty="0">
-                <a:solidFill>
-                  <a:srgbClr val="2D2D2D"/>
-                </a:solidFill>
-                <a:latin typeface="Avenir Next" panose="020B0503020202020204" pitchFamily="34" charset="0"/>
-              </a:rPr>
-              <a:t>merely </a:t>
-            </a:r>
-            <a:r>
-              <a:rPr sz="1600" dirty="0">
-                <a:solidFill>
-                  <a:srgbClr val="2D2D2D"/>
-                </a:solidFill>
-                <a:latin typeface="Avenir Next" panose="020B0503020202020204" pitchFamily="34" charset="0"/>
-              </a:rPr>
-              <a:t>consumer </a:t>
-            </a:r>
-            <a:r>
-              <a:rPr lang="en-US" sz="1600" dirty="0">
-                <a:solidFill>
-                  <a:srgbClr val="2D2D2D"/>
-                </a:solidFill>
-                <a:latin typeface="Avenir Next" panose="020B0503020202020204" pitchFamily="34" charset="0"/>
-              </a:rPr>
-              <a:t>harm</a:t>
-            </a:r>
-            <a:r>
-              <a:rPr sz="1600" dirty="0">
-                <a:solidFill>
-                  <a:srgbClr val="2D2D2D"/>
-                </a:solidFill>
-                <a:latin typeface="Avenir Next" panose="020B0503020202020204" pitchFamily="34" charset="0"/>
-              </a:rPr>
-              <a:t>, not systemic governance failure.</a:t>
-            </a:r>
-            <a:endParaRPr lang="en-US" sz="1600" dirty="0">
-              <a:solidFill>
-                <a:srgbClr val="2D2D2D"/>
-              </a:solidFill>
-              <a:latin typeface="Avenir Next" panose="020B0503020202020204" pitchFamily="34" charset="0"/>
-            </a:endParaRPr>
-          </a:p>
-          <a:p>
-            <a:pPr>
+              <a:t>It permits futuristic claims, without mandatory interim milestone reporting and no independent verification of interim progress or a penalty on non-delivery of these targets. </a:t>
+            </a:r>
+          </a:p>
+          <a:p>
+            <a:pPr marL="342900" indent="-342900">
               <a:spcBef>
                 <a:spcPts val="200"/>
               </a:spcBef>
               <a:spcAft>
                 <a:spcPts val="300"/>
               </a:spcAft>
-            </a:pPr>
-            <a:r>
-              <a:rPr lang="en-US" sz="1600" b="1" dirty="0">
+              <a:buFontTx/>
+              <a:buAutoNum type="arabicPeriod"/>
+            </a:pPr>
+            <a:r>
+              <a:rPr lang="en-US" sz="1400" b="1" dirty="0">
                 <a:solidFill>
                   <a:srgbClr val="22704E"/>
                 </a:solidFill>
                 <a:latin typeface="Avenir Next" panose="020B0503020202020204" pitchFamily="34" charset="0"/>
               </a:rPr>
-              <a:t>4. </a:t>
-            </a:r>
-            <a:r>
-              <a:rPr sz="1600" b="1" dirty="0">
-                <a:solidFill>
-                  <a:srgbClr val="22704E"/>
-                </a:solidFill>
-                <a:latin typeface="Avenir Next" panose="020B0503020202020204" pitchFamily="34" charset="0"/>
-              </a:rPr>
-              <a:t>Puffery Loophole: </a:t>
-            </a:r>
-            <a:r>
-              <a:rPr lang="en-US" sz="1600" dirty="0">
+              <a:t>Visual Imagery &amp; Puffery Loophole: </a:t>
+            </a:r>
+            <a:r>
+              <a:rPr lang="en-US" sz="1400" dirty="0">
                 <a:solidFill>
                   <a:srgbClr val="2D2D2D"/>
                 </a:solidFill>
                 <a:latin typeface="Avenir Next" panose="020B0503020202020204" pitchFamily="34" charset="0"/>
               </a:rPr>
-              <a:t>Scope for </a:t>
-            </a:r>
-            <a:r>
-              <a:rPr sz="1600" dirty="0">
-                <a:solidFill>
-                  <a:srgbClr val="2D2D2D"/>
-                </a:solidFill>
-                <a:latin typeface="Avenir Next" panose="020B0503020202020204" pitchFamily="34" charset="0"/>
-              </a:rPr>
-              <a:t>exaggerations </a:t>
-            </a:r>
-            <a:r>
-              <a:rPr lang="en-US" sz="1600" dirty="0">
-                <a:solidFill>
-                  <a:srgbClr val="2D2D2D"/>
-                </a:solidFill>
-                <a:latin typeface="Avenir Next" panose="020B0503020202020204" pitchFamily="34" charset="0"/>
-              </a:rPr>
-              <a:t>creates </a:t>
-            </a:r>
-            <a:r>
-              <a:rPr sz="1600" dirty="0">
-                <a:solidFill>
-                  <a:srgbClr val="2D2D2D"/>
-                </a:solidFill>
-                <a:latin typeface="Avenir Next" panose="020B0503020202020204" pitchFamily="34" charset="0"/>
-              </a:rPr>
-              <a:t>loopholes for vague green buzzwords.</a:t>
-            </a:r>
-          </a:p>
-          <a:p>
-            <a:pPr>
+              <a:t>It exempts generic nature visuals and exaggerated talk in advertisements, which leaves scope for greenwashing. </a:t>
+            </a:r>
+          </a:p>
+          <a:p>
+            <a:pPr marL="342900" indent="-342900">
               <a:spcBef>
                 <a:spcPts val="200"/>
               </a:spcBef>
               <a:spcAft>
                 <a:spcPts val="300"/>
               </a:spcAft>
-            </a:pPr>
-            <a:r>
-              <a:rPr lang="en-US" sz="1600" b="1" dirty="0">
+              <a:buFontTx/>
+              <a:buAutoNum type="arabicPeriod"/>
+            </a:pPr>
+            <a:r>
+              <a:rPr lang="en-US" sz="1400" b="1" dirty="0">
                 <a:solidFill>
                   <a:srgbClr val="22704E"/>
                 </a:solidFill>
                 <a:latin typeface="Avenir Next" panose="020B0503020202020204" pitchFamily="34" charset="0"/>
               </a:rPr>
-              <a:t>5</a:t>
-            </a:r>
-            <a:r>
-              <a:rPr sz="1600" b="1" dirty="0">
+              <a:t>Fixed cap penalties</a:t>
+            </a:r>
+            <a:r>
+              <a:rPr sz="1400" b="1" dirty="0">
                 <a:solidFill>
                   <a:srgbClr val="22704E"/>
                 </a:solidFill>
                 <a:latin typeface="Avenir Next" panose="020B0503020202020204" pitchFamily="34" charset="0"/>
               </a:rPr>
-              <a:t>. </a:t>
-            </a:r>
-            <a:r>
-              <a:rPr lang="en-US" sz="1600" b="1" dirty="0">
-                <a:solidFill>
-                  <a:srgbClr val="22704E"/>
-                </a:solidFill>
-                <a:latin typeface="Avenir Next" panose="020B0503020202020204" pitchFamily="34" charset="0"/>
-              </a:rPr>
-              <a:t>Fixed cap penalties</a:t>
-            </a:r>
-            <a:r>
-              <a:rPr sz="1600" b="1" dirty="0">
-                <a:solidFill>
-                  <a:srgbClr val="22704E"/>
-                </a:solidFill>
-                <a:latin typeface="Avenir Next" panose="020B0503020202020204" pitchFamily="34" charset="0"/>
-              </a:rPr>
               <a:t>: </a:t>
             </a:r>
             <a:r>
-              <a:rPr lang="en-IN" sz="1600" dirty="0">
+              <a:rPr lang="en-IN" sz="1400" dirty="0">
                 <a:solidFill>
                   <a:srgbClr val="2D2D2D"/>
                 </a:solidFill>
@@ -7035,7 +6919,7 @@
               <a:t>Not turnover linked</a:t>
             </a:r>
             <a:r>
-              <a:rPr sz="1600" dirty="0">
+              <a:rPr sz="1400" dirty="0">
                 <a:solidFill>
                   <a:srgbClr val="2D2D2D"/>
                 </a:solidFill>
@@ -7044,7 +6928,7 @@
               <a:t>.</a:t>
             </a:r>
             <a:r>
-              <a:rPr lang="en-US" sz="1600" dirty="0">
+              <a:rPr lang="en-US" sz="1400" dirty="0">
                 <a:solidFill>
                   <a:srgbClr val="2D2D2D"/>
                 </a:solidFill>
@@ -7052,7 +6936,7 @@
               </a:rPr>
               <a:t> Limited deterrence for big companies.</a:t>
             </a:r>
-            <a:endParaRPr lang="en-US" sz="1600" dirty="0">
+            <a:endParaRPr lang="en-US" sz="1400" dirty="0">
               <a:latin typeface="Avenir Next" panose="020B0503020202020204" pitchFamily="34" charset="0"/>
               <a:ea typeface="Calibri"/>
               <a:cs typeface="Calibri"/>

</xml_diff>